<commit_message>
Clarify real data interpretation slides
</commit_message>
<xml_diff>
--- a/reports/SpatialScope_Agent_Presentation.pptx
+++ b/reports/SpatialScope_Agent_Presentation.pptx
@@ -2,28 +2,29 @@
 <file path=ppt/presentation.xml><?xml version="1.0" encoding="utf-8"?>
 <p:presentation xmlns:p="http://schemas.openxmlformats.org/presentationml/2006/main">
   <p:sldMasterIdLst>
-    <p:sldMasterId xmlns:r="http://schemas.openxmlformats.org/officeDocument/2006/relationships" id="2147483648" r:id="R63222e2112b74bfb"/>
+    <p:sldMasterId xmlns:r="http://schemas.openxmlformats.org/officeDocument/2006/relationships" id="2147483648" r:id="Re4ad2b4681694137"/>
   </p:sldMasterIdLst>
   <p:notesMasterIdLst>
-    <p:notesMasterId xmlns:r="http://schemas.openxmlformats.org/officeDocument/2006/relationships" r:id="Rd336bb2088ba4dd3"/>
+    <p:notesMasterId xmlns:r="http://schemas.openxmlformats.org/officeDocument/2006/relationships" r:id="Rbc2448d429a34edc"/>
   </p:notesMasterIdLst>
   <p:sldIdLst>
-    <p:sldId xmlns:r="http://schemas.openxmlformats.org/officeDocument/2006/relationships" id="256" r:id="Rc18003aced6a4353"/>
-    <p:sldId xmlns:r="http://schemas.openxmlformats.org/officeDocument/2006/relationships" id="257" r:id="R70515fec168b4d6f"/>
-    <p:sldId xmlns:r="http://schemas.openxmlformats.org/officeDocument/2006/relationships" id="258" r:id="R2452753c51db4627"/>
-    <p:sldId xmlns:r="http://schemas.openxmlformats.org/officeDocument/2006/relationships" id="259" r:id="R41848a6e34524ea8"/>
-    <p:sldId xmlns:r="http://schemas.openxmlformats.org/officeDocument/2006/relationships" id="260" r:id="Rc15f87b6964140f5"/>
-    <p:sldId xmlns:r="http://schemas.openxmlformats.org/officeDocument/2006/relationships" id="261" r:id="R4ba7278e32fe4c96"/>
-    <p:sldId xmlns:r="http://schemas.openxmlformats.org/officeDocument/2006/relationships" id="262" r:id="Rb4a90d3278774566"/>
-    <p:sldId xmlns:r="http://schemas.openxmlformats.org/officeDocument/2006/relationships" id="263" r:id="Re8e4259c907e4442"/>
-    <p:sldId xmlns:r="http://schemas.openxmlformats.org/officeDocument/2006/relationships" id="264" r:id="R2ff34cf7e1e84200"/>
-    <p:sldId xmlns:r="http://schemas.openxmlformats.org/officeDocument/2006/relationships" id="265" r:id="R4923cf01a7f84fde"/>
-    <p:sldId xmlns:r="http://schemas.openxmlformats.org/officeDocument/2006/relationships" id="266" r:id="Rdfd226aa0b064e2f"/>
-    <p:sldId xmlns:r="http://schemas.openxmlformats.org/officeDocument/2006/relationships" id="267" r:id="R76724a97fc984c63"/>
-    <p:sldId xmlns:r="http://schemas.openxmlformats.org/officeDocument/2006/relationships" id="268" r:id="R038b97cc1aaa4aa3"/>
-    <p:sldId xmlns:r="http://schemas.openxmlformats.org/officeDocument/2006/relationships" id="269" r:id="Ra1a4e1edd84a44d7"/>
-    <p:sldId xmlns:r="http://schemas.openxmlformats.org/officeDocument/2006/relationships" id="270" r:id="R96452d73796246c6"/>
-    <p:sldId xmlns:r="http://schemas.openxmlformats.org/officeDocument/2006/relationships" id="271" r:id="Rde9d113dbcf24f00"/>
+    <p:sldId xmlns:r="http://schemas.openxmlformats.org/officeDocument/2006/relationships" id="256" r:id="Rcdeca84b5720436d"/>
+    <p:sldId xmlns:r="http://schemas.openxmlformats.org/officeDocument/2006/relationships" id="257" r:id="R28c1b823b007410d"/>
+    <p:sldId xmlns:r="http://schemas.openxmlformats.org/officeDocument/2006/relationships" id="258" r:id="R812b6ac2edb44cb4"/>
+    <p:sldId xmlns:r="http://schemas.openxmlformats.org/officeDocument/2006/relationships" id="259" r:id="Re0e8d660b57b4ac3"/>
+    <p:sldId xmlns:r="http://schemas.openxmlformats.org/officeDocument/2006/relationships" id="260" r:id="Re56bd8a5b0c04105"/>
+    <p:sldId xmlns:r="http://schemas.openxmlformats.org/officeDocument/2006/relationships" id="261" r:id="R52946f1bdcc64747"/>
+    <p:sldId xmlns:r="http://schemas.openxmlformats.org/officeDocument/2006/relationships" id="262" r:id="Rca3c435ebe814530"/>
+    <p:sldId xmlns:r="http://schemas.openxmlformats.org/officeDocument/2006/relationships" id="263" r:id="R02f18b55c16342db"/>
+    <p:sldId xmlns:r="http://schemas.openxmlformats.org/officeDocument/2006/relationships" id="264" r:id="Raef0f1cc6cc54ce1"/>
+    <p:sldId xmlns:r="http://schemas.openxmlformats.org/officeDocument/2006/relationships" id="265" r:id="R94355af0c66c4a47"/>
+    <p:sldId xmlns:r="http://schemas.openxmlformats.org/officeDocument/2006/relationships" id="266" r:id="Rb5b0eaec034b4fa3"/>
+    <p:sldId xmlns:r="http://schemas.openxmlformats.org/officeDocument/2006/relationships" id="267" r:id="R2177448b66354878"/>
+    <p:sldId xmlns:r="http://schemas.openxmlformats.org/officeDocument/2006/relationships" id="268" r:id="Refcd5c90cd074c41"/>
+    <p:sldId xmlns:r="http://schemas.openxmlformats.org/officeDocument/2006/relationships" id="269" r:id="R060d170c2ae44e37"/>
+    <p:sldId xmlns:r="http://schemas.openxmlformats.org/officeDocument/2006/relationships" id="270" r:id="R7e13d774c5ae4f44"/>
+    <p:sldId xmlns:r="http://schemas.openxmlformats.org/officeDocument/2006/relationships" id="271" r:id="R48a4849e96064510"/>
+    <p:sldId xmlns:r="http://schemas.openxmlformats.org/officeDocument/2006/relationships" id="272" r:id="R88763f969bb746da"/>
   </p:sldIdLst>
   <p:sldSz cx="12192000" cy="6858000"/>
   <p:notesSz cx="6858000" cy="9144000"/>
@@ -982,17 +983,47 @@
           <a:lstStyle xmlns:a="http://schemas.openxmlformats.org/drawingml/2006/main"/>
           <a:p xmlns:a="http://schemas.openxmlformats.org/drawingml/2006/main">
             <a:r>
-              <a:t>讲稿：刚才演示的是一个稳定的小型胚胎 demo。为了说明系统不只是 toy example，我也用公开真实数据 GSE278603 E7.5 mouse embryo 做了验证。这个样本包含 8190 spots 和 16364 genes，源文件中的 X_spatial 被标准化为 spatial，quick run 得到 7 个 Leiden clusters，0 warnings，0 errors。</a:t>
+              <a:t>讲稿：这一页说明真实数据验证。前面网站演示用的是小型 demo，因为在线部署要稳定；但我没有只停留在 toy data。我下载了公开数据 GSE278603 中 E7.5 mouse embryo Stereo-seq 的一个样本。这个样本有 8190 个 spots 和 16364 个 genes，数据规模和字段复杂度都比 demo 更接近真实科研数据。</a:t>
             </a:r>
           </a:p>
           <a:p xmlns:a="http://schemas.openxmlformats.org/drawingml/2006/main">
             <a:r>
-              <a:t>操作：此页回到 PPT，不再操作网站。指左侧数据卡，再看右侧真实 spatial Leiden、UMAP Leiden 和 gene panel。</a:t>
+              <a:t/>
             </a:r>
           </a:p>
           <a:p xmlns:a="http://schemas.openxmlformats.org/drawingml/2006/main">
             <a:r>
-              <a:t>过渡：真实数据验证说明系统有一定泛化能力。接下来说明它在科研场景中可以如何使用，以及边界在哪里。</a:t>
+              <a:t>讲图顺序：先指左侧数据卡。第一行是数据规模；第二行说明原数据里空间坐标叫 obsm["X_spatial"]，Agent 会把它标准化成常用的 obsm["spatial"]；第三行说明 quick run 仍然包含 QC、UMAP、Leiden 聚类和 gene panel；最后一行说明这次运行得到 7 个 clusters，并且没有 warnings 和 errors。</a:t>
+            </a:r>
+          </a:p>
+          <a:p xmlns:a="http://schemas.openxmlformats.org/drawingml/2006/main">
+            <a:r>
+              <a:t/>
+            </a:r>
+          </a:p>
+          <a:p xmlns:a="http://schemas.openxmlformats.org/drawingml/2006/main">
+            <a:r>
+              <a:t>然后指右侧三类图。Spatial Leiden 是把聚类结果放回真实组织坐标；UMAP Leiden 是看表达状态是否能分开；gene panel 是看 Sox17、T、Mesp1、Pou5f1 这些发育相关基因是否有空间表达倾向。</a:t>
+            </a:r>
+          </a:p>
+          <a:p xmlns:a="http://schemas.openxmlformats.org/drawingml/2006/main">
+            <a:r>
+              <a:t/>
+            </a:r>
+          </a:p>
+          <a:p xmlns:a="http://schemas.openxmlformats.org/drawingml/2006/main">
+            <a:r>
+              <a:t>重要边界：这里的目的不是给出完整生物学结论，而是证明系统可以处理真实 AnnData、真实坐标字段和真实表达层。完整生物学解释还需要更系统的 marker、组织学背景和专家注释。</a:t>
+            </a:r>
+          </a:p>
+          <a:p xmlns:a="http://schemas.openxmlformats.org/drawingml/2006/main">
+            <a:r>
+              <a:t/>
+            </a:r>
+          </a:p>
+          <a:p xmlns:a="http://schemas.openxmlformats.org/drawingml/2006/main">
+            <a:r>
+              <a:t>过渡：下一页我解释 Leiden、UMAP 和 Spatial 这几张图具体应该怎么读。</a:t>
             </a:r>
           </a:p>
         </p:txBody>
@@ -1062,17 +1093,57 @@
           <a:lstStyle xmlns:a="http://schemas.openxmlformats.org/drawingml/2006/main"/>
           <a:p xmlns:a="http://schemas.openxmlformats.org/drawingml/2006/main">
             <a:r>
-              <a:t>讲稿：SpatialScope 可以作为 exploratory analysis workspace。发育生物学里可以比较不同胚胎阶段的空间区域；肿瘤微环境里可以探索 tumor、immune、stromal regions；病理切片探索中可以整合组织结构、空间表达和 cluster；教学中可以帮助学生从自然语言问题进入可复现分析。</a:t>
+              <a:t>讲稿：这一页是为了把真实数据图讲清楚。Leiden 是一种图聚类算法，可以简单理解为：先根据基因表达相似性把 spots 连接成邻居图，再把连接更紧密的 spots 分到同一个 cluster。它回答的是“哪些 spot 的整体表达模式相似”。</a:t>
             </a:r>
           </a:p>
           <a:p xmlns:a="http://schemas.openxmlformats.org/drawingml/2006/main">
             <a:r>
-              <a:t>操作：此页留在 PPT。讲四个场景时不要承诺过度，最后一定强调黄色边界：不能替代专家注释，不能把 marker ranking 当作机制证明，大数据需要更强计算后端。</a:t>
+              <a:t/>
             </a:r>
           </a:p>
           <a:p xmlns:a="http://schemas.openxmlformats.org/drawingml/2006/main">
             <a:r>
-              <a:t>过渡：最后总结项目的核心贡献和交付。</a:t>
+              <a:t>这里一定要强调：Leiden cluster 不等于细胞类型。颜色 0 到 6 只是算法给出的分组编号，不是说 cluster 0 就一定是什么细胞。要把 cluster 解释成细胞类型，还需要 marker genes、参考文献和专家判断。</a:t>
+            </a:r>
+          </a:p>
+          <a:p xmlns:a="http://schemas.openxmlformats.org/drawingml/2006/main">
+            <a:r>
+              <a:t/>
+            </a:r>
+          </a:p>
+          <a:p xmlns:a="http://schemas.openxmlformats.org/drawingml/2006/main">
+            <a:r>
+              <a:t>UMAP 图不是组织地图，而是表达状态地图。两个点在 UMAP 上接近，表示它们的整体基因表达相似；离得远，表示表达差异更大。这个真实数据的 UMAP 分成几个比较清楚的区域，说明表达状态确实有结构。</a:t>
+            </a:r>
+          </a:p>
+          <a:p xmlns:a="http://schemas.openxmlformats.org/drawingml/2006/main">
+            <a:r>
+              <a:t/>
+            </a:r>
+          </a:p>
+          <a:p xmlns:a="http://schemas.openxmlformats.org/drawingml/2006/main">
+            <a:r>
+              <a:t>Spatial 图是真实组织坐标。把 Leiden cluster 放回 Spatial 后，会发现颜色没有像 UMAP 那样分成特别干净的大块，而是有不少混合。这不是失败，反而是真实数据常见的情况：组织里不同状态可能交错，空间分辨率、发育阶段和技术噪声都会让结构更复杂。</a:t>
+            </a:r>
+          </a:p>
+          <a:p xmlns:a="http://schemas.openxmlformats.org/drawingml/2006/main">
+            <a:r>
+              <a:t/>
+            </a:r>
+          </a:p>
+          <a:p xmlns:a="http://schemas.openxmlformats.org/drawingml/2006/main">
+            <a:r>
+              <a:t>Gene panel 用来找生物学线索。比如 T 和 Mesp1 是中胚层/早期发育相关基因，如果它们在某些空间区域更高，就可以作为后续解释的线索。但这里仍然要谨慎：单个基因的空间表达不能直接证明机制，只能作为 evidence。</a:t>
+            </a:r>
+          </a:p>
+          <a:p xmlns:a="http://schemas.openxmlformats.org/drawingml/2006/main">
+            <a:r>
+              <a:t/>
+            </a:r>
+          </a:p>
+          <a:p xmlns:a="http://schemas.openxmlformats.org/drawingml/2006/main">
+            <a:r>
+              <a:t>一句话总结：UMAP 看表达状态是否分开，Spatial 看这些状态在组织哪里，Gene panel 用发育基因帮助解释这些区域。</a:t>
             </a:r>
           </a:p>
         </p:txBody>
@@ -1142,12 +1213,112 @@
           <a:lstStyle xmlns:a="http://schemas.openxmlformats.org/drawingml/2006/main"/>
           <a:p xmlns:a="http://schemas.openxmlformats.org/drawingml/2006/main">
             <a:r>
+              <a:t>讲稿：在理解真实数据图之后，再回到真实科研场景。SpatialScope 可以作为 exploratory analysis workspace。发育生物学里可以比较不同胚胎阶段的空间区域，并查看 Sox17、T、Mesp1 等基因；肿瘤微环境里可以探索 tumor、immune、stromal regions；病理切片探索中可以整合组织结构、空间表达和 cluster；教学中可以帮助学生从自然语言问题进入可复现分析。</a:t>
+            </a:r>
+          </a:p>
+          <a:p xmlns:a="http://schemas.openxmlformats.org/drawingml/2006/main">
+            <a:r>
+              <a:t/>
+            </a:r>
+          </a:p>
+          <a:p xmlns:a="http://schemas.openxmlformats.org/drawingml/2006/main">
+            <a:r>
+              <a:t>操作：此页留在 PPT。讲四个场景时不要承诺过度，最后一定强调黄色边界：不能替代专家注释，不能把 marker ranking 当作机制证明，大数据需要更强计算后端。</a:t>
+            </a:r>
+          </a:p>
+          <a:p xmlns:a="http://schemas.openxmlformats.org/drawingml/2006/main">
+            <a:r>
+              <a:t/>
+            </a:r>
+          </a:p>
+          <a:p xmlns:a="http://schemas.openxmlformats.org/drawingml/2006/main">
+            <a:r>
+              <a:t>过渡：最后总结项目的核心贡献和交付。</a:t>
+            </a:r>
+          </a:p>
+        </p:txBody>
+      </p:sp>
+      <p:sp>
+        <p:nvSpPr>
+          <p:cNvPr id="4" name="Slide Number Placeholder 3"/>
+          <p:cNvSpPr>
+            <a:spLocks xmlns:a="http://schemas.openxmlformats.org/drawingml/2006/main" noGrp="1"/>
+          </p:cNvSpPr>
+          <p:nvPr>
+            <p:ph type="sldNum" idx="5"/>
+          </p:nvPr>
+        </p:nvSpPr>
+        <p:spPr/>
+        <p:txBody>
+          <a:bodyPr xmlns:a="http://schemas.openxmlformats.org/drawingml/2006/main"/>
+          <a:lstStyle xmlns:a="http://schemas.openxmlformats.org/drawingml/2006/main"/>
+          <a:p xmlns:a="http://schemas.openxmlformats.org/drawingml/2006/main"/>
+        </p:txBody>
+      </p:sp>
+    </p:spTree>
+  </p:cSld>
+  <p:clrMapOvr>
+    <a:masterClrMapping xmlns:a="http://schemas.openxmlformats.org/drawingml/2006/main"/>
+  </p:clrMapOvr>
+</p:notes>
+</file>
+
+<file path=ppt/notesSlides/notesSlide17.xml><?xml version="1.0" encoding="utf-8"?>
+<p:notes xmlns:p="http://schemas.openxmlformats.org/presentationml/2006/main">
+  <p:cSld>
+    <p:spTree>
+      <p:nvGrpSpPr>
+        <p:cNvPr id="1" name=""/>
+        <p:cNvGrpSpPr/>
+        <p:nvPr/>
+      </p:nvGrpSpPr>
+      <p:grpSpPr>
+        <a:xfrm xmlns:a="http://schemas.openxmlformats.org/drawingml/2006/main"/>
+      </p:grpSpPr>
+      <p:sp>
+        <p:nvSpPr>
+          <p:cNvPr id="2" name="Slide Image Placeholder 1"/>
+          <p:cNvSpPr>
+            <a:spLocks xmlns:a="http://schemas.openxmlformats.org/drawingml/2006/main" noGrp="1"/>
+          </p:cNvSpPr>
+          <p:nvPr>
+            <p:ph type="sldImg" idx="0"/>
+          </p:nvPr>
+        </p:nvSpPr>
+        <p:spPr/>
+      </p:sp>
+      <p:sp>
+        <p:nvSpPr>
+          <p:cNvPr id="3" name="Notes Placeholder 2"/>
+          <p:cNvSpPr>
+            <a:spLocks xmlns:a="http://schemas.openxmlformats.org/drawingml/2006/main" noGrp="1"/>
+          </p:cNvSpPr>
+          <p:nvPr>
+            <p:ph type="body" idx="1"/>
+          </p:nvPr>
+        </p:nvSpPr>
+        <p:spPr/>
+        <p:txBody>
+          <a:bodyPr xmlns:a="http://schemas.openxmlformats.org/drawingml/2006/main"/>
+          <a:lstStyle xmlns:a="http://schemas.openxmlformats.org/drawingml/2006/main"/>
+          <a:p xmlns:a="http://schemas.openxmlformats.org/drawingml/2006/main">
+            <a:r>
               <a:t>讲稿：最后总结三点。第一，理解空间转录组数据结构和标准分析流程是项目基础。第二，SpatialScope 用 LangGraph 把流程组织成计划、执行、校验、修复和报告。第三，LLM 被限制在 evidence pack 内，用于解释和问答，而不是替代数值分析。</a:t>
             </a:r>
           </a:p>
           <a:p xmlns:a="http://schemas.openxmlformats.org/drawingml/2006/main">
             <a:r>
+              <a:t/>
+            </a:r>
+          </a:p>
+          <a:p xmlns:a="http://schemas.openxmlformats.org/drawingml/2006/main">
+            <a:r>
               <a:t>操作：此页留在 PPT。指向交付与验证卡片：GitHub repo、Streamlit app、GitHub Pages、final PDF report、99 passed。</a:t>
+            </a:r>
+          </a:p>
+          <a:p xmlns:a="http://schemas.openxmlformats.org/drawingml/2006/main">
+            <a:r>
+              <a:t/>
             </a:r>
           </a:p>
           <a:p xmlns:a="http://schemas.openxmlformats.org/drawingml/2006/main">
@@ -1860,7 +2031,7 @@
   </p:cSld>
   <p:clrMap bg1="lt1" tx1="dk1" bg2="lt2" tx2="dk2" accent1="accent1" accent2="accent2" accent3="accent3" accent4="accent4" accent5="accent5" accent6="accent6" hlink="hlink" folHlink="folHlink"/>
   <p:sldLayoutIdLst>
-    <p:sldLayoutId xmlns:r="http://schemas.openxmlformats.org/officeDocument/2006/relationships" id="2147483649" r:id="R72215cc291ae41b8"/>
+    <p:sldLayoutId xmlns:r="http://schemas.openxmlformats.org/officeDocument/2006/relationships" id="2147483649" r:id="R7b42a05a4c2c4c72"/>
   </p:sldLayoutIdLst>
   <p:txStyles>
     <p:titleStyle>
@@ -2474,14 +2645,14 @@
       </p:sp>
       <p:pic>
         <p:nvPicPr>
-          <p:cNvPr id="20" name=""/>
+          <p:cNvPr id="22" name=""/>
           <p:cNvPicPr>
             <a:picLocks xmlns:a="http://schemas.openxmlformats.org/drawingml/2006/main" noChangeAspect="1"/>
           </p:cNvPicPr>
           <p:nvPr/>
         </p:nvPicPr>
         <p:blipFill>
-          <a:blip xmlns:r="http://schemas.openxmlformats.org/officeDocument/2006/relationships" xmlns:a="http://schemas.openxmlformats.org/drawingml/2006/main" r:embed="R5911c689ef324efa"/>
+          <a:blip xmlns:r="http://schemas.openxmlformats.org/officeDocument/2006/relationships" xmlns:a="http://schemas.openxmlformats.org/drawingml/2006/main" r:embed="Rfa2947ec9ce3440b"/>
           <a:stretch xmlns:a="http://schemas.openxmlformats.org/drawingml/2006/main"/>
         </p:blipFill>
         <p:spPr>
@@ -2490,9 +2661,7 @@
             <a:ext cx="781050" cy="781050"/>
           </a:xfrm>
           <a:prstGeom xmlns:a="http://schemas.openxmlformats.org/drawingml/2006/main" prst="roundRect">
-            <a:avLst>
-              <a:gd name="adj" fmla="val 9756"/>
-            </a:avLst>
+            <a:avLst/>
           </a:prstGeom>
         </p:spPr>
       </p:pic>
@@ -2684,14 +2853,14 @@
       </p:sp>
       <p:pic>
         <p:nvPicPr>
-          <p:cNvPr id="24" name=""/>
+          <p:cNvPr id="26" name=""/>
           <p:cNvPicPr>
             <a:picLocks xmlns:a="http://schemas.openxmlformats.org/drawingml/2006/main" noChangeAspect="1"/>
           </p:cNvPicPr>
           <p:nvPr/>
         </p:nvPicPr>
         <p:blipFill>
-          <a:blip xmlns:r="http://schemas.openxmlformats.org/officeDocument/2006/relationships" xmlns:a="http://schemas.openxmlformats.org/drawingml/2006/main" r:embed="Rffc4392112724738"/>
+          <a:blip xmlns:r="http://schemas.openxmlformats.org/officeDocument/2006/relationships" xmlns:a="http://schemas.openxmlformats.org/drawingml/2006/main" r:embed="R383c861c02554c86"/>
           <a:srcRect xmlns:a="http://schemas.openxmlformats.org/drawingml/2006/main" l="0" t="10358" r="0" b="10358"/>
           <a:stretch xmlns:a="http://schemas.openxmlformats.org/drawingml/2006/main">
             <a:fillRect l="0" t="0" r="0" b="0"/>
@@ -2703,9 +2872,7 @@
             <a:ext cx="6381750" cy="3162300"/>
           </a:xfrm>
           <a:prstGeom xmlns:a="http://schemas.openxmlformats.org/drawingml/2006/main" prst="roundRect">
-            <a:avLst>
-              <a:gd name="adj" fmla="val 3614"/>
-            </a:avLst>
+            <a:avLst/>
           </a:prstGeom>
         </p:spPr>
       </p:pic>
@@ -2915,6 +3082,7 @@
           <a:lstStyle xmlns:a="http://schemas.openxmlformats.org/drawingml/2006/main"/>
           <a:p xmlns:a="http://schemas.openxmlformats.org/drawingml/2006/main">
             <a:pPr algn="ctr">
+              <a:buNone/>
               <a:defRPr sz="1013" b="1">
                 <a:solidFill>
                   <a:srgbClr val="0F766E"/>
@@ -2979,6 +3147,7 @@
           <a:lstStyle xmlns:a="http://schemas.openxmlformats.org/drawingml/2006/main"/>
           <a:p xmlns:a="http://schemas.openxmlformats.org/drawingml/2006/main">
             <a:pPr algn="ctr">
+              <a:buNone/>
               <a:defRPr sz="1013" b="1">
                 <a:solidFill>
                   <a:srgbClr val="0F766E"/>
@@ -3043,6 +3212,7 @@
           <a:lstStyle xmlns:a="http://schemas.openxmlformats.org/drawingml/2006/main"/>
           <a:p xmlns:a="http://schemas.openxmlformats.org/drawingml/2006/main">
             <a:pPr algn="ctr">
+              <a:buNone/>
               <a:defRPr sz="1013" b="1">
                 <a:solidFill>
                   <a:srgbClr val="0F766E"/>
@@ -5646,6 +5816,7 @@
           <a:lstStyle xmlns:a="http://schemas.openxmlformats.org/drawingml/2006/main"/>
           <a:p xmlns:a="http://schemas.openxmlformats.org/drawingml/2006/main">
             <a:pPr algn="ctr">
+              <a:buNone/>
               <a:defRPr sz="1425">
                 <a:solidFill>
                   <a:srgbClr val="17212B"/>
@@ -5710,6 +5881,7 @@
           <a:lstStyle xmlns:a="http://schemas.openxmlformats.org/drawingml/2006/main"/>
           <a:p xmlns:a="http://schemas.openxmlformats.org/drawingml/2006/main">
             <a:pPr algn="ctr">
+              <a:buNone/>
               <a:defRPr sz="1388" b="1">
                 <a:solidFill>
                   <a:srgbClr val="0B4F49"/>
@@ -5735,7 +5907,7 @@
       </p:sp>
       <p:cxnSp>
         <p:nvCxnSpPr>
-          <p:cNvPr id="38" name=""/>
+          <p:cNvPr id="66" name=""/>
           <p:cNvCxnSpPr>
             <a:stCxn xmlns:a="http://schemas.openxmlformats.org/drawingml/2006/main" id="5" idx="3"/>
             <a:endCxn xmlns:a="http://schemas.openxmlformats.org/drawingml/2006/main" id="6" idx="1"/>
@@ -5800,6 +5972,7 @@
           <a:lstStyle xmlns:a="http://schemas.openxmlformats.org/drawingml/2006/main"/>
           <a:p xmlns:a="http://schemas.openxmlformats.org/drawingml/2006/main">
             <a:pPr algn="ctr">
+              <a:buNone/>
               <a:defRPr sz="1425">
                 <a:solidFill>
                   <a:srgbClr val="17212B"/>
@@ -5864,6 +6037,7 @@
           <a:lstStyle xmlns:a="http://schemas.openxmlformats.org/drawingml/2006/main"/>
           <a:p xmlns:a="http://schemas.openxmlformats.org/drawingml/2006/main">
             <a:pPr algn="ctr">
+              <a:buNone/>
               <a:defRPr sz="1388" b="1">
                 <a:solidFill>
                   <a:srgbClr val="0B4F49"/>
@@ -5889,7 +6063,7 @@
       </p:sp>
       <p:cxnSp>
         <p:nvCxnSpPr>
-          <p:cNvPr id="41" name=""/>
+          <p:cNvPr id="69" name=""/>
           <p:cNvCxnSpPr>
             <a:stCxn xmlns:a="http://schemas.openxmlformats.org/drawingml/2006/main" id="8" idx="3"/>
             <a:endCxn xmlns:a="http://schemas.openxmlformats.org/drawingml/2006/main" id="9" idx="1"/>
@@ -5954,6 +6128,7 @@
           <a:lstStyle xmlns:a="http://schemas.openxmlformats.org/drawingml/2006/main"/>
           <a:p xmlns:a="http://schemas.openxmlformats.org/drawingml/2006/main">
             <a:pPr algn="ctr">
+              <a:buNone/>
               <a:defRPr sz="1425">
                 <a:solidFill>
                   <a:srgbClr val="17212B"/>
@@ -6018,6 +6193,7 @@
           <a:lstStyle xmlns:a="http://schemas.openxmlformats.org/drawingml/2006/main"/>
           <a:p xmlns:a="http://schemas.openxmlformats.org/drawingml/2006/main">
             <a:pPr algn="ctr">
+              <a:buNone/>
               <a:defRPr sz="1388" b="1">
                 <a:solidFill>
                   <a:srgbClr val="0B4F49"/>
@@ -6043,7 +6219,7 @@
       </p:sp>
       <p:cxnSp>
         <p:nvCxnSpPr>
-          <p:cNvPr id="44" name=""/>
+          <p:cNvPr id="72" name=""/>
           <p:cNvCxnSpPr>
             <a:stCxn xmlns:a="http://schemas.openxmlformats.org/drawingml/2006/main" id="11" idx="3"/>
             <a:endCxn xmlns:a="http://schemas.openxmlformats.org/drawingml/2006/main" id="12" idx="1"/>
@@ -6108,6 +6284,7 @@
           <a:lstStyle xmlns:a="http://schemas.openxmlformats.org/drawingml/2006/main"/>
           <a:p xmlns:a="http://schemas.openxmlformats.org/drawingml/2006/main">
             <a:pPr algn="ctr">
+              <a:buNone/>
               <a:defRPr sz="1425">
                 <a:solidFill>
                   <a:srgbClr val="17212B"/>
@@ -6172,6 +6349,7 @@
           <a:lstStyle xmlns:a="http://schemas.openxmlformats.org/drawingml/2006/main"/>
           <a:p xmlns:a="http://schemas.openxmlformats.org/drawingml/2006/main">
             <a:pPr algn="ctr">
+              <a:buNone/>
               <a:defRPr sz="1388" b="1">
                 <a:solidFill>
                   <a:srgbClr val="0B4F49"/>
@@ -6197,7 +6375,7 @@
       </p:sp>
       <p:cxnSp>
         <p:nvCxnSpPr>
-          <p:cNvPr id="47" name=""/>
+          <p:cNvPr id="75" name=""/>
           <p:cNvCxnSpPr>
             <a:stCxn xmlns:a="http://schemas.openxmlformats.org/drawingml/2006/main" id="14" idx="3"/>
             <a:endCxn xmlns:a="http://schemas.openxmlformats.org/drawingml/2006/main" id="15" idx="1"/>
@@ -6262,6 +6440,7 @@
           <a:lstStyle xmlns:a="http://schemas.openxmlformats.org/drawingml/2006/main"/>
           <a:p xmlns:a="http://schemas.openxmlformats.org/drawingml/2006/main">
             <a:pPr algn="ctr">
+              <a:buNone/>
               <a:defRPr sz="1425">
                 <a:solidFill>
                   <a:srgbClr val="17212B"/>
@@ -6326,6 +6505,7 @@
           <a:lstStyle xmlns:a="http://schemas.openxmlformats.org/drawingml/2006/main"/>
           <a:p xmlns:a="http://schemas.openxmlformats.org/drawingml/2006/main">
             <a:pPr algn="ctr">
+              <a:buNone/>
               <a:defRPr sz="1388" b="1">
                 <a:solidFill>
                   <a:srgbClr val="0B4F49"/>
@@ -6351,7 +6531,7 @@
       </p:sp>
       <p:cxnSp>
         <p:nvCxnSpPr>
-          <p:cNvPr id="50" name=""/>
+          <p:cNvPr id="78" name=""/>
           <p:cNvCxnSpPr>
             <a:stCxn xmlns:a="http://schemas.openxmlformats.org/drawingml/2006/main" id="17" idx="3"/>
             <a:endCxn xmlns:a="http://schemas.openxmlformats.org/drawingml/2006/main" id="18" idx="1"/>
@@ -6416,6 +6596,7 @@
           <a:lstStyle xmlns:a="http://schemas.openxmlformats.org/drawingml/2006/main"/>
           <a:p xmlns:a="http://schemas.openxmlformats.org/drawingml/2006/main">
             <a:pPr algn="ctr">
+              <a:buNone/>
               <a:defRPr sz="1425">
                 <a:solidFill>
                   <a:srgbClr val="17212B"/>
@@ -6480,6 +6661,7 @@
           <a:lstStyle xmlns:a="http://schemas.openxmlformats.org/drawingml/2006/main"/>
           <a:p xmlns:a="http://schemas.openxmlformats.org/drawingml/2006/main">
             <a:pPr algn="ctr">
+              <a:buNone/>
               <a:defRPr sz="1388" b="1">
                 <a:solidFill>
                   <a:srgbClr val="0B4F49"/>
@@ -6505,7 +6687,7 @@
       </p:sp>
       <p:cxnSp>
         <p:nvCxnSpPr>
-          <p:cNvPr id="53" name=""/>
+          <p:cNvPr id="81" name=""/>
           <p:cNvCxnSpPr>
             <a:stCxn xmlns:a="http://schemas.openxmlformats.org/drawingml/2006/main" id="20" idx="3"/>
             <a:endCxn xmlns:a="http://schemas.openxmlformats.org/drawingml/2006/main" id="21" idx="1"/>
@@ -6570,6 +6752,7 @@
           <a:lstStyle xmlns:a="http://schemas.openxmlformats.org/drawingml/2006/main"/>
           <a:p xmlns:a="http://schemas.openxmlformats.org/drawingml/2006/main">
             <a:pPr algn="ctr">
+              <a:buNone/>
               <a:defRPr sz="1425">
                 <a:solidFill>
                   <a:srgbClr val="17212B"/>
@@ -6634,6 +6817,7 @@
           <a:lstStyle xmlns:a="http://schemas.openxmlformats.org/drawingml/2006/main"/>
           <a:p xmlns:a="http://schemas.openxmlformats.org/drawingml/2006/main">
             <a:pPr algn="ctr">
+              <a:buNone/>
               <a:defRPr sz="1388" b="1">
                 <a:solidFill>
                   <a:srgbClr val="0B4F49"/>
@@ -6659,7 +6843,7 @@
       </p:sp>
       <p:cxnSp>
         <p:nvCxnSpPr>
-          <p:cNvPr id="56" name=""/>
+          <p:cNvPr id="84" name=""/>
           <p:cNvCxnSpPr>
             <a:stCxn xmlns:a="http://schemas.openxmlformats.org/drawingml/2006/main" id="23" idx="3"/>
             <a:endCxn xmlns:a="http://schemas.openxmlformats.org/drawingml/2006/main" id="24" idx="1"/>
@@ -6724,6 +6908,7 @@
           <a:lstStyle xmlns:a="http://schemas.openxmlformats.org/drawingml/2006/main"/>
           <a:p xmlns:a="http://schemas.openxmlformats.org/drawingml/2006/main">
             <a:pPr algn="ctr">
+              <a:buNone/>
               <a:defRPr sz="1425">
                 <a:solidFill>
                   <a:srgbClr val="17212B"/>
@@ -6788,6 +6973,7 @@
           <a:lstStyle xmlns:a="http://schemas.openxmlformats.org/drawingml/2006/main"/>
           <a:p xmlns:a="http://schemas.openxmlformats.org/drawingml/2006/main">
             <a:pPr algn="ctr">
+              <a:buNone/>
               <a:defRPr sz="1388" b="1">
                 <a:solidFill>
                   <a:srgbClr val="0B4F49"/>
@@ -6813,7 +6999,7 @@
       </p:sp>
       <p:cxnSp>
         <p:nvCxnSpPr>
-          <p:cNvPr id="59" name=""/>
+          <p:cNvPr id="87" name=""/>
           <p:cNvCxnSpPr>
             <a:stCxn xmlns:a="http://schemas.openxmlformats.org/drawingml/2006/main" id="26" idx="3"/>
             <a:endCxn xmlns:a="http://schemas.openxmlformats.org/drawingml/2006/main" id="27" idx="1"/>
@@ -7147,14 +7333,14 @@
       </p:sp>
       <p:pic>
         <p:nvPicPr>
-          <p:cNvPr id="33" name=""/>
+          <p:cNvPr id="35" name=""/>
           <p:cNvPicPr>
             <a:picLocks xmlns:a="http://schemas.openxmlformats.org/drawingml/2006/main" noChangeAspect="1"/>
           </p:cNvPicPr>
           <p:nvPr/>
         </p:nvPicPr>
         <p:blipFill>
-          <a:blip xmlns:r="http://schemas.openxmlformats.org/officeDocument/2006/relationships" xmlns:a="http://schemas.openxmlformats.org/drawingml/2006/main" r:embed="R99707a8c62444ee6"/>
+          <a:blip xmlns:r="http://schemas.openxmlformats.org/officeDocument/2006/relationships" xmlns:a="http://schemas.openxmlformats.org/drawingml/2006/main" r:embed="R7a63601b11db47b8"/>
           <a:srcRect xmlns:a="http://schemas.openxmlformats.org/drawingml/2006/main" l="0" t="17360" r="0" b="17360"/>
           <a:stretch xmlns:a="http://schemas.openxmlformats.org/drawingml/2006/main">
             <a:fillRect l="0" t="0" r="0" b="0"/>
@@ -7166,22 +7352,20 @@
             <a:ext cx="4762500" cy="1943100"/>
           </a:xfrm>
           <a:prstGeom xmlns:a="http://schemas.openxmlformats.org/drawingml/2006/main" prst="roundRect">
-            <a:avLst>
-              <a:gd name="adj" fmla="val 5882"/>
-            </a:avLst>
+            <a:avLst/>
           </a:prstGeom>
         </p:spPr>
       </p:pic>
       <p:pic>
         <p:nvPicPr>
-          <p:cNvPr id="34" name=""/>
+          <p:cNvPr id="36" name=""/>
           <p:cNvPicPr>
             <a:picLocks xmlns:a="http://schemas.openxmlformats.org/drawingml/2006/main" noChangeAspect="1"/>
           </p:cNvPicPr>
           <p:nvPr/>
         </p:nvPicPr>
         <p:blipFill>
-          <a:blip xmlns:r="http://schemas.openxmlformats.org/officeDocument/2006/relationships" xmlns:a="http://schemas.openxmlformats.org/drawingml/2006/main" r:embed="Rd0a78d8ea48c427c"/>
+          <a:blip xmlns:r="http://schemas.openxmlformats.org/officeDocument/2006/relationships" xmlns:a="http://schemas.openxmlformats.org/drawingml/2006/main" r:embed="R24b1bb5068044729"/>
           <a:srcRect xmlns:a="http://schemas.openxmlformats.org/drawingml/2006/main" l="0" t="17360" r="0" b="17360"/>
           <a:stretch xmlns:a="http://schemas.openxmlformats.org/drawingml/2006/main">
             <a:fillRect l="0" t="0" r="0" b="0"/>
@@ -7193,9 +7377,7 @@
             <a:ext cx="4762500" cy="1943100"/>
           </a:xfrm>
           <a:prstGeom xmlns:a="http://schemas.openxmlformats.org/drawingml/2006/main" prst="roundRect">
-            <a:avLst>
-              <a:gd name="adj" fmla="val 5882"/>
-            </a:avLst>
+            <a:avLst/>
           </a:prstGeom>
         </p:spPr>
       </p:pic>
@@ -7450,6 +7632,7 @@
           <a:lstStyle xmlns:a="http://schemas.openxmlformats.org/drawingml/2006/main"/>
           <a:p xmlns:a="http://schemas.openxmlformats.org/drawingml/2006/main">
             <a:pPr algn="ctr">
+              <a:buNone/>
               <a:defRPr sz="938" b="1">
                 <a:solidFill>
                   <a:srgbClr val="FFFFFF"/>
@@ -7642,6 +7825,7 @@
           <a:lstStyle xmlns:a="http://schemas.openxmlformats.org/drawingml/2006/main"/>
           <a:p xmlns:a="http://schemas.openxmlformats.org/drawingml/2006/main">
             <a:pPr algn="ctr">
+              <a:buNone/>
               <a:defRPr sz="938" b="1">
                 <a:solidFill>
                   <a:srgbClr val="FFFFFF"/>
@@ -7834,6 +8018,7 @@
           <a:lstStyle xmlns:a="http://schemas.openxmlformats.org/drawingml/2006/main"/>
           <a:p xmlns:a="http://schemas.openxmlformats.org/drawingml/2006/main">
             <a:pPr algn="ctr">
+              <a:buNone/>
               <a:defRPr sz="938" b="1">
                 <a:solidFill>
                   <a:srgbClr val="FFFFFF"/>
@@ -8026,6 +8211,7 @@
           <a:lstStyle xmlns:a="http://schemas.openxmlformats.org/drawingml/2006/main"/>
           <a:p xmlns:a="http://schemas.openxmlformats.org/drawingml/2006/main">
             <a:pPr algn="ctr">
+              <a:buNone/>
               <a:defRPr sz="938" b="1">
                 <a:solidFill>
                   <a:srgbClr val="FFFFFF"/>
@@ -10821,33 +11007,6 @@
                 <a:ea typeface="PingFang SC"/>
                 <a:cs typeface="PingFang SC"/>
               </a:rPr>
-              <a:t>GSM9046244 ... stereo_rep2.h5ad</a:t>
-            </a:r>
-          </a:p>
-          <a:p xmlns:a="http://schemas.openxmlformats.org/drawingml/2006/main">
-            <a:pPr algn="l">
-              <a:lnSpc>
-                <a:spcPct val="108000"/>
-              </a:lnSpc>
-              <a:buNone/>
-              <a:defRPr sz="1425" b="0" i="0">
-                <a:solidFill>
-                  <a:srgbClr val="475569"/>
-                </a:solidFill>
-                <a:latin typeface="PingFang SC"/>
-                <a:ea typeface="PingFang SC"/>
-                <a:cs typeface="PingFang SC"/>
-              </a:defRPr>
-            </a:pPr>
-            <a:r>
-              <a:rPr sz="1425" b="0" i="0">
-                <a:solidFill>
-                  <a:srgbClr val="475569"/>
-                </a:solidFill>
-                <a:latin typeface="PingFang SC"/>
-                <a:ea typeface="PingFang SC"/>
-                <a:cs typeface="PingFang SC"/>
-              </a:rPr>
               <a:t>8190 spots · 16364 genes</a:t>
             </a:r>
           </a:p>
@@ -10875,7 +11034,7 @@
                 <a:ea typeface="PingFang SC"/>
                 <a:cs typeface="PingFang SC"/>
               </a:rPr>
-              <a:t>X_spatial -&gt; spatial</a:t>
+              <a:t>obsm["X_spatial"] -&gt; obsm["spatial"]</a:t>
             </a:r>
           </a:p>
           <a:p xmlns:a="http://schemas.openxmlformats.org/drawingml/2006/main">
@@ -10902,21 +11061,48 @@
                 <a:ea typeface="PingFang SC"/>
                 <a:cs typeface="PingFang SC"/>
               </a:rPr>
-              <a:t>7 Leiden clusters · 0 warnings · 0 errors</a:t>
+              <a:t>Quick run: QC + UMAP + Leiden + gene panel</a:t>
+            </a:r>
+          </a:p>
+          <a:p xmlns:a="http://schemas.openxmlformats.org/drawingml/2006/main">
+            <a:pPr algn="l">
+              <a:lnSpc>
+                <a:spcPct val="108000"/>
+              </a:lnSpc>
+              <a:buNone/>
+              <a:defRPr sz="1425" b="0" i="0">
+                <a:solidFill>
+                  <a:srgbClr val="475569"/>
+                </a:solidFill>
+                <a:latin typeface="PingFang SC"/>
+                <a:ea typeface="PingFang SC"/>
+                <a:cs typeface="PingFang SC"/>
+              </a:defRPr>
+            </a:pPr>
+            <a:r>
+              <a:rPr sz="1425" b="0" i="0">
+                <a:solidFill>
+                  <a:srgbClr val="475569"/>
+                </a:solidFill>
+                <a:latin typeface="PingFang SC"/>
+                <a:ea typeface="PingFang SC"/>
+                <a:cs typeface="PingFang SC"/>
+              </a:rPr>
+              <a:t>7 clusters · 0 warnings · 0 errors</a:t>
             </a:r>
           </a:p>
         </p:txBody>
       </p:sp>
       <p:pic>
         <p:nvPicPr>
-          <p:cNvPr id="18" name=""/>
+          <p:cNvPr id="21" name=""/>
           <p:cNvPicPr>
             <a:picLocks xmlns:a="http://schemas.openxmlformats.org/drawingml/2006/main" noChangeAspect="1"/>
           </p:cNvPicPr>
           <p:nvPr/>
         </p:nvPicPr>
         <p:blipFill>
-          <a:blip xmlns:r="http://schemas.openxmlformats.org/officeDocument/2006/relationships" xmlns:a="http://schemas.openxmlformats.org/drawingml/2006/main" r:embed="Rb383447b315a4a49"/>
+          <a:blip xmlns:r="http://schemas.openxmlformats.org/officeDocument/2006/relationships" xmlns:a="http://schemas.openxmlformats.org/drawingml/2006/main" r:embed="Rab085b1d504e412c"/>
           <a:stretch xmlns:a="http://schemas.openxmlformats.org/drawingml/2006/main"/>
         </p:blipFill>
         <p:spPr>
@@ -10925,22 +11111,20 @@
             <a:ext cx="2741490" cy="2190750"/>
           </a:xfrm>
           <a:prstGeom xmlns:a="http://schemas.openxmlformats.org/drawingml/2006/main" prst="roundRect">
-            <a:avLst>
-              <a:gd name="adj" fmla="val 5217"/>
-            </a:avLst>
+            <a:avLst/>
           </a:prstGeom>
         </p:spPr>
       </p:pic>
       <p:pic>
         <p:nvPicPr>
-          <p:cNvPr id="19" name=""/>
+          <p:cNvPr id="22" name=""/>
           <p:cNvPicPr>
             <a:picLocks xmlns:a="http://schemas.openxmlformats.org/drawingml/2006/main" noChangeAspect="1"/>
           </p:cNvPicPr>
           <p:nvPr/>
         </p:nvPicPr>
         <p:blipFill>
-          <a:blip xmlns:r="http://schemas.openxmlformats.org/officeDocument/2006/relationships" xmlns:a="http://schemas.openxmlformats.org/drawingml/2006/main" r:embed="R14cd6f5f63cb47b9"/>
+          <a:blip xmlns:r="http://schemas.openxmlformats.org/officeDocument/2006/relationships" xmlns:a="http://schemas.openxmlformats.org/drawingml/2006/main" r:embed="R2e9461f257fe4bc7"/>
           <a:stretch xmlns:a="http://schemas.openxmlformats.org/drawingml/2006/main"/>
         </p:blipFill>
         <p:spPr>
@@ -10949,22 +11133,20 @@
             <a:ext cx="2952750" cy="1822284"/>
           </a:xfrm>
           <a:prstGeom xmlns:a="http://schemas.openxmlformats.org/drawingml/2006/main" prst="roundRect">
-            <a:avLst>
-              <a:gd name="adj" fmla="val 5217"/>
-            </a:avLst>
+            <a:avLst/>
           </a:prstGeom>
         </p:spPr>
       </p:pic>
       <p:pic>
         <p:nvPicPr>
-          <p:cNvPr id="20" name=""/>
+          <p:cNvPr id="23" name=""/>
           <p:cNvPicPr>
             <a:picLocks xmlns:a="http://schemas.openxmlformats.org/drawingml/2006/main" noChangeAspect="1"/>
           </p:cNvPicPr>
           <p:nvPr/>
         </p:nvPicPr>
         <p:blipFill>
-          <a:blip xmlns:r="http://schemas.openxmlformats.org/officeDocument/2006/relationships" xmlns:a="http://schemas.openxmlformats.org/drawingml/2006/main" r:embed="R7d1a0315ec49446a"/>
+          <a:blip xmlns:r="http://schemas.openxmlformats.org/officeDocument/2006/relationships" xmlns:a="http://schemas.openxmlformats.org/drawingml/2006/main" r:embed="R3e29ffbd25634e5c"/>
           <a:stretch xmlns:a="http://schemas.openxmlformats.org/drawingml/2006/main"/>
         </p:blipFill>
         <p:spPr>
@@ -10973,9 +11155,7 @@
             <a:ext cx="2506922" cy="1657350"/>
           </a:xfrm>
           <a:prstGeom xmlns:a="http://schemas.openxmlformats.org/drawingml/2006/main" prst="roundRect">
-            <a:avLst>
-              <a:gd name="adj" fmla="val 6897"/>
-            </a:avLst>
+            <a:avLst/>
           </a:prstGeom>
         </p:spPr>
       </p:pic>
@@ -11009,7 +11189,7 @@
         </p:spPr>
         <p:txBody>
           <a:bodyPr xmlns:a="http://schemas.openxmlformats.org/drawingml/2006/main" lIns="0" tIns="0" rIns="0" bIns="0" anchor="t">
-            <a:normAutofit fontScale="90633"/>
+            <a:normAutofit fontScale="80702"/>
           </a:bodyPr>
           <a:lstStyle xmlns:a="http://schemas.openxmlformats.org/drawingml/2006/main"/>
           <a:p xmlns:a="http://schemas.openxmlformats.org/drawingml/2006/main">
@@ -11036,7 +11216,7 @@
                 <a:ea typeface="PingFang SC"/>
                 <a:cs typeface="PingFang SC"/>
               </a:rPr>
-              <a:t>真实数据验证证明系统能处理真实 AnnData、真实坐标字段和更复杂的表达层状态。</a:t>
+              <a:t>这页不是声称发现新机制，而是验证系统能处理真实 AnnData、真实空间坐标和真实表达层状态。</a:t>
             </a:r>
           </a:p>
         </p:txBody>
@@ -11230,7 +11410,7 @@
           <p:cNvPr id="1" name="">
             <a:extLst xmlns:a="http://schemas.openxmlformats.org/drawingml/2006/main">
               <a:ext uri="{FF2B5EF4-FFF2-40B4-BE49-F238E27FC236}">
-                <a16:creationId xmlns:a16="http://schemas.microsoft.com/office/drawing/2014/main" id="{F08CDAF8-8E38-4D7F-96E6-F673D4259727}"/>
+                <a16:creationId xmlns:a16="http://schemas.microsoft.com/office/drawing/2014/main" id="{EABC0170-F86A-4D71-8C4E-9DDEB616EB8C}"/>
               </a:ext>
             </a:extLst>
           </p:cNvPr>
@@ -11282,7 +11462,7 @@
                 <a:ea typeface="PingFang SC"/>
                 <a:cs typeface="PingFang SC"/>
               </a:rPr>
-              <a:t>RESEARCH USE CASES</a:t>
+              <a:t>READING GUIDE</a:t>
             </a:r>
           </a:p>
         </p:txBody>
@@ -11292,7 +11472,7 @@
           <p:cNvPr id="2" name="">
             <a:extLst xmlns:a="http://schemas.openxmlformats.org/drawingml/2006/main">
               <a:ext uri="{FF2B5EF4-FFF2-40B4-BE49-F238E27FC236}">
-                <a16:creationId xmlns:a16="http://schemas.microsoft.com/office/drawing/2014/main" id="{BF8685D2-BFB7-4D4C-B334-1787B177A528}"/>
+                <a16:creationId xmlns:a16="http://schemas.microsoft.com/office/drawing/2014/main" id="{196A3E13-3DA9-4CDA-A5E9-E586D928DABE}"/>
               </a:ext>
             </a:extLst>
           </p:cNvPr>
@@ -11344,7 +11524,7 @@
                 <a:ea typeface="PingFang SC"/>
                 <a:cs typeface="PingFang SC"/>
               </a:rPr>
-              <a:t>面向真实科研场景的应用</a:t>
+              <a:t>如何读真实数据图</a:t>
             </a:r>
           </a:p>
         </p:txBody>
@@ -11354,27 +11534,27 @@
           <p:cNvPr id="3" name="">
             <a:extLst xmlns:a="http://schemas.openxmlformats.org/drawingml/2006/main">
               <a:ext uri="{FF2B5EF4-FFF2-40B4-BE49-F238E27FC236}">
-                <a16:creationId xmlns:a16="http://schemas.microsoft.com/office/drawing/2014/main" id="{816CF460-0C5D-41C2-B427-5231798E33EE}"/>
-              </a:ext>
-            </a:extLst>
-          </p:cNvPr>
-          <p:cNvSpPr>
-            <a:spLocks xmlns:a="http://schemas.openxmlformats.org/drawingml/2006/main" noGrp="1"/>
-          </p:cNvSpPr>
-          <p:nvPr/>
-        </p:nvSpPr>
-        <p:spPr>
-          <a:xfrm xmlns:a="http://schemas.openxmlformats.org/drawingml/2006/main">
-            <a:off x="819150" y="1581150"/>
-            <a:ext cx="2476500" cy="1390650"/>
+                <a16:creationId xmlns:a16="http://schemas.microsoft.com/office/drawing/2014/main" id="{D83787D5-CB9A-433B-A113-80345E5D04BA}"/>
+              </a:ext>
+            </a:extLst>
+          </p:cNvPr>
+          <p:cNvSpPr>
+            <a:spLocks xmlns:a="http://schemas.openxmlformats.org/drawingml/2006/main" noGrp="1"/>
+          </p:cNvSpPr>
+          <p:nvPr/>
+        </p:nvSpPr>
+        <p:spPr>
+          <a:xfrm xmlns:a="http://schemas.openxmlformats.org/drawingml/2006/main">
+            <a:off x="704850" y="1524000"/>
+            <a:ext cx="3619500" cy="2000250"/>
           </a:xfrm>
           <a:prstGeom xmlns:a="http://schemas.openxmlformats.org/drawingml/2006/main" prst="roundRect">
             <a:avLst>
-              <a:gd name="adj" fmla="val 8219"/>
+              <a:gd name="adj" fmla="val 5714"/>
             </a:avLst>
           </a:prstGeom>
           <a:solidFill xmlns:a="http://schemas.openxmlformats.org/drawingml/2006/main">
-            <a:srgbClr val="E9F5F2"/>
+            <a:srgbClr val="F6FAF8"/>
           </a:solidFill>
           <a:ln xmlns:a="http://schemas.openxmlformats.org/drawingml/2006/main" w="9525">
             <a:solidFill>
@@ -11395,19 +11575,19 @@
           <p:cNvPr id="4" name="">
             <a:extLst xmlns:a="http://schemas.openxmlformats.org/drawingml/2006/main">
               <a:ext uri="{FF2B5EF4-FFF2-40B4-BE49-F238E27FC236}">
-                <a16:creationId xmlns:a16="http://schemas.microsoft.com/office/drawing/2014/main" id="{2C6DB7D3-B959-4592-B562-E53DE718C99E}"/>
-              </a:ext>
-            </a:extLst>
-          </p:cNvPr>
-          <p:cNvSpPr>
-            <a:spLocks xmlns:a="http://schemas.openxmlformats.org/drawingml/2006/main" noGrp="1"/>
-          </p:cNvSpPr>
-          <p:nvPr/>
-        </p:nvSpPr>
-        <p:spPr>
-          <a:xfrm xmlns:a="http://schemas.openxmlformats.org/drawingml/2006/main">
-            <a:off x="1009650" y="1752600"/>
-            <a:ext cx="2095500" cy="285750"/>
+                <a16:creationId xmlns:a16="http://schemas.microsoft.com/office/drawing/2014/main" id="{970BCABE-0986-4E9F-9AE1-F2B476BD9906}"/>
+              </a:ext>
+            </a:extLst>
+          </p:cNvPr>
+          <p:cNvSpPr>
+            <a:spLocks xmlns:a="http://schemas.openxmlformats.org/drawingml/2006/main" noGrp="1"/>
+          </p:cNvSpPr>
+          <p:nvPr/>
+        </p:nvSpPr>
+        <p:spPr>
+          <a:xfrm xmlns:a="http://schemas.openxmlformats.org/drawingml/2006/main">
+            <a:off x="895350" y="1695450"/>
+            <a:ext cx="3238500" cy="285750"/>
           </a:xfrm>
           <a:prstGeom xmlns:a="http://schemas.openxmlformats.org/drawingml/2006/main" prst="rect">
             <a:avLst/>
@@ -11447,6 +11627,688 @@
                 <a:ea typeface="PingFang SC"/>
                 <a:cs typeface="PingFang SC"/>
               </a:rPr>
+              <a:t>Leiden 是什么？</a:t>
+            </a:r>
+          </a:p>
+        </p:txBody>
+      </p:sp>
+      <p:sp>
+        <p:nvSpPr>
+          <p:cNvPr id="5" name="">
+            <a:extLst xmlns:a="http://schemas.openxmlformats.org/drawingml/2006/main">
+              <a:ext uri="{FF2B5EF4-FFF2-40B4-BE49-F238E27FC236}">
+                <a16:creationId xmlns:a16="http://schemas.microsoft.com/office/drawing/2014/main" id="{E0D30BF8-71B3-42E8-A443-55FD366C2BAE}"/>
+              </a:ext>
+            </a:extLst>
+          </p:cNvPr>
+          <p:cNvSpPr>
+            <a:spLocks xmlns:a="http://schemas.openxmlformats.org/drawingml/2006/main" noGrp="1"/>
+          </p:cNvSpPr>
+          <p:nvPr/>
+        </p:nvSpPr>
+        <p:spPr>
+          <a:xfrm xmlns:a="http://schemas.openxmlformats.org/drawingml/2006/main">
+            <a:off x="895350" y="2076450"/>
+            <a:ext cx="3238500" cy="1333500"/>
+          </a:xfrm>
+          <a:prstGeom xmlns:a="http://schemas.openxmlformats.org/drawingml/2006/main" prst="rect">
+            <a:avLst/>
+          </a:prstGeom>
+          <a:noFill xmlns:a="http://schemas.openxmlformats.org/drawingml/2006/main"/>
+          <a:ln xmlns:a="http://schemas.openxmlformats.org/drawingml/2006/main" w="0">
+            <a:noFill/>
+            <a:prstDash val="solid"/>
+          </a:ln>
+        </p:spPr>
+        <p:txBody>
+          <a:bodyPr xmlns:a="http://schemas.openxmlformats.org/drawingml/2006/main" lIns="0" tIns="0" rIns="0" bIns="0" anchor="t">
+            <a:normAutofit fontScale="100000"/>
+          </a:bodyPr>
+          <a:lstStyle xmlns:a="http://schemas.openxmlformats.org/drawingml/2006/main"/>
+          <a:p xmlns:a="http://schemas.openxmlformats.org/drawingml/2006/main">
+            <a:pPr algn="l">
+              <a:lnSpc>
+                <a:spcPct val="108000"/>
+              </a:lnSpc>
+              <a:buNone/>
+              <a:defRPr sz="1425" b="0" i="0">
+                <a:solidFill>
+                  <a:srgbClr val="475569"/>
+                </a:solidFill>
+                <a:latin typeface="PingFang SC"/>
+                <a:ea typeface="PingFang SC"/>
+                <a:cs typeface="PingFang SC"/>
+              </a:defRPr>
+            </a:pPr>
+            <a:r>
+              <a:rPr sz="1425" b="0" i="0">
+                <a:solidFill>
+                  <a:srgbClr val="475569"/>
+                </a:solidFill>
+                <a:latin typeface="PingFang SC"/>
+                <a:ea typeface="PingFang SC"/>
+                <a:cs typeface="PingFang SC"/>
+              </a:rPr>
+              <a:t>Leiden clustering：把表达谱相似的 spots 分到同一组</a:t>
+            </a:r>
+          </a:p>
+          <a:p xmlns:a="http://schemas.openxmlformats.org/drawingml/2006/main">
+            <a:pPr algn="l">
+              <a:lnSpc>
+                <a:spcPct val="108000"/>
+              </a:lnSpc>
+              <a:buNone/>
+              <a:defRPr sz="1425" b="0" i="0">
+                <a:solidFill>
+                  <a:srgbClr val="475569"/>
+                </a:solidFill>
+                <a:latin typeface="PingFang SC"/>
+                <a:ea typeface="PingFang SC"/>
+                <a:cs typeface="PingFang SC"/>
+              </a:defRPr>
+            </a:pPr>
+            <a:r>
+              <a:rPr sz="1425" b="0" i="0">
+                <a:solidFill>
+                  <a:srgbClr val="475569"/>
+                </a:solidFill>
+                <a:latin typeface="PingFang SC"/>
+                <a:ea typeface="PingFang SC"/>
+                <a:cs typeface="PingFang SC"/>
+              </a:rPr>
+              <a:t>颜色只是 cluster ID，不等于细胞类型</a:t>
+            </a:r>
+          </a:p>
+          <a:p xmlns:a="http://schemas.openxmlformats.org/drawingml/2006/main">
+            <a:pPr algn="l">
+              <a:lnSpc>
+                <a:spcPct val="108000"/>
+              </a:lnSpc>
+              <a:buNone/>
+              <a:defRPr sz="1425" b="0" i="0">
+                <a:solidFill>
+                  <a:srgbClr val="475569"/>
+                </a:solidFill>
+                <a:latin typeface="PingFang SC"/>
+                <a:ea typeface="PingFang SC"/>
+                <a:cs typeface="PingFang SC"/>
+              </a:defRPr>
+            </a:pPr>
+            <a:r>
+              <a:rPr sz="1425" b="0" i="0">
+                <a:solidFill>
+                  <a:srgbClr val="475569"/>
+                </a:solidFill>
+                <a:latin typeface="PingFang SC"/>
+                <a:ea typeface="PingFang SC"/>
+                <a:cs typeface="PingFang SC"/>
+              </a:rPr>
+              <a:t>UMAP 分得清：表达状态可分</a:t>
+            </a:r>
+          </a:p>
+          <a:p xmlns:a="http://schemas.openxmlformats.org/drawingml/2006/main">
+            <a:pPr algn="l">
+              <a:lnSpc>
+                <a:spcPct val="108000"/>
+              </a:lnSpc>
+              <a:buNone/>
+              <a:defRPr sz="1425" b="0" i="0">
+                <a:solidFill>
+                  <a:srgbClr val="475569"/>
+                </a:solidFill>
+                <a:latin typeface="PingFang SC"/>
+                <a:ea typeface="PingFang SC"/>
+                <a:cs typeface="PingFang SC"/>
+              </a:defRPr>
+            </a:pPr>
+            <a:r>
+              <a:rPr sz="1425" b="0" i="0">
+                <a:solidFill>
+                  <a:srgbClr val="475569"/>
+                </a:solidFill>
+                <a:latin typeface="PingFang SC"/>
+                <a:ea typeface="PingFang SC"/>
+                <a:cs typeface="PingFang SC"/>
+              </a:rPr>
+              <a:t>Spatial 混在一起：真实组织结构更复杂</a:t>
+            </a:r>
+          </a:p>
+        </p:txBody>
+      </p:sp>
+      <p:pic>
+        <p:nvPicPr>
+          <p:cNvPr id="21" name=""/>
+          <p:cNvPicPr>
+            <a:picLocks xmlns:a="http://schemas.openxmlformats.org/drawingml/2006/main" noChangeAspect="1"/>
+          </p:cNvPicPr>
+          <p:nvPr/>
+        </p:nvPicPr>
+        <p:blipFill>
+          <a:blip xmlns:r="http://schemas.openxmlformats.org/officeDocument/2006/relationships" xmlns:a="http://schemas.openxmlformats.org/drawingml/2006/main" r:embed="Rd0be40847c164fb4"/>
+          <a:stretch xmlns:a="http://schemas.openxmlformats.org/drawingml/2006/main"/>
+        </p:blipFill>
+        <p:spPr>
+          <a:xfrm xmlns:a="http://schemas.openxmlformats.org/drawingml/2006/main">
+            <a:off x="4762500" y="1428750"/>
+            <a:ext cx="2714625" cy="2047875"/>
+          </a:xfrm>
+          <a:prstGeom xmlns:a="http://schemas.openxmlformats.org/drawingml/2006/main" prst="roundRect">
+            <a:avLst/>
+          </a:prstGeom>
+        </p:spPr>
+      </p:pic>
+      <p:pic>
+        <p:nvPicPr>
+          <p:cNvPr id="22" name=""/>
+          <p:cNvPicPr>
+            <a:picLocks xmlns:a="http://schemas.openxmlformats.org/drawingml/2006/main" noChangeAspect="1"/>
+          </p:cNvPicPr>
+          <p:nvPr/>
+        </p:nvPicPr>
+        <p:blipFill>
+          <a:blip xmlns:r="http://schemas.openxmlformats.org/officeDocument/2006/relationships" xmlns:a="http://schemas.openxmlformats.org/drawingml/2006/main" r:embed="Rbf6d077675be4cb5"/>
+          <a:stretch xmlns:a="http://schemas.openxmlformats.org/drawingml/2006/main"/>
+        </p:blipFill>
+        <p:spPr>
+          <a:xfrm xmlns:a="http://schemas.openxmlformats.org/drawingml/2006/main">
+            <a:off x="7829550" y="1381125"/>
+            <a:ext cx="3238500" cy="2143125"/>
+          </a:xfrm>
+          <a:prstGeom xmlns:a="http://schemas.openxmlformats.org/drawingml/2006/main" prst="roundRect">
+            <a:avLst/>
+          </a:prstGeom>
+        </p:spPr>
+      </p:pic>
+      <p:pic>
+        <p:nvPicPr>
+          <p:cNvPr id="23" name=""/>
+          <p:cNvPicPr>
+            <a:picLocks xmlns:a="http://schemas.openxmlformats.org/drawingml/2006/main" noChangeAspect="1"/>
+          </p:cNvPicPr>
+          <p:nvPr/>
+        </p:nvPicPr>
+        <p:blipFill>
+          <a:blip xmlns:r="http://schemas.openxmlformats.org/officeDocument/2006/relationships" xmlns:a="http://schemas.openxmlformats.org/drawingml/2006/main" r:embed="R0a8592c124a849b3"/>
+          <a:stretch xmlns:a="http://schemas.openxmlformats.org/drawingml/2006/main"/>
+        </p:blipFill>
+        <p:spPr>
+          <a:xfrm xmlns:a="http://schemas.openxmlformats.org/drawingml/2006/main">
+            <a:off x="5715000" y="3905250"/>
+            <a:ext cx="5095875" cy="1762125"/>
+          </a:xfrm>
+          <a:prstGeom xmlns:a="http://schemas.openxmlformats.org/drawingml/2006/main" prst="roundRect">
+            <a:avLst/>
+          </a:prstGeom>
+        </p:spPr>
+      </p:pic>
+      <p:sp>
+        <p:nvSpPr>
+          <p:cNvPr id="9" name="">
+            <a:extLst xmlns:a="http://schemas.openxmlformats.org/drawingml/2006/main">
+              <a:ext uri="{FF2B5EF4-FFF2-40B4-BE49-F238E27FC236}">
+                <a16:creationId xmlns:a16="http://schemas.microsoft.com/office/drawing/2014/main" id="{6B80F217-C291-455D-945A-FC7C668C4649}"/>
+              </a:ext>
+            </a:extLst>
+          </p:cNvPr>
+          <p:cNvSpPr>
+            <a:spLocks xmlns:a="http://schemas.openxmlformats.org/drawingml/2006/main" noGrp="1"/>
+          </p:cNvSpPr>
+          <p:nvPr/>
+        </p:nvSpPr>
+        <p:spPr>
+          <a:xfrm xmlns:a="http://schemas.openxmlformats.org/drawingml/2006/main">
+            <a:off x="914400" y="4953000"/>
+            <a:ext cx="3238500" cy="704850"/>
+          </a:xfrm>
+          <a:prstGeom xmlns:a="http://schemas.openxmlformats.org/drawingml/2006/main" prst="rect">
+            <a:avLst/>
+          </a:prstGeom>
+          <a:noFill xmlns:a="http://schemas.openxmlformats.org/drawingml/2006/main"/>
+          <a:ln xmlns:a="http://schemas.openxmlformats.org/drawingml/2006/main" w="0">
+            <a:noFill/>
+            <a:prstDash val="solid"/>
+          </a:ln>
+        </p:spPr>
+        <p:txBody>
+          <a:bodyPr xmlns:a="http://schemas.openxmlformats.org/drawingml/2006/main" lIns="0" tIns="0" rIns="0" bIns="0" anchor="t">
+            <a:normAutofit fontScale="78440"/>
+          </a:bodyPr>
+          <a:lstStyle xmlns:a="http://schemas.openxmlformats.org/drawingml/2006/main"/>
+          <a:p xmlns:a="http://schemas.openxmlformats.org/drawingml/2006/main">
+            <a:pPr algn="l">
+              <a:lnSpc>
+                <a:spcPct val="108000"/>
+              </a:lnSpc>
+              <a:buNone/>
+              <a:defRPr sz="1575" b="1" i="0">
+                <a:solidFill>
+                  <a:srgbClr val="17212B"/>
+                </a:solidFill>
+                <a:latin typeface="PingFang SC"/>
+                <a:ea typeface="PingFang SC"/>
+                <a:cs typeface="PingFang SC"/>
+              </a:defRPr>
+            </a:pPr>
+            <a:r>
+              <a:rPr sz="1575" b="1" i="0">
+                <a:solidFill>
+                  <a:srgbClr val="17212B"/>
+                </a:solidFill>
+                <a:latin typeface="PingFang SC"/>
+                <a:ea typeface="PingFang SC"/>
+                <a:cs typeface="PingFang SC"/>
+              </a:rPr>
+              <a:t>读图顺序：先看 UMAP 聚类是否分开，再回到 Spatial 看组织位置，最后用 T、Mesp1 等基因图寻找可解释的发育区域。</a:t>
+            </a:r>
+          </a:p>
+        </p:txBody>
+      </p:sp>
+      <p:sp>
+        <p:nvSpPr>
+          <p:cNvPr id="10" name="">
+            <a:extLst xmlns:a="http://schemas.openxmlformats.org/drawingml/2006/main">
+              <a:ext uri="{FF2B5EF4-FFF2-40B4-BE49-F238E27FC236}">
+                <a16:creationId xmlns:a16="http://schemas.microsoft.com/office/drawing/2014/main" id="{04D7FE8A-919F-4F67-8E56-D49023B944A0}"/>
+              </a:ext>
+            </a:extLst>
+          </p:cNvPr>
+          <p:cNvSpPr>
+            <a:spLocks xmlns:a="http://schemas.openxmlformats.org/drawingml/2006/main" noGrp="1"/>
+          </p:cNvSpPr>
+          <p:nvPr/>
+        </p:nvSpPr>
+        <p:spPr>
+          <a:xfrm xmlns:a="http://schemas.openxmlformats.org/drawingml/2006/main">
+            <a:off x="609600" y="6438900"/>
+            <a:ext cx="10972800" cy="0"/>
+          </a:xfrm>
+          <a:prstGeom xmlns:a="http://schemas.openxmlformats.org/drawingml/2006/main" prst="line">
+            <a:avLst/>
+          </a:prstGeom>
+          <a:noFill xmlns:a="http://schemas.openxmlformats.org/drawingml/2006/main"/>
+          <a:ln xmlns:a="http://schemas.openxmlformats.org/drawingml/2006/main" w="9525">
+            <a:solidFill>
+              <a:srgbClr val="D7E4E0"/>
+            </a:solidFill>
+            <a:prstDash val="solid"/>
+          </a:ln>
+        </p:spPr>
+      </p:sp>
+      <p:sp>
+        <p:nvSpPr>
+          <p:cNvPr id="11" name="">
+            <a:extLst xmlns:a="http://schemas.openxmlformats.org/drawingml/2006/main">
+              <a:ext uri="{FF2B5EF4-FFF2-40B4-BE49-F238E27FC236}">
+                <a16:creationId xmlns:a16="http://schemas.microsoft.com/office/drawing/2014/main" id="{6ABE88E0-098F-4F3F-8DD4-1492AFC292EE}"/>
+              </a:ext>
+            </a:extLst>
+          </p:cNvPr>
+          <p:cNvSpPr>
+            <a:spLocks xmlns:a="http://schemas.openxmlformats.org/drawingml/2006/main" noGrp="1"/>
+          </p:cNvSpPr>
+          <p:nvPr/>
+        </p:nvSpPr>
+        <p:spPr>
+          <a:xfrm xmlns:a="http://schemas.openxmlformats.org/drawingml/2006/main">
+            <a:off x="609600" y="6515100"/>
+            <a:ext cx="8572500" cy="190500"/>
+          </a:xfrm>
+          <a:prstGeom xmlns:a="http://schemas.openxmlformats.org/drawingml/2006/main" prst="rect">
+            <a:avLst/>
+          </a:prstGeom>
+          <a:noFill xmlns:a="http://schemas.openxmlformats.org/drawingml/2006/main"/>
+          <a:ln xmlns:a="http://schemas.openxmlformats.org/drawingml/2006/main" w="0">
+            <a:noFill/>
+            <a:prstDash val="solid"/>
+          </a:ln>
+        </p:spPr>
+        <p:txBody>
+          <a:bodyPr xmlns:a="http://schemas.openxmlformats.org/drawingml/2006/main" lIns="0" tIns="0" rIns="0" bIns="0" anchor="t">
+            <a:normAutofit fontScale="100000"/>
+          </a:bodyPr>
+          <a:lstStyle xmlns:a="http://schemas.openxmlformats.org/drawingml/2006/main"/>
+          <a:p xmlns:a="http://schemas.openxmlformats.org/drawingml/2006/main">
+            <a:pPr algn="l">
+              <a:lnSpc>
+                <a:spcPct val="108000"/>
+              </a:lnSpc>
+              <a:buNone/>
+              <a:defRPr sz="863" b="0" i="0">
+                <a:solidFill>
+                  <a:srgbClr val="475569"/>
+                </a:solidFill>
+                <a:latin typeface="PingFang SC"/>
+                <a:ea typeface="PingFang SC"/>
+                <a:cs typeface="PingFang SC"/>
+              </a:defRPr>
+            </a:pPr>
+            <a:r>
+              <a:rPr sz="863" b="0" i="0">
+                <a:solidFill>
+                  <a:srgbClr val="475569"/>
+                </a:solidFill>
+                <a:latin typeface="PingFang SC"/>
+                <a:ea typeface="PingFang SC"/>
+                <a:cs typeface="PingFang SC"/>
+              </a:rPr>
+              <a:t>Interpretation guide for the real GSE278603 quick run.</a:t>
+            </a:r>
+          </a:p>
+        </p:txBody>
+      </p:sp>
+      <p:sp>
+        <p:nvSpPr>
+          <p:cNvPr id="12" name="">
+            <a:extLst xmlns:a="http://schemas.openxmlformats.org/drawingml/2006/main">
+              <a:ext uri="{FF2B5EF4-FFF2-40B4-BE49-F238E27FC236}">
+                <a16:creationId xmlns:a16="http://schemas.microsoft.com/office/drawing/2014/main" id="{1EE57992-2202-49DE-94A1-9F4BD33E9203}"/>
+              </a:ext>
+            </a:extLst>
+          </p:cNvPr>
+          <p:cNvSpPr>
+            <a:spLocks xmlns:a="http://schemas.openxmlformats.org/drawingml/2006/main" noGrp="1"/>
+          </p:cNvSpPr>
+          <p:nvPr/>
+        </p:nvSpPr>
+        <p:spPr>
+          <a:xfrm xmlns:a="http://schemas.openxmlformats.org/drawingml/2006/main">
+            <a:off x="11125200" y="6515100"/>
+            <a:ext cx="457200" cy="190500"/>
+          </a:xfrm>
+          <a:prstGeom xmlns:a="http://schemas.openxmlformats.org/drawingml/2006/main" prst="rect">
+            <a:avLst/>
+          </a:prstGeom>
+          <a:noFill xmlns:a="http://schemas.openxmlformats.org/drawingml/2006/main"/>
+          <a:ln xmlns:a="http://schemas.openxmlformats.org/drawingml/2006/main" w="0">
+            <a:noFill/>
+            <a:prstDash val="solid"/>
+          </a:ln>
+        </p:spPr>
+        <p:txBody>
+          <a:bodyPr xmlns:a="http://schemas.openxmlformats.org/drawingml/2006/main" lIns="0" tIns="0" rIns="0" bIns="0" anchor="t">
+            <a:normAutofit fontScale="100000"/>
+          </a:bodyPr>
+          <a:lstStyle xmlns:a="http://schemas.openxmlformats.org/drawingml/2006/main"/>
+          <a:p xmlns:a="http://schemas.openxmlformats.org/drawingml/2006/main">
+            <a:pPr algn="r">
+              <a:lnSpc>
+                <a:spcPct val="108000"/>
+              </a:lnSpc>
+              <a:buNone/>
+              <a:defRPr sz="1013" b="1" i="0">
+                <a:solidFill>
+                  <a:srgbClr val="0F766E"/>
+                </a:solidFill>
+                <a:latin typeface="PingFang SC"/>
+                <a:ea typeface="PingFang SC"/>
+                <a:cs typeface="PingFang SC"/>
+              </a:defRPr>
+            </a:pPr>
+            <a:r>
+              <a:rPr sz="1013" b="1" i="0">
+                <a:solidFill>
+                  <a:srgbClr val="0F766E"/>
+                </a:solidFill>
+                <a:latin typeface="PingFang SC"/>
+                <a:ea typeface="PingFang SC"/>
+                <a:cs typeface="PingFang SC"/>
+              </a:rPr>
+              <a:t>15</a:t>
+            </a:r>
+          </a:p>
+        </p:txBody>
+      </p:sp>
+    </p:spTree>
+    <p:extLst>
+      <p:ext uri="{BB962C8B-B14F-4D97-AF65-F5344CB8AC3E}">
+        <p14:creationId xmlns:p14="http://schemas.microsoft.com/office/powerpoint/2010/main" val="1490332863"/>
+      </p:ext>
+    </p:extLst>
+  </p:cSld>
+</p:sld>
+</file>
+
+<file path=ppt/slides/slide16.xml><?xml version="1.0" encoding="utf-8"?>
+<p:sld xmlns:p="http://schemas.openxmlformats.org/presentationml/2006/main">
+  <p:cSld>
+    <p:bg>
+      <p:bgPr>
+        <a:solidFill xmlns:a="http://schemas.openxmlformats.org/drawingml/2006/main">
+          <a:srgbClr val="FFFFFF"/>
+        </a:solidFill>
+      </p:bgPr>
+    </p:bg>
+    <p:spTree>
+      <p:nvGrpSpPr>
+        <p:cNvPr id="1" name=""/>
+        <p:cNvGrpSpPr/>
+        <p:nvPr/>
+      </p:nvGrpSpPr>
+      <p:grpSpPr>
+        <a:xfrm xmlns:a="http://schemas.openxmlformats.org/drawingml/2006/main"/>
+      </p:grpSpPr>
+      <p:sp>
+        <p:nvSpPr>
+          <p:cNvPr id="1" name="">
+            <a:extLst xmlns:a="http://schemas.openxmlformats.org/drawingml/2006/main">
+              <a:ext uri="{FF2B5EF4-FFF2-40B4-BE49-F238E27FC236}">
+                <a16:creationId xmlns:a16="http://schemas.microsoft.com/office/drawing/2014/main" id="{F08CDAF8-8E38-4D7F-96E6-F673D4259727}"/>
+              </a:ext>
+            </a:extLst>
+          </p:cNvPr>
+          <p:cNvSpPr>
+            <a:spLocks xmlns:a="http://schemas.openxmlformats.org/drawingml/2006/main" noGrp="1"/>
+          </p:cNvSpPr>
+          <p:nvPr/>
+        </p:nvSpPr>
+        <p:spPr>
+          <a:xfrm xmlns:a="http://schemas.openxmlformats.org/drawingml/2006/main">
+            <a:off x="609600" y="304800"/>
+            <a:ext cx="4953000" cy="209550"/>
+          </a:xfrm>
+          <a:prstGeom xmlns:a="http://schemas.openxmlformats.org/drawingml/2006/main" prst="rect">
+            <a:avLst/>
+          </a:prstGeom>
+          <a:noFill xmlns:a="http://schemas.openxmlformats.org/drawingml/2006/main"/>
+          <a:ln xmlns:a="http://schemas.openxmlformats.org/drawingml/2006/main" w="0">
+            <a:noFill/>
+            <a:prstDash val="solid"/>
+          </a:ln>
+        </p:spPr>
+        <p:txBody>
+          <a:bodyPr xmlns:a="http://schemas.openxmlformats.org/drawingml/2006/main" lIns="0" tIns="0" rIns="0" bIns="0" anchor="t">
+            <a:normAutofit fontScale="100000"/>
+          </a:bodyPr>
+          <a:lstStyle xmlns:a="http://schemas.openxmlformats.org/drawingml/2006/main"/>
+          <a:p xmlns:a="http://schemas.openxmlformats.org/drawingml/2006/main">
+            <a:pPr algn="l">
+              <a:lnSpc>
+                <a:spcPct val="108000"/>
+              </a:lnSpc>
+              <a:buNone/>
+              <a:defRPr sz="1013" b="1" i="0">
+                <a:solidFill>
+                  <a:srgbClr val="0F766E"/>
+                </a:solidFill>
+                <a:latin typeface="PingFang SC"/>
+                <a:ea typeface="PingFang SC"/>
+                <a:cs typeface="PingFang SC"/>
+              </a:defRPr>
+            </a:pPr>
+            <a:r>
+              <a:rPr sz="1013" b="1" i="0">
+                <a:solidFill>
+                  <a:srgbClr val="0F766E"/>
+                </a:solidFill>
+                <a:latin typeface="PingFang SC"/>
+                <a:ea typeface="PingFang SC"/>
+                <a:cs typeface="PingFang SC"/>
+              </a:rPr>
+              <a:t>RESEARCH USE CASES</a:t>
+            </a:r>
+          </a:p>
+        </p:txBody>
+      </p:sp>
+      <p:sp>
+        <p:nvSpPr>
+          <p:cNvPr id="2" name="">
+            <a:extLst xmlns:a="http://schemas.openxmlformats.org/drawingml/2006/main">
+              <a:ext uri="{FF2B5EF4-FFF2-40B4-BE49-F238E27FC236}">
+                <a16:creationId xmlns:a16="http://schemas.microsoft.com/office/drawing/2014/main" id="{BF8685D2-BFB7-4D4C-B334-1787B177A528}"/>
+              </a:ext>
+            </a:extLst>
+          </p:cNvPr>
+          <p:cNvSpPr>
+            <a:spLocks xmlns:a="http://schemas.openxmlformats.org/drawingml/2006/main" noGrp="1"/>
+          </p:cNvSpPr>
+          <p:nvPr/>
+        </p:nvSpPr>
+        <p:spPr>
+          <a:xfrm xmlns:a="http://schemas.openxmlformats.org/drawingml/2006/main">
+            <a:off x="609600" y="552450"/>
+            <a:ext cx="9334500" cy="552450"/>
+          </a:xfrm>
+          <a:prstGeom xmlns:a="http://schemas.openxmlformats.org/drawingml/2006/main" prst="rect">
+            <a:avLst/>
+          </a:prstGeom>
+          <a:noFill xmlns:a="http://schemas.openxmlformats.org/drawingml/2006/main"/>
+          <a:ln xmlns:a="http://schemas.openxmlformats.org/drawingml/2006/main" w="0">
+            <a:noFill/>
+            <a:prstDash val="solid"/>
+          </a:ln>
+        </p:spPr>
+        <p:txBody>
+          <a:bodyPr xmlns:a="http://schemas.openxmlformats.org/drawingml/2006/main" lIns="0" tIns="0" rIns="0" bIns="0" anchor="t">
+            <a:normAutofit fontScale="100000"/>
+          </a:bodyPr>
+          <a:lstStyle xmlns:a="http://schemas.openxmlformats.org/drawingml/2006/main"/>
+          <a:p xmlns:a="http://schemas.openxmlformats.org/drawingml/2006/main">
+            <a:pPr algn="l">
+              <a:lnSpc>
+                <a:spcPct val="108000"/>
+              </a:lnSpc>
+              <a:buNone/>
+              <a:defRPr sz="3000" b="1" i="0">
+                <a:solidFill>
+                  <a:srgbClr val="17212B"/>
+                </a:solidFill>
+                <a:latin typeface="PingFang SC"/>
+                <a:ea typeface="PingFang SC"/>
+                <a:cs typeface="PingFang SC"/>
+              </a:defRPr>
+            </a:pPr>
+            <a:r>
+              <a:rPr sz="3000" b="1" i="0">
+                <a:solidFill>
+                  <a:srgbClr val="17212B"/>
+                </a:solidFill>
+                <a:latin typeface="PingFang SC"/>
+                <a:ea typeface="PingFang SC"/>
+                <a:cs typeface="PingFang SC"/>
+              </a:rPr>
+              <a:t>面向真实科研场景的应用</a:t>
+            </a:r>
+          </a:p>
+        </p:txBody>
+      </p:sp>
+      <p:sp>
+        <p:nvSpPr>
+          <p:cNvPr id="3" name="">
+            <a:extLst xmlns:a="http://schemas.openxmlformats.org/drawingml/2006/main">
+              <a:ext uri="{FF2B5EF4-FFF2-40B4-BE49-F238E27FC236}">
+                <a16:creationId xmlns:a16="http://schemas.microsoft.com/office/drawing/2014/main" id="{816CF460-0C5D-41C2-B427-5231798E33EE}"/>
+              </a:ext>
+            </a:extLst>
+          </p:cNvPr>
+          <p:cNvSpPr>
+            <a:spLocks xmlns:a="http://schemas.openxmlformats.org/drawingml/2006/main" noGrp="1"/>
+          </p:cNvSpPr>
+          <p:nvPr/>
+        </p:nvSpPr>
+        <p:spPr>
+          <a:xfrm xmlns:a="http://schemas.openxmlformats.org/drawingml/2006/main">
+            <a:off x="819150" y="1581150"/>
+            <a:ext cx="2476500" cy="1390650"/>
+          </a:xfrm>
+          <a:prstGeom xmlns:a="http://schemas.openxmlformats.org/drawingml/2006/main" prst="roundRect">
+            <a:avLst>
+              <a:gd name="adj" fmla="val 8219"/>
+            </a:avLst>
+          </a:prstGeom>
+          <a:solidFill xmlns:a="http://schemas.openxmlformats.org/drawingml/2006/main">
+            <a:srgbClr val="E9F5F2"/>
+          </a:solidFill>
+          <a:ln xmlns:a="http://schemas.openxmlformats.org/drawingml/2006/main" w="9525">
+            <a:solidFill>
+              <a:srgbClr val="D7E4E0"/>
+            </a:solidFill>
+            <a:prstDash val="solid"/>
+          </a:ln>
+        </p:spPr>
+        <p:style>
+          <a:lnRef xmlns:a="http://schemas.openxmlformats.org/drawingml/2006/main" idx="0"/>
+          <a:fillRef xmlns:a="http://schemas.openxmlformats.org/drawingml/2006/main" idx="0"/>
+          <a:effectRef xmlns:a="http://schemas.openxmlformats.org/drawingml/2006/main" idx="4"/>
+          <a:fontRef xmlns:a="http://schemas.openxmlformats.org/drawingml/2006/main" idx="major"/>
+        </p:style>
+      </p:sp>
+      <p:sp>
+        <p:nvSpPr>
+          <p:cNvPr id="4" name="">
+            <a:extLst xmlns:a="http://schemas.openxmlformats.org/drawingml/2006/main">
+              <a:ext uri="{FF2B5EF4-FFF2-40B4-BE49-F238E27FC236}">
+                <a16:creationId xmlns:a16="http://schemas.microsoft.com/office/drawing/2014/main" id="{2C6DB7D3-B959-4592-B562-E53DE718C99E}"/>
+              </a:ext>
+            </a:extLst>
+          </p:cNvPr>
+          <p:cNvSpPr>
+            <a:spLocks xmlns:a="http://schemas.openxmlformats.org/drawingml/2006/main" noGrp="1"/>
+          </p:cNvSpPr>
+          <p:nvPr/>
+        </p:nvSpPr>
+        <p:spPr>
+          <a:xfrm xmlns:a="http://schemas.openxmlformats.org/drawingml/2006/main">
+            <a:off x="1009650" y="1752600"/>
+            <a:ext cx="2095500" cy="285750"/>
+          </a:xfrm>
+          <a:prstGeom xmlns:a="http://schemas.openxmlformats.org/drawingml/2006/main" prst="rect">
+            <a:avLst/>
+          </a:prstGeom>
+          <a:noFill xmlns:a="http://schemas.openxmlformats.org/drawingml/2006/main"/>
+          <a:ln xmlns:a="http://schemas.openxmlformats.org/drawingml/2006/main" w="0">
+            <a:noFill/>
+            <a:prstDash val="solid"/>
+          </a:ln>
+        </p:spPr>
+        <p:txBody>
+          <a:bodyPr xmlns:a="http://schemas.openxmlformats.org/drawingml/2006/main" lIns="0" tIns="0" rIns="0" bIns="0" anchor="t">
+            <a:normAutofit fontScale="100000"/>
+          </a:bodyPr>
+          <a:lstStyle xmlns:a="http://schemas.openxmlformats.org/drawingml/2006/main"/>
+          <a:p xmlns:a="http://schemas.openxmlformats.org/drawingml/2006/main">
+            <a:pPr algn="l">
+              <a:lnSpc>
+                <a:spcPct val="108000"/>
+              </a:lnSpc>
+              <a:buNone/>
+              <a:defRPr sz="1575" b="1" i="0">
+                <a:solidFill>
+                  <a:srgbClr val="0F766E"/>
+                </a:solidFill>
+                <a:latin typeface="PingFang SC"/>
+                <a:ea typeface="PingFang SC"/>
+                <a:cs typeface="PingFang SC"/>
+              </a:defRPr>
+            </a:pPr>
+            <a:r>
+              <a:rPr sz="1575" b="1" i="0">
+                <a:solidFill>
+                  <a:srgbClr val="0F766E"/>
+                </a:solidFill>
+                <a:latin typeface="PingFang SC"/>
+                <a:ea typeface="PingFang SC"/>
+                <a:cs typeface="PingFang SC"/>
+              </a:rPr>
               <a:t>发育生物学</a:t>
             </a:r>
           </a:p>
@@ -12494,7 +13356,7 @@
                 <a:ea typeface="PingFang SC"/>
                 <a:cs typeface="PingFang SC"/>
               </a:rPr>
-              <a:t>15</a:t>
+              <a:t>16</a:t>
             </a:r>
           </a:p>
         </p:txBody>
@@ -12509,7 +13371,7 @@
 </p:sld>
 </file>
 
-<file path=ppt/slides/slide16.xml><?xml version="1.0" encoding="utf-8"?>
+<file path=ppt/slides/slide17.xml><?xml version="1.0" encoding="utf-8"?>
 <p:sld xmlns:p="http://schemas.openxmlformats.org/presentationml/2006/main">
   <p:cSld>
     <p:bg>
@@ -12530,14 +13392,14 @@
       </p:grpSpPr>
       <p:pic>
         <p:nvPicPr>
-          <p:cNvPr id="16" name=""/>
+          <p:cNvPr id="17" name=""/>
           <p:cNvPicPr>
             <a:picLocks xmlns:a="http://schemas.openxmlformats.org/drawingml/2006/main" noChangeAspect="1"/>
           </p:cNvPicPr>
           <p:nvPr/>
         </p:nvPicPr>
         <p:blipFill>
-          <a:blip xmlns:r="http://schemas.openxmlformats.org/officeDocument/2006/relationships" xmlns:a="http://schemas.openxmlformats.org/drawingml/2006/main" r:embed="R78ad7b07f8ca4521"/>
+          <a:blip xmlns:r="http://schemas.openxmlformats.org/officeDocument/2006/relationships" xmlns:a="http://schemas.openxmlformats.org/drawingml/2006/main" r:embed="R7c611a598e7c4227"/>
           <a:stretch xmlns:a="http://schemas.openxmlformats.org/drawingml/2006/main"/>
         </p:blipFill>
         <p:spPr>
@@ -12546,9 +13408,7 @@
             <a:ext cx="666750" cy="666750"/>
           </a:xfrm>
           <a:prstGeom xmlns:a="http://schemas.openxmlformats.org/drawingml/2006/main" prst="roundRect">
-            <a:avLst>
-              <a:gd name="adj" fmla="val 11429"/>
-            </a:avLst>
+            <a:avLst/>
           </a:prstGeom>
         </p:spPr>
       </p:pic>
@@ -13281,7 +14141,7 @@
                 <a:ea typeface="PingFang SC"/>
                 <a:cs typeface="PingFang SC"/>
               </a:rPr>
-              <a:t>16</a:t>
+              <a:t>17</a:t>
             </a:r>
           </a:p>
         </p:txBody>
@@ -27230,6 +28090,7 @@
           <a:lstStyle xmlns:a="http://schemas.openxmlformats.org/drawingml/2006/main"/>
           <a:p xmlns:a="http://schemas.openxmlformats.org/drawingml/2006/main">
             <a:pPr algn="ctr">
+              <a:buNone/>
               <a:defRPr sz="1500" b="1">
                 <a:solidFill>
                   <a:srgbClr val="FFFFFF"/>
@@ -27292,6 +28153,7 @@
           <a:lstStyle xmlns:a="http://schemas.openxmlformats.org/drawingml/2006/main"/>
           <a:p xmlns:a="http://schemas.openxmlformats.org/drawingml/2006/main">
             <a:pPr algn="ctr">
+              <a:buNone/>
               <a:defRPr sz="1500" b="1">
                 <a:solidFill>
                   <a:srgbClr val="FFFFFF"/>
@@ -27354,6 +28216,7 @@
           <a:lstStyle xmlns:a="http://schemas.openxmlformats.org/drawingml/2006/main"/>
           <a:p xmlns:a="http://schemas.openxmlformats.org/drawingml/2006/main">
             <a:pPr algn="ctr">
+              <a:buNone/>
               <a:defRPr sz="1500" b="1">
                 <a:solidFill>
                   <a:srgbClr val="FFFFFF"/>
@@ -27416,6 +28279,7 @@
           <a:lstStyle xmlns:a="http://schemas.openxmlformats.org/drawingml/2006/main"/>
           <a:p xmlns:a="http://schemas.openxmlformats.org/drawingml/2006/main">
             <a:pPr algn="ctr">
+              <a:buNone/>
               <a:defRPr sz="1500" b="1">
                 <a:solidFill>
                   <a:srgbClr val="FFFFFF"/>
@@ -27478,6 +28342,7 @@
           <a:lstStyle xmlns:a="http://schemas.openxmlformats.org/drawingml/2006/main"/>
           <a:p xmlns:a="http://schemas.openxmlformats.org/drawingml/2006/main">
             <a:pPr algn="ctr">
+              <a:buNone/>
               <a:defRPr sz="1575" b="1">
                 <a:solidFill>
                   <a:srgbClr val="0B4F49"/>
@@ -27540,6 +28405,7 @@
           <a:lstStyle xmlns:a="http://schemas.openxmlformats.org/drawingml/2006/main"/>
           <a:p xmlns:a="http://schemas.openxmlformats.org/drawingml/2006/main">
             <a:pPr algn="ctr">
+              <a:buNone/>
               <a:defRPr sz="1463" b="0">
                 <a:solidFill>
                   <a:srgbClr val="17212B"/>
@@ -27602,6 +28468,7 @@
           <a:lstStyle xmlns:a="http://schemas.openxmlformats.org/drawingml/2006/main"/>
           <a:p xmlns:a="http://schemas.openxmlformats.org/drawingml/2006/main">
             <a:pPr algn="ctr">
+              <a:buNone/>
               <a:defRPr sz="1463" b="0">
                 <a:solidFill>
                   <a:srgbClr val="17212B"/>
@@ -27664,6 +28531,7 @@
           <a:lstStyle xmlns:a="http://schemas.openxmlformats.org/drawingml/2006/main"/>
           <a:p xmlns:a="http://schemas.openxmlformats.org/drawingml/2006/main">
             <a:pPr algn="ctr">
+              <a:buNone/>
               <a:defRPr sz="1463" b="0">
                 <a:solidFill>
                   <a:srgbClr val="17212B"/>
@@ -27726,6 +28594,7 @@
           <a:lstStyle xmlns:a="http://schemas.openxmlformats.org/drawingml/2006/main"/>
           <a:p xmlns:a="http://schemas.openxmlformats.org/drawingml/2006/main">
             <a:pPr algn="ctr">
+              <a:buNone/>
               <a:defRPr sz="1575" b="1">
                 <a:solidFill>
                   <a:srgbClr val="0B4F49"/>
@@ -27788,6 +28657,7 @@
           <a:lstStyle xmlns:a="http://schemas.openxmlformats.org/drawingml/2006/main"/>
           <a:p xmlns:a="http://schemas.openxmlformats.org/drawingml/2006/main">
             <a:pPr algn="ctr">
+              <a:buNone/>
               <a:defRPr sz="1463" b="0">
                 <a:solidFill>
                   <a:srgbClr val="17212B"/>
@@ -27850,6 +28720,7 @@
           <a:lstStyle xmlns:a="http://schemas.openxmlformats.org/drawingml/2006/main"/>
           <a:p xmlns:a="http://schemas.openxmlformats.org/drawingml/2006/main">
             <a:pPr algn="ctr">
+              <a:buNone/>
               <a:defRPr sz="1463" b="0">
                 <a:solidFill>
                   <a:srgbClr val="17212B"/>
@@ -27912,6 +28783,7 @@
           <a:lstStyle xmlns:a="http://schemas.openxmlformats.org/drawingml/2006/main"/>
           <a:p xmlns:a="http://schemas.openxmlformats.org/drawingml/2006/main">
             <a:pPr algn="ctr">
+              <a:buNone/>
               <a:defRPr sz="1463" b="0">
                 <a:solidFill>
                   <a:srgbClr val="17212B"/>
@@ -27974,6 +28846,7 @@
           <a:lstStyle xmlns:a="http://schemas.openxmlformats.org/drawingml/2006/main"/>
           <a:p xmlns:a="http://schemas.openxmlformats.org/drawingml/2006/main">
             <a:pPr algn="ctr">
+              <a:buNone/>
               <a:defRPr sz="1575" b="1">
                 <a:solidFill>
                   <a:srgbClr val="0B4F49"/>
@@ -28036,6 +28909,7 @@
           <a:lstStyle xmlns:a="http://schemas.openxmlformats.org/drawingml/2006/main"/>
           <a:p xmlns:a="http://schemas.openxmlformats.org/drawingml/2006/main">
             <a:pPr algn="ctr">
+              <a:buNone/>
               <a:defRPr sz="1463" b="0">
                 <a:solidFill>
                   <a:srgbClr val="17212B"/>
@@ -28098,6 +28972,7 @@
           <a:lstStyle xmlns:a="http://schemas.openxmlformats.org/drawingml/2006/main"/>
           <a:p xmlns:a="http://schemas.openxmlformats.org/drawingml/2006/main">
             <a:pPr algn="ctr">
+              <a:buNone/>
               <a:defRPr sz="1463" b="0">
                 <a:solidFill>
                   <a:srgbClr val="17212B"/>
@@ -28160,6 +29035,7 @@
           <a:lstStyle xmlns:a="http://schemas.openxmlformats.org/drawingml/2006/main"/>
           <a:p xmlns:a="http://schemas.openxmlformats.org/drawingml/2006/main">
             <a:pPr algn="ctr">
+              <a:buNone/>
               <a:defRPr sz="1463" b="0">
                 <a:solidFill>
                   <a:srgbClr val="17212B"/>
@@ -30767,14 +31643,14 @@
       </p:sp>
       <p:pic>
         <p:nvPicPr>
-          <p:cNvPr id="16" name=""/>
+          <p:cNvPr id="17" name=""/>
           <p:cNvPicPr>
             <a:picLocks xmlns:a="http://schemas.openxmlformats.org/drawingml/2006/main" noChangeAspect="1"/>
           </p:cNvPicPr>
           <p:nvPr/>
         </p:nvPicPr>
         <p:blipFill>
-          <a:blip xmlns:r="http://schemas.openxmlformats.org/officeDocument/2006/relationships" xmlns:a="http://schemas.openxmlformats.org/drawingml/2006/main" r:embed="Rabd1b0771aa94eab"/>
+          <a:blip xmlns:r="http://schemas.openxmlformats.org/officeDocument/2006/relationships" xmlns:a="http://schemas.openxmlformats.org/drawingml/2006/main" r:embed="Rb619f5382c524270"/>
           <a:stretch xmlns:a="http://schemas.openxmlformats.org/drawingml/2006/main"/>
         </p:blipFill>
         <p:spPr>
@@ -30783,9 +31659,7 @@
             <a:ext cx="4514850" cy="1509998"/>
           </a:xfrm>
           <a:prstGeom xmlns:a="http://schemas.openxmlformats.org/drawingml/2006/main" prst="roundRect">
-            <a:avLst>
-              <a:gd name="adj" fmla="val 3871"/>
-            </a:avLst>
+            <a:avLst/>
           </a:prstGeom>
         </p:spPr>
       </p:pic>
@@ -31626,14 +32500,14 @@
       </p:sp>
       <p:pic>
         <p:nvPicPr>
-          <p:cNvPr id="21" name=""/>
+          <p:cNvPr id="24" name=""/>
           <p:cNvPicPr>
             <a:picLocks xmlns:a="http://schemas.openxmlformats.org/drawingml/2006/main" noChangeAspect="1"/>
           </p:cNvPicPr>
           <p:nvPr/>
         </p:nvPicPr>
         <p:blipFill>
-          <a:blip xmlns:r="http://schemas.openxmlformats.org/officeDocument/2006/relationships" xmlns:a="http://schemas.openxmlformats.org/drawingml/2006/main" r:embed="R67935831f2134662"/>
+          <a:blip xmlns:r="http://schemas.openxmlformats.org/officeDocument/2006/relationships" xmlns:a="http://schemas.openxmlformats.org/drawingml/2006/main" r:embed="Rc1f1c9e3dec94c47"/>
           <a:stretch xmlns:a="http://schemas.openxmlformats.org/drawingml/2006/main"/>
         </p:blipFill>
         <p:spPr>
@@ -31642,22 +32516,20 @@
             <a:ext cx="3143250" cy="1944174"/>
           </a:xfrm>
           <a:prstGeom xmlns:a="http://schemas.openxmlformats.org/drawingml/2006/main" prst="roundRect">
-            <a:avLst>
-              <a:gd name="adj" fmla="val 4800"/>
-            </a:avLst>
+            <a:avLst/>
           </a:prstGeom>
         </p:spPr>
       </p:pic>
       <p:pic>
         <p:nvPicPr>
-          <p:cNvPr id="22" name=""/>
+          <p:cNvPr id="25" name=""/>
           <p:cNvPicPr>
             <a:picLocks xmlns:a="http://schemas.openxmlformats.org/drawingml/2006/main" noChangeAspect="1"/>
           </p:cNvPicPr>
           <p:nvPr/>
         </p:nvPicPr>
         <p:blipFill>
-          <a:blip xmlns:r="http://schemas.openxmlformats.org/officeDocument/2006/relationships" xmlns:a="http://schemas.openxmlformats.org/drawingml/2006/main" r:embed="Rc7156383ede94c4e"/>
+          <a:blip xmlns:r="http://schemas.openxmlformats.org/officeDocument/2006/relationships" xmlns:a="http://schemas.openxmlformats.org/drawingml/2006/main" r:embed="Rf246755a37cd439e"/>
           <a:stretch xmlns:a="http://schemas.openxmlformats.org/drawingml/2006/main"/>
         </p:blipFill>
         <p:spPr>
@@ -31666,22 +32538,20 @@
             <a:ext cx="3143250" cy="1794810"/>
           </a:xfrm>
           <a:prstGeom xmlns:a="http://schemas.openxmlformats.org/drawingml/2006/main" prst="roundRect">
-            <a:avLst>
-              <a:gd name="adj" fmla="val 4800"/>
-            </a:avLst>
+            <a:avLst/>
           </a:prstGeom>
         </p:spPr>
       </p:pic>
       <p:pic>
         <p:nvPicPr>
-          <p:cNvPr id="23" name=""/>
+          <p:cNvPr id="26" name=""/>
           <p:cNvPicPr>
             <a:picLocks xmlns:a="http://schemas.openxmlformats.org/drawingml/2006/main" noChangeAspect="1"/>
           </p:cNvPicPr>
           <p:nvPr/>
         </p:nvPicPr>
         <p:blipFill>
-          <a:blip xmlns:r="http://schemas.openxmlformats.org/officeDocument/2006/relationships" xmlns:a="http://schemas.openxmlformats.org/drawingml/2006/main" r:embed="Rce9abd914f7f47d8"/>
+          <a:blip xmlns:r="http://schemas.openxmlformats.org/officeDocument/2006/relationships" xmlns:a="http://schemas.openxmlformats.org/drawingml/2006/main" r:embed="R548cc2614cfe4219"/>
           <a:stretch xmlns:a="http://schemas.openxmlformats.org/drawingml/2006/main"/>
         </p:blipFill>
         <p:spPr>
@@ -31690,9 +32560,7 @@
             <a:ext cx="3143250" cy="2078032"/>
           </a:xfrm>
           <a:prstGeom xmlns:a="http://schemas.openxmlformats.org/drawingml/2006/main" prst="roundRect">
-            <a:avLst>
-              <a:gd name="adj" fmla="val 4800"/>
-            </a:avLst>
+            <a:avLst/>
           </a:prstGeom>
         </p:spPr>
       </p:pic>
@@ -32845,6 +33713,7 @@
           <a:lstStyle xmlns:a="http://schemas.openxmlformats.org/drawingml/2006/main"/>
           <a:p xmlns:a="http://schemas.openxmlformats.org/drawingml/2006/main">
             <a:pPr algn="ctr">
+              <a:buNone/>
               <a:defRPr sz="938" b="1">
                 <a:solidFill>
                   <a:srgbClr val="FFFFFF"/>
@@ -33010,6 +33879,7 @@
           <a:lstStyle xmlns:a="http://schemas.openxmlformats.org/drawingml/2006/main"/>
           <a:p xmlns:a="http://schemas.openxmlformats.org/drawingml/2006/main">
             <a:pPr algn="ctr">
+              <a:buNone/>
               <a:defRPr sz="938" b="1">
                 <a:solidFill>
                   <a:srgbClr val="FFFFFF"/>
@@ -33175,6 +34045,7 @@
           <a:lstStyle xmlns:a="http://schemas.openxmlformats.org/drawingml/2006/main"/>
           <a:p xmlns:a="http://schemas.openxmlformats.org/drawingml/2006/main">
             <a:pPr algn="ctr">
+              <a:buNone/>
               <a:defRPr sz="938" b="1">
                 <a:solidFill>
                   <a:srgbClr val="FFFFFF"/>
@@ -33340,6 +34211,7 @@
           <a:lstStyle xmlns:a="http://schemas.openxmlformats.org/drawingml/2006/main"/>
           <a:p xmlns:a="http://schemas.openxmlformats.org/drawingml/2006/main">
             <a:pPr algn="ctr">
+              <a:buNone/>
               <a:defRPr sz="938" b="1">
                 <a:solidFill>
                   <a:srgbClr val="FFFFFF"/>
@@ -33505,6 +34377,7 @@
           <a:lstStyle xmlns:a="http://schemas.openxmlformats.org/drawingml/2006/main"/>
           <a:p xmlns:a="http://schemas.openxmlformats.org/drawingml/2006/main">
             <a:pPr algn="ctr">
+              <a:buNone/>
               <a:defRPr sz="938" b="1">
                 <a:solidFill>
                   <a:srgbClr val="FFFFFF"/>

</xml_diff>

<commit_message>
Focus real data validation slide
</commit_message>
<xml_diff>
--- a/reports/SpatialScope_Agent_Presentation.pptx
+++ b/reports/SpatialScope_Agent_Presentation.pptx
@@ -2,29 +2,28 @@
 <file path=ppt/presentation.xml><?xml version="1.0" encoding="utf-8"?>
 <p:presentation xmlns:p="http://schemas.openxmlformats.org/presentationml/2006/main">
   <p:sldMasterIdLst>
-    <p:sldMasterId xmlns:r="http://schemas.openxmlformats.org/officeDocument/2006/relationships" id="2147483648" r:id="Re4ad2b4681694137"/>
+    <p:sldMasterId xmlns:r="http://schemas.openxmlformats.org/officeDocument/2006/relationships" id="2147483648" r:id="R5bb8db4d8151479b"/>
   </p:sldMasterIdLst>
   <p:notesMasterIdLst>
-    <p:notesMasterId xmlns:r="http://schemas.openxmlformats.org/officeDocument/2006/relationships" r:id="Rbc2448d429a34edc"/>
+    <p:notesMasterId xmlns:r="http://schemas.openxmlformats.org/officeDocument/2006/relationships" r:id="R6da5f6d4c73e4e16"/>
   </p:notesMasterIdLst>
   <p:sldIdLst>
-    <p:sldId xmlns:r="http://schemas.openxmlformats.org/officeDocument/2006/relationships" id="256" r:id="Rcdeca84b5720436d"/>
-    <p:sldId xmlns:r="http://schemas.openxmlformats.org/officeDocument/2006/relationships" id="257" r:id="R28c1b823b007410d"/>
-    <p:sldId xmlns:r="http://schemas.openxmlformats.org/officeDocument/2006/relationships" id="258" r:id="R812b6ac2edb44cb4"/>
-    <p:sldId xmlns:r="http://schemas.openxmlformats.org/officeDocument/2006/relationships" id="259" r:id="Re0e8d660b57b4ac3"/>
-    <p:sldId xmlns:r="http://schemas.openxmlformats.org/officeDocument/2006/relationships" id="260" r:id="Re56bd8a5b0c04105"/>
-    <p:sldId xmlns:r="http://schemas.openxmlformats.org/officeDocument/2006/relationships" id="261" r:id="R52946f1bdcc64747"/>
-    <p:sldId xmlns:r="http://schemas.openxmlformats.org/officeDocument/2006/relationships" id="262" r:id="Rca3c435ebe814530"/>
-    <p:sldId xmlns:r="http://schemas.openxmlformats.org/officeDocument/2006/relationships" id="263" r:id="R02f18b55c16342db"/>
-    <p:sldId xmlns:r="http://schemas.openxmlformats.org/officeDocument/2006/relationships" id="264" r:id="Raef0f1cc6cc54ce1"/>
-    <p:sldId xmlns:r="http://schemas.openxmlformats.org/officeDocument/2006/relationships" id="265" r:id="R94355af0c66c4a47"/>
-    <p:sldId xmlns:r="http://schemas.openxmlformats.org/officeDocument/2006/relationships" id="266" r:id="Rb5b0eaec034b4fa3"/>
-    <p:sldId xmlns:r="http://schemas.openxmlformats.org/officeDocument/2006/relationships" id="267" r:id="R2177448b66354878"/>
-    <p:sldId xmlns:r="http://schemas.openxmlformats.org/officeDocument/2006/relationships" id="268" r:id="Refcd5c90cd074c41"/>
-    <p:sldId xmlns:r="http://schemas.openxmlformats.org/officeDocument/2006/relationships" id="269" r:id="R060d170c2ae44e37"/>
-    <p:sldId xmlns:r="http://schemas.openxmlformats.org/officeDocument/2006/relationships" id="270" r:id="R7e13d774c5ae4f44"/>
-    <p:sldId xmlns:r="http://schemas.openxmlformats.org/officeDocument/2006/relationships" id="271" r:id="R48a4849e96064510"/>
-    <p:sldId xmlns:r="http://schemas.openxmlformats.org/officeDocument/2006/relationships" id="272" r:id="R88763f969bb746da"/>
+    <p:sldId xmlns:r="http://schemas.openxmlformats.org/officeDocument/2006/relationships" id="256" r:id="R59a7aa19e5874be2"/>
+    <p:sldId xmlns:r="http://schemas.openxmlformats.org/officeDocument/2006/relationships" id="257" r:id="R6ca8893ca1234547"/>
+    <p:sldId xmlns:r="http://schemas.openxmlformats.org/officeDocument/2006/relationships" id="258" r:id="Re0887018bb5e41d9"/>
+    <p:sldId xmlns:r="http://schemas.openxmlformats.org/officeDocument/2006/relationships" id="259" r:id="R3097437c90294386"/>
+    <p:sldId xmlns:r="http://schemas.openxmlformats.org/officeDocument/2006/relationships" id="260" r:id="R449d6de7b6504dd7"/>
+    <p:sldId xmlns:r="http://schemas.openxmlformats.org/officeDocument/2006/relationships" id="261" r:id="Re9c9bffb40994b3a"/>
+    <p:sldId xmlns:r="http://schemas.openxmlformats.org/officeDocument/2006/relationships" id="262" r:id="Re0d963fc4efc4c78"/>
+    <p:sldId xmlns:r="http://schemas.openxmlformats.org/officeDocument/2006/relationships" id="263" r:id="R916cbaeb62484ac5"/>
+    <p:sldId xmlns:r="http://schemas.openxmlformats.org/officeDocument/2006/relationships" id="264" r:id="R03c38d5d44354f24"/>
+    <p:sldId xmlns:r="http://schemas.openxmlformats.org/officeDocument/2006/relationships" id="265" r:id="Rad20951c931a4bb8"/>
+    <p:sldId xmlns:r="http://schemas.openxmlformats.org/officeDocument/2006/relationships" id="266" r:id="Ra4404fb9df0343a9"/>
+    <p:sldId xmlns:r="http://schemas.openxmlformats.org/officeDocument/2006/relationships" id="267" r:id="Rf3c1d67b91204280"/>
+    <p:sldId xmlns:r="http://schemas.openxmlformats.org/officeDocument/2006/relationships" id="268" r:id="Rf79ff2fb32d04c24"/>
+    <p:sldId xmlns:r="http://schemas.openxmlformats.org/officeDocument/2006/relationships" id="269" r:id="R5cf9b85c93f142c2"/>
+    <p:sldId xmlns:r="http://schemas.openxmlformats.org/officeDocument/2006/relationships" id="270" r:id="R4d601c3d946041bb"/>
+    <p:sldId xmlns:r="http://schemas.openxmlformats.org/officeDocument/2006/relationships" id="271" r:id="R34341111d24a47dc"/>
   </p:sldIdLst>
   <p:sldSz cx="12192000" cy="6858000"/>
   <p:notesSz cx="6858000" cy="9144000"/>
@@ -983,7 +982,7 @@
           <a:lstStyle xmlns:a="http://schemas.openxmlformats.org/drawingml/2006/main"/>
           <a:p xmlns:a="http://schemas.openxmlformats.org/drawingml/2006/main">
             <a:r>
-              <a:t>讲稿：这一页说明真实数据验证。前面网站演示用的是小型 demo，因为在线部署要稳定；但我没有只停留在 toy data。我下载了公开数据 GSE278603 中 E7.5 mouse embryo Stereo-seq 的一个样本。这个样本有 8190 个 spots 和 16364 个 genes，数据规模和字段复杂度都比 demo 更接近真实科研数据。</a:t>
+              <a:t>讲稿：这一页讲真实数据验证，不展开算法细节。前面网站演示用的是小型 demo，因为在线部署要稳定；但为了证明系统不只依赖 toy data，我又用公开真实数据 GSE278603 的 E7.5 mouse embryo Stereo-seq 样本做了本地验证。</a:t>
             </a:r>
           </a:p>
           <a:p xmlns:a="http://schemas.openxmlformats.org/drawingml/2006/main">
@@ -993,7 +992,7 @@
           </a:p>
           <a:p xmlns:a="http://schemas.openxmlformats.org/drawingml/2006/main">
             <a:r>
-              <a:t>讲图顺序：先指左侧数据卡。第一行是数据规模；第二行说明原数据里空间坐标叫 obsm["X_spatial"]，Agent 会把它标准化成常用的 obsm["spatial"]；第三行说明 quick run 仍然包含 QC、UMAP、Leiden 聚类和 gene panel；最后一行说明这次运行得到 7 个 clusters，并且没有 warnings 和 errors。</a:t>
+              <a:t>先看左侧数据卡。这个样本有 8190 个 spots 和 16364 个 genes，是真实的空间转录组 AnnData。原始文件里的空间坐标字段叫 X_spatial，系统可以把它标准化为常用的 spatial 字段，然后继续执行分析。</a:t>
             </a:r>
           </a:p>
           <a:p xmlns:a="http://schemas.openxmlformats.org/drawingml/2006/main">
@@ -1003,7 +1002,7 @@
           </a:p>
           <a:p xmlns:a="http://schemas.openxmlformats.org/drawingml/2006/main">
             <a:r>
-              <a:t>然后指右侧三类图。Spatial Leiden 是把聚类结果放回真实组织坐标；UMAP Leiden 是看表达状态是否能分开；gene panel 是看 Sox17、T、Mesp1、Pou5f1 这些发育相关基因是否有空间表达倾向。</a:t>
+              <a:t>再看右侧三类输出。左上是空间聚类图，把分析得到的分组放回真实组织坐标；右上是 UMAP 图，用来观察表达状态是否能形成结构；下面是基因表达面板，用 Sox17、T、Mesp1、Pou5f1 这些发育相关基因查看空间表达趋势。</a:t>
             </a:r>
           </a:p>
           <a:p xmlns:a="http://schemas.openxmlformats.org/drawingml/2006/main">
@@ -1013,7 +1012,7 @@
           </a:p>
           <a:p xmlns:a="http://schemas.openxmlformats.org/drawingml/2006/main">
             <a:r>
-              <a:t>重要边界：这里的目的不是给出完整生物学结论，而是证明系统可以处理真实 AnnData、真实坐标字段和真实表达层。完整生物学解释还需要更系统的 marker、组织学背景和专家注释。</a:t>
+              <a:t>这里我想强调的不是“发现了一个新的胚胎发育机制”，而是验证系统的工程和科研可用性：真实数据能读入，真实坐标能识别，标准流程能跑完，图表和报告能生成，而且 quick run 没有 warnings 和 errors。</a:t>
             </a:r>
           </a:p>
           <a:p xmlns:a="http://schemas.openxmlformats.org/drawingml/2006/main">
@@ -1023,7 +1022,17 @@
           </a:p>
           <a:p xmlns:a="http://schemas.openxmlformats.org/drawingml/2006/main">
             <a:r>
-              <a:t>过渡：下一页我解释 Leiden、UMAP 和 Spatial 这几张图具体应该怎么读。</a:t>
+              <a:t>边界也要说清楚：这只是 smoke validation。要做正式生物学结论，还需要更完整的参数调优、marker gene 证据、组织学背景和专家注释。</a:t>
+            </a:r>
+          </a:p>
+          <a:p xmlns:a="http://schemas.openxmlformats.org/drawingml/2006/main">
+            <a:r>
+              <a:t/>
+            </a:r>
+          </a:p>
+          <a:p xmlns:a="http://schemas.openxmlformats.org/drawingml/2006/main">
+            <a:r>
+              <a:t>过渡：真实数据验证说明系统有一定泛化能力。接下来说明它在真实科研场景中可以怎么用，以及它的边界在哪里。</a:t>
             </a:r>
           </a:p>
         </p:txBody>
@@ -1093,127 +1102,7 @@
           <a:lstStyle xmlns:a="http://schemas.openxmlformats.org/drawingml/2006/main"/>
           <a:p xmlns:a="http://schemas.openxmlformats.org/drawingml/2006/main">
             <a:r>
-              <a:t>讲稿：这一页是为了把真实数据图讲清楚。Leiden 是一种图聚类算法，可以简单理解为：先根据基因表达相似性把 spots 连接成邻居图，再把连接更紧密的 spots 分到同一个 cluster。它回答的是“哪些 spot 的整体表达模式相似”。</a:t>
-            </a:r>
-          </a:p>
-          <a:p xmlns:a="http://schemas.openxmlformats.org/drawingml/2006/main">
-            <a:r>
-              <a:t/>
-            </a:r>
-          </a:p>
-          <a:p xmlns:a="http://schemas.openxmlformats.org/drawingml/2006/main">
-            <a:r>
-              <a:t>这里一定要强调：Leiden cluster 不等于细胞类型。颜色 0 到 6 只是算法给出的分组编号，不是说 cluster 0 就一定是什么细胞。要把 cluster 解释成细胞类型，还需要 marker genes、参考文献和专家判断。</a:t>
-            </a:r>
-          </a:p>
-          <a:p xmlns:a="http://schemas.openxmlformats.org/drawingml/2006/main">
-            <a:r>
-              <a:t/>
-            </a:r>
-          </a:p>
-          <a:p xmlns:a="http://schemas.openxmlformats.org/drawingml/2006/main">
-            <a:r>
-              <a:t>UMAP 图不是组织地图，而是表达状态地图。两个点在 UMAP 上接近，表示它们的整体基因表达相似；离得远，表示表达差异更大。这个真实数据的 UMAP 分成几个比较清楚的区域，说明表达状态确实有结构。</a:t>
-            </a:r>
-          </a:p>
-          <a:p xmlns:a="http://schemas.openxmlformats.org/drawingml/2006/main">
-            <a:r>
-              <a:t/>
-            </a:r>
-          </a:p>
-          <a:p xmlns:a="http://schemas.openxmlformats.org/drawingml/2006/main">
-            <a:r>
-              <a:t>Spatial 图是真实组织坐标。把 Leiden cluster 放回 Spatial 后，会发现颜色没有像 UMAP 那样分成特别干净的大块，而是有不少混合。这不是失败，反而是真实数据常见的情况：组织里不同状态可能交错，空间分辨率、发育阶段和技术噪声都会让结构更复杂。</a:t>
-            </a:r>
-          </a:p>
-          <a:p xmlns:a="http://schemas.openxmlformats.org/drawingml/2006/main">
-            <a:r>
-              <a:t/>
-            </a:r>
-          </a:p>
-          <a:p xmlns:a="http://schemas.openxmlformats.org/drawingml/2006/main">
-            <a:r>
-              <a:t>Gene panel 用来找生物学线索。比如 T 和 Mesp1 是中胚层/早期发育相关基因，如果它们在某些空间区域更高，就可以作为后续解释的线索。但这里仍然要谨慎：单个基因的空间表达不能直接证明机制，只能作为 evidence。</a:t>
-            </a:r>
-          </a:p>
-          <a:p xmlns:a="http://schemas.openxmlformats.org/drawingml/2006/main">
-            <a:r>
-              <a:t/>
-            </a:r>
-          </a:p>
-          <a:p xmlns:a="http://schemas.openxmlformats.org/drawingml/2006/main">
-            <a:r>
-              <a:t>一句话总结：UMAP 看表达状态是否分开，Spatial 看这些状态在组织哪里，Gene panel 用发育基因帮助解释这些区域。</a:t>
-            </a:r>
-          </a:p>
-        </p:txBody>
-      </p:sp>
-      <p:sp>
-        <p:nvSpPr>
-          <p:cNvPr id="4" name="Slide Number Placeholder 3"/>
-          <p:cNvSpPr>
-            <a:spLocks xmlns:a="http://schemas.openxmlformats.org/drawingml/2006/main" noGrp="1"/>
-          </p:cNvSpPr>
-          <p:nvPr>
-            <p:ph type="sldNum" idx="5"/>
-          </p:nvPr>
-        </p:nvSpPr>
-        <p:spPr/>
-        <p:txBody>
-          <a:bodyPr xmlns:a="http://schemas.openxmlformats.org/drawingml/2006/main"/>
-          <a:lstStyle xmlns:a="http://schemas.openxmlformats.org/drawingml/2006/main"/>
-          <a:p xmlns:a="http://schemas.openxmlformats.org/drawingml/2006/main"/>
-        </p:txBody>
-      </p:sp>
-    </p:spTree>
-  </p:cSld>
-  <p:clrMapOvr>
-    <a:masterClrMapping xmlns:a="http://schemas.openxmlformats.org/drawingml/2006/main"/>
-  </p:clrMapOvr>
-</p:notes>
-</file>
-
-<file path=ppt/notesSlides/notesSlide16.xml><?xml version="1.0" encoding="utf-8"?>
-<p:notes xmlns:p="http://schemas.openxmlformats.org/presentationml/2006/main">
-  <p:cSld>
-    <p:spTree>
-      <p:nvGrpSpPr>
-        <p:cNvPr id="1" name=""/>
-        <p:cNvGrpSpPr/>
-        <p:nvPr/>
-      </p:nvGrpSpPr>
-      <p:grpSpPr>
-        <a:xfrm xmlns:a="http://schemas.openxmlformats.org/drawingml/2006/main"/>
-      </p:grpSpPr>
-      <p:sp>
-        <p:nvSpPr>
-          <p:cNvPr id="2" name="Slide Image Placeholder 1"/>
-          <p:cNvSpPr>
-            <a:spLocks xmlns:a="http://schemas.openxmlformats.org/drawingml/2006/main" noGrp="1"/>
-          </p:cNvSpPr>
-          <p:nvPr>
-            <p:ph type="sldImg" idx="0"/>
-          </p:nvPr>
-        </p:nvSpPr>
-        <p:spPr/>
-      </p:sp>
-      <p:sp>
-        <p:nvSpPr>
-          <p:cNvPr id="3" name="Notes Placeholder 2"/>
-          <p:cNvSpPr>
-            <a:spLocks xmlns:a="http://schemas.openxmlformats.org/drawingml/2006/main" noGrp="1"/>
-          </p:cNvSpPr>
-          <p:nvPr>
-            <p:ph type="body" idx="1"/>
-          </p:nvPr>
-        </p:nvSpPr>
-        <p:spPr/>
-        <p:txBody>
-          <a:bodyPr xmlns:a="http://schemas.openxmlformats.org/drawingml/2006/main"/>
-          <a:lstStyle xmlns:a="http://schemas.openxmlformats.org/drawingml/2006/main"/>
-          <a:p xmlns:a="http://schemas.openxmlformats.org/drawingml/2006/main">
-            <a:r>
-              <a:t>讲稿：在理解真实数据图之后，再回到真实科研场景。SpatialScope 可以作为 exploratory analysis workspace。发育生物学里可以比较不同胚胎阶段的空间区域，并查看 Sox17、T、Mesp1 等基因；肿瘤微环境里可以探索 tumor、immune、stromal regions；病理切片探索中可以整合组织结构、空间表达和 cluster；教学中可以帮助学生从自然语言问题进入可复现分析。</a:t>
+              <a:t>讲稿：真实数据验证之后，再回到真实科研场景。SpatialScope 可以作为 exploratory analysis workspace。发育生物学里可以比较不同胚胎阶段的空间区域，并查看 Sox17、T、Mesp1 等基因；肿瘤微环境里可以探索 tumor、immune、stromal regions；病理切片探索中可以整合组织结构、空间表达和 cluster；教学中可以帮助学生从自然语言问题进入可复现分析。</a:t>
             </a:r>
           </a:p>
           <a:p xmlns:a="http://schemas.openxmlformats.org/drawingml/2006/main">
@@ -1263,7 +1152,7 @@
 </p:notes>
 </file>
 
-<file path=ppt/notesSlides/notesSlide17.xml><?xml version="1.0" encoding="utf-8"?>
+<file path=ppt/notesSlides/notesSlide16.xml><?xml version="1.0" encoding="utf-8"?>
 <p:notes xmlns:p="http://schemas.openxmlformats.org/presentationml/2006/main">
   <p:cSld>
     <p:spTree>
@@ -2031,7 +1920,7 @@
   </p:cSld>
   <p:clrMap bg1="lt1" tx1="dk1" bg2="lt2" tx2="dk2" accent1="accent1" accent2="accent2" accent3="accent3" accent4="accent4" accent5="accent5" accent6="accent6" hlink="hlink" folHlink="folHlink"/>
   <p:sldLayoutIdLst>
-    <p:sldLayoutId xmlns:r="http://schemas.openxmlformats.org/officeDocument/2006/relationships" id="2147483649" r:id="R7b42a05a4c2c4c72"/>
+    <p:sldLayoutId xmlns:r="http://schemas.openxmlformats.org/officeDocument/2006/relationships" id="2147483649" r:id="R5113e0da4466459c"/>
   </p:sldLayoutIdLst>
   <p:txStyles>
     <p:titleStyle>
@@ -2652,7 +2541,7 @@
           <p:nvPr/>
         </p:nvPicPr>
         <p:blipFill>
-          <a:blip xmlns:r="http://schemas.openxmlformats.org/officeDocument/2006/relationships" xmlns:a="http://schemas.openxmlformats.org/drawingml/2006/main" r:embed="Rfa2947ec9ce3440b"/>
+          <a:blip xmlns:r="http://schemas.openxmlformats.org/officeDocument/2006/relationships" xmlns:a="http://schemas.openxmlformats.org/drawingml/2006/main" r:embed="R5062443b37b94b83"/>
           <a:stretch xmlns:a="http://schemas.openxmlformats.org/drawingml/2006/main"/>
         </p:blipFill>
         <p:spPr>
@@ -2860,7 +2749,7 @@
           <p:nvPr/>
         </p:nvPicPr>
         <p:blipFill>
-          <a:blip xmlns:r="http://schemas.openxmlformats.org/officeDocument/2006/relationships" xmlns:a="http://schemas.openxmlformats.org/drawingml/2006/main" r:embed="R383c861c02554c86"/>
+          <a:blip xmlns:r="http://schemas.openxmlformats.org/officeDocument/2006/relationships" xmlns:a="http://schemas.openxmlformats.org/drawingml/2006/main" r:embed="Rba7f4712a1bd46d3"/>
           <a:srcRect xmlns:a="http://schemas.openxmlformats.org/drawingml/2006/main" l="0" t="10358" r="0" b="10358"/>
           <a:stretch xmlns:a="http://schemas.openxmlformats.org/drawingml/2006/main">
             <a:fillRect l="0" t="0" r="0" b="0"/>
@@ -5907,7 +5796,7 @@
       </p:sp>
       <p:cxnSp>
         <p:nvCxnSpPr>
-          <p:cNvPr id="66" name=""/>
+          <p:cNvPr id="94" name=""/>
           <p:cNvCxnSpPr>
             <a:stCxn xmlns:a="http://schemas.openxmlformats.org/drawingml/2006/main" id="5" idx="3"/>
             <a:endCxn xmlns:a="http://schemas.openxmlformats.org/drawingml/2006/main" id="6" idx="1"/>
@@ -6063,7 +5952,7 @@
       </p:sp>
       <p:cxnSp>
         <p:nvCxnSpPr>
-          <p:cNvPr id="69" name=""/>
+          <p:cNvPr id="97" name=""/>
           <p:cNvCxnSpPr>
             <a:stCxn xmlns:a="http://schemas.openxmlformats.org/drawingml/2006/main" id="8" idx="3"/>
             <a:endCxn xmlns:a="http://schemas.openxmlformats.org/drawingml/2006/main" id="9" idx="1"/>
@@ -6219,7 +6108,7 @@
       </p:sp>
       <p:cxnSp>
         <p:nvCxnSpPr>
-          <p:cNvPr id="72" name=""/>
+          <p:cNvPr id="100" name=""/>
           <p:cNvCxnSpPr>
             <a:stCxn xmlns:a="http://schemas.openxmlformats.org/drawingml/2006/main" id="11" idx="3"/>
             <a:endCxn xmlns:a="http://schemas.openxmlformats.org/drawingml/2006/main" id="12" idx="1"/>
@@ -6375,7 +6264,7 @@
       </p:sp>
       <p:cxnSp>
         <p:nvCxnSpPr>
-          <p:cNvPr id="75" name=""/>
+          <p:cNvPr id="103" name=""/>
           <p:cNvCxnSpPr>
             <a:stCxn xmlns:a="http://schemas.openxmlformats.org/drawingml/2006/main" id="14" idx="3"/>
             <a:endCxn xmlns:a="http://schemas.openxmlformats.org/drawingml/2006/main" id="15" idx="1"/>
@@ -6531,7 +6420,7 @@
       </p:sp>
       <p:cxnSp>
         <p:nvCxnSpPr>
-          <p:cNvPr id="78" name=""/>
+          <p:cNvPr id="106" name=""/>
           <p:cNvCxnSpPr>
             <a:stCxn xmlns:a="http://schemas.openxmlformats.org/drawingml/2006/main" id="17" idx="3"/>
             <a:endCxn xmlns:a="http://schemas.openxmlformats.org/drawingml/2006/main" id="18" idx="1"/>
@@ -6687,7 +6576,7 @@
       </p:sp>
       <p:cxnSp>
         <p:nvCxnSpPr>
-          <p:cNvPr id="81" name=""/>
+          <p:cNvPr id="109" name=""/>
           <p:cNvCxnSpPr>
             <a:stCxn xmlns:a="http://schemas.openxmlformats.org/drawingml/2006/main" id="20" idx="3"/>
             <a:endCxn xmlns:a="http://schemas.openxmlformats.org/drawingml/2006/main" id="21" idx="1"/>
@@ -6843,7 +6732,7 @@
       </p:sp>
       <p:cxnSp>
         <p:nvCxnSpPr>
-          <p:cNvPr id="84" name=""/>
+          <p:cNvPr id="112" name=""/>
           <p:cNvCxnSpPr>
             <a:stCxn xmlns:a="http://schemas.openxmlformats.org/drawingml/2006/main" id="23" idx="3"/>
             <a:endCxn xmlns:a="http://schemas.openxmlformats.org/drawingml/2006/main" id="24" idx="1"/>
@@ -6999,7 +6888,7 @@
       </p:sp>
       <p:cxnSp>
         <p:nvCxnSpPr>
-          <p:cNvPr id="87" name=""/>
+          <p:cNvPr id="115" name=""/>
           <p:cNvCxnSpPr>
             <a:stCxn xmlns:a="http://schemas.openxmlformats.org/drawingml/2006/main" id="26" idx="3"/>
             <a:endCxn xmlns:a="http://schemas.openxmlformats.org/drawingml/2006/main" id="27" idx="1"/>
@@ -7340,7 +7229,7 @@
           <p:nvPr/>
         </p:nvPicPr>
         <p:blipFill>
-          <a:blip xmlns:r="http://schemas.openxmlformats.org/officeDocument/2006/relationships" xmlns:a="http://schemas.openxmlformats.org/drawingml/2006/main" r:embed="R7a63601b11db47b8"/>
+          <a:blip xmlns:r="http://schemas.openxmlformats.org/officeDocument/2006/relationships" xmlns:a="http://schemas.openxmlformats.org/drawingml/2006/main" r:embed="R8190f9b06e9b4d60"/>
           <a:srcRect xmlns:a="http://schemas.openxmlformats.org/drawingml/2006/main" l="0" t="17360" r="0" b="17360"/>
           <a:stretch xmlns:a="http://schemas.openxmlformats.org/drawingml/2006/main">
             <a:fillRect l="0" t="0" r="0" b="0"/>
@@ -7365,7 +7254,7 @@
           <p:nvPr/>
         </p:nvPicPr>
         <p:blipFill>
-          <a:blip xmlns:r="http://schemas.openxmlformats.org/officeDocument/2006/relationships" xmlns:a="http://schemas.openxmlformats.org/drawingml/2006/main" r:embed="R24b1bb5068044729"/>
+          <a:blip xmlns:r="http://schemas.openxmlformats.org/officeDocument/2006/relationships" xmlns:a="http://schemas.openxmlformats.org/drawingml/2006/main" r:embed="R90f66e01d02f454c"/>
           <a:srcRect xmlns:a="http://schemas.openxmlformats.org/drawingml/2006/main" l="0" t="17360" r="0" b="17360"/>
           <a:stretch xmlns:a="http://schemas.openxmlformats.org/drawingml/2006/main">
             <a:fillRect l="0" t="0" r="0" b="0"/>
@@ -11034,7 +10923,7 @@
                 <a:ea typeface="PingFang SC"/>
                 <a:cs typeface="PingFang SC"/>
               </a:rPr>
-              <a:t>obsm["X_spatial"] -&gt; obsm["spatial"]</a:t>
+              <a:t>真实空间坐标：X_spatial -&gt; spatial</a:t>
             </a:r>
           </a:p>
           <a:p xmlns:a="http://schemas.openxmlformats.org/drawingml/2006/main">
@@ -11061,7 +10950,7 @@
                 <a:ea typeface="PingFang SC"/>
                 <a:cs typeface="PingFang SC"/>
               </a:rPr>
-              <a:t>Quick run: QC + UMAP + Leiden + gene panel</a:t>
+              <a:t>输出：空间聚类 · UMAP · 基因表达面板</a:t>
             </a:r>
           </a:p>
           <a:p xmlns:a="http://schemas.openxmlformats.org/drawingml/2006/main">
@@ -11088,7 +10977,7 @@
                 <a:ea typeface="PingFang SC"/>
                 <a:cs typeface="PingFang SC"/>
               </a:rPr>
-              <a:t>7 clusters · 0 warnings · 0 errors</a:t>
+              <a:t>Quick run: 0 warnings · 0 errors</a:t>
             </a:r>
           </a:p>
         </p:txBody>
@@ -11102,7 +10991,7 @@
           <p:nvPr/>
         </p:nvPicPr>
         <p:blipFill>
-          <a:blip xmlns:r="http://schemas.openxmlformats.org/officeDocument/2006/relationships" xmlns:a="http://schemas.openxmlformats.org/drawingml/2006/main" r:embed="Rab085b1d504e412c"/>
+          <a:blip xmlns:r="http://schemas.openxmlformats.org/officeDocument/2006/relationships" xmlns:a="http://schemas.openxmlformats.org/drawingml/2006/main" r:embed="R30de565b46854558"/>
           <a:stretch xmlns:a="http://schemas.openxmlformats.org/drawingml/2006/main"/>
         </p:blipFill>
         <p:spPr>
@@ -11124,7 +11013,7 @@
           <p:nvPr/>
         </p:nvPicPr>
         <p:blipFill>
-          <a:blip xmlns:r="http://schemas.openxmlformats.org/officeDocument/2006/relationships" xmlns:a="http://schemas.openxmlformats.org/drawingml/2006/main" r:embed="R2e9461f257fe4bc7"/>
+          <a:blip xmlns:r="http://schemas.openxmlformats.org/officeDocument/2006/relationships" xmlns:a="http://schemas.openxmlformats.org/drawingml/2006/main" r:embed="Ra24cfae5f0a04615"/>
           <a:stretch xmlns:a="http://schemas.openxmlformats.org/drawingml/2006/main"/>
         </p:blipFill>
         <p:spPr>
@@ -11146,7 +11035,7 @@
           <p:nvPr/>
         </p:nvPicPr>
         <p:blipFill>
-          <a:blip xmlns:r="http://schemas.openxmlformats.org/officeDocument/2006/relationships" xmlns:a="http://schemas.openxmlformats.org/drawingml/2006/main" r:embed="R3e29ffbd25634e5c"/>
+          <a:blip xmlns:r="http://schemas.openxmlformats.org/officeDocument/2006/relationships" xmlns:a="http://schemas.openxmlformats.org/drawingml/2006/main" r:embed="R28848bdbc0cd4e8b"/>
           <a:stretch xmlns:a="http://schemas.openxmlformats.org/drawingml/2006/main"/>
         </p:blipFill>
         <p:spPr>
@@ -11189,7 +11078,7 @@
         </p:spPr>
         <p:txBody>
           <a:bodyPr xmlns:a="http://schemas.openxmlformats.org/drawingml/2006/main" lIns="0" tIns="0" rIns="0" bIns="0" anchor="t">
-            <a:normAutofit fontScale="80702"/>
+            <a:normAutofit fontScale="76702"/>
           </a:bodyPr>
           <a:lstStyle xmlns:a="http://schemas.openxmlformats.org/drawingml/2006/main"/>
           <a:p xmlns:a="http://schemas.openxmlformats.org/drawingml/2006/main">
@@ -11216,7 +11105,7 @@
                 <a:ea typeface="PingFang SC"/>
                 <a:cs typeface="PingFang SC"/>
               </a:rPr>
-              <a:t>这页不是声称发现新机制，而是验证系统能处理真实 AnnData、真实空间坐标和真实表达层状态。</a:t>
+              <a:t>验证重点：系统能从真实 AnnData 读取空间坐标，完成标准分析流程，并生成可复核图表；不把 quick run 过度解释为机制发现。</a:t>
             </a:r>
           </a:p>
         </p:txBody>
@@ -11410,7 +11299,7 @@
           <p:cNvPr id="1" name="">
             <a:extLst xmlns:a="http://schemas.openxmlformats.org/drawingml/2006/main">
               <a:ext uri="{FF2B5EF4-FFF2-40B4-BE49-F238E27FC236}">
-                <a16:creationId xmlns:a16="http://schemas.microsoft.com/office/drawing/2014/main" id="{EABC0170-F86A-4D71-8C4E-9DDEB616EB8C}"/>
+                <a16:creationId xmlns:a16="http://schemas.microsoft.com/office/drawing/2014/main" id="{F08CDAF8-8E38-4D7F-96E6-F673D4259727}"/>
               </a:ext>
             </a:extLst>
           </p:cNvPr>
@@ -11462,7 +11351,7 @@
                 <a:ea typeface="PingFang SC"/>
                 <a:cs typeface="PingFang SC"/>
               </a:rPr>
-              <a:t>READING GUIDE</a:t>
+              <a:t>RESEARCH USE CASES</a:t>
             </a:r>
           </a:p>
         </p:txBody>
@@ -11472,7 +11361,7 @@
           <p:cNvPr id="2" name="">
             <a:extLst xmlns:a="http://schemas.openxmlformats.org/drawingml/2006/main">
               <a:ext uri="{FF2B5EF4-FFF2-40B4-BE49-F238E27FC236}">
-                <a16:creationId xmlns:a16="http://schemas.microsoft.com/office/drawing/2014/main" id="{196A3E13-3DA9-4CDA-A5E9-E586D928DABE}"/>
+                <a16:creationId xmlns:a16="http://schemas.microsoft.com/office/drawing/2014/main" id="{BF8685D2-BFB7-4D4C-B334-1787B177A528}"/>
               </a:ext>
             </a:extLst>
           </p:cNvPr>
@@ -11524,7 +11413,7 @@
                 <a:ea typeface="PingFang SC"/>
                 <a:cs typeface="PingFang SC"/>
               </a:rPr>
-              <a:t>如何读真实数据图</a:t>
+              <a:t>面向真实科研场景的应用</a:t>
             </a:r>
           </a:p>
         </p:txBody>
@@ -11534,27 +11423,27 @@
           <p:cNvPr id="3" name="">
             <a:extLst xmlns:a="http://schemas.openxmlformats.org/drawingml/2006/main">
               <a:ext uri="{FF2B5EF4-FFF2-40B4-BE49-F238E27FC236}">
-                <a16:creationId xmlns:a16="http://schemas.microsoft.com/office/drawing/2014/main" id="{D83787D5-CB9A-433B-A113-80345E5D04BA}"/>
-              </a:ext>
-            </a:extLst>
-          </p:cNvPr>
-          <p:cNvSpPr>
-            <a:spLocks xmlns:a="http://schemas.openxmlformats.org/drawingml/2006/main" noGrp="1"/>
-          </p:cNvSpPr>
-          <p:nvPr/>
-        </p:nvSpPr>
-        <p:spPr>
-          <a:xfrm xmlns:a="http://schemas.openxmlformats.org/drawingml/2006/main">
-            <a:off x="704850" y="1524000"/>
-            <a:ext cx="3619500" cy="2000250"/>
+                <a16:creationId xmlns:a16="http://schemas.microsoft.com/office/drawing/2014/main" id="{816CF460-0C5D-41C2-B427-5231798E33EE}"/>
+              </a:ext>
+            </a:extLst>
+          </p:cNvPr>
+          <p:cNvSpPr>
+            <a:spLocks xmlns:a="http://schemas.openxmlformats.org/drawingml/2006/main" noGrp="1"/>
+          </p:cNvSpPr>
+          <p:nvPr/>
+        </p:nvSpPr>
+        <p:spPr>
+          <a:xfrm xmlns:a="http://schemas.openxmlformats.org/drawingml/2006/main">
+            <a:off x="819150" y="1581150"/>
+            <a:ext cx="2476500" cy="1390650"/>
           </a:xfrm>
           <a:prstGeom xmlns:a="http://schemas.openxmlformats.org/drawingml/2006/main" prst="roundRect">
             <a:avLst>
-              <a:gd name="adj" fmla="val 5714"/>
+              <a:gd name="adj" fmla="val 8219"/>
             </a:avLst>
           </a:prstGeom>
           <a:solidFill xmlns:a="http://schemas.openxmlformats.org/drawingml/2006/main">
-            <a:srgbClr val="F6FAF8"/>
+            <a:srgbClr val="E9F5F2"/>
           </a:solidFill>
           <a:ln xmlns:a="http://schemas.openxmlformats.org/drawingml/2006/main" w="9525">
             <a:solidFill>
@@ -11575,19 +11464,19 @@
           <p:cNvPr id="4" name="">
             <a:extLst xmlns:a="http://schemas.openxmlformats.org/drawingml/2006/main">
               <a:ext uri="{FF2B5EF4-FFF2-40B4-BE49-F238E27FC236}">
-                <a16:creationId xmlns:a16="http://schemas.microsoft.com/office/drawing/2014/main" id="{970BCABE-0986-4E9F-9AE1-F2B476BD9906}"/>
-              </a:ext>
-            </a:extLst>
-          </p:cNvPr>
-          <p:cNvSpPr>
-            <a:spLocks xmlns:a="http://schemas.openxmlformats.org/drawingml/2006/main" noGrp="1"/>
-          </p:cNvSpPr>
-          <p:nvPr/>
-        </p:nvSpPr>
-        <p:spPr>
-          <a:xfrm xmlns:a="http://schemas.openxmlformats.org/drawingml/2006/main">
-            <a:off x="895350" y="1695450"/>
-            <a:ext cx="3238500" cy="285750"/>
+                <a16:creationId xmlns:a16="http://schemas.microsoft.com/office/drawing/2014/main" id="{2C6DB7D3-B959-4592-B562-E53DE718C99E}"/>
+              </a:ext>
+            </a:extLst>
+          </p:cNvPr>
+          <p:cNvSpPr>
+            <a:spLocks xmlns:a="http://schemas.openxmlformats.org/drawingml/2006/main" noGrp="1"/>
+          </p:cNvSpPr>
+          <p:nvPr/>
+        </p:nvSpPr>
+        <p:spPr>
+          <a:xfrm xmlns:a="http://schemas.openxmlformats.org/drawingml/2006/main">
+            <a:off x="1009650" y="1752600"/>
+            <a:ext cx="2095500" cy="285750"/>
           </a:xfrm>
           <a:prstGeom xmlns:a="http://schemas.openxmlformats.org/drawingml/2006/main" prst="rect">
             <a:avLst/>
@@ -11627,7 +11516,7 @@
                 <a:ea typeface="PingFang SC"/>
                 <a:cs typeface="PingFang SC"/>
               </a:rPr>
-              <a:t>Leiden 是什么？</a:t>
+              <a:t>发育生物学</a:t>
             </a:r>
           </a:p>
         </p:txBody>
@@ -11637,19 +11526,19 @@
           <p:cNvPr id="5" name="">
             <a:extLst xmlns:a="http://schemas.openxmlformats.org/drawingml/2006/main">
               <a:ext uri="{FF2B5EF4-FFF2-40B4-BE49-F238E27FC236}">
-                <a16:creationId xmlns:a16="http://schemas.microsoft.com/office/drawing/2014/main" id="{E0D30BF8-71B3-42E8-A443-55FD366C2BAE}"/>
-              </a:ext>
-            </a:extLst>
-          </p:cNvPr>
-          <p:cNvSpPr>
-            <a:spLocks xmlns:a="http://schemas.openxmlformats.org/drawingml/2006/main" noGrp="1"/>
-          </p:cNvSpPr>
-          <p:nvPr/>
-        </p:nvSpPr>
-        <p:spPr>
-          <a:xfrm xmlns:a="http://schemas.openxmlformats.org/drawingml/2006/main">
-            <a:off x="895350" y="2076450"/>
-            <a:ext cx="3238500" cy="1333500"/>
+                <a16:creationId xmlns:a16="http://schemas.microsoft.com/office/drawing/2014/main" id="{FDB3678F-D970-4A5E-BF95-1AE46058DAE3}"/>
+              </a:ext>
+            </a:extLst>
+          </p:cNvPr>
+          <p:cNvSpPr>
+            <a:spLocks xmlns:a="http://schemas.openxmlformats.org/drawingml/2006/main" noGrp="1"/>
+          </p:cNvSpPr>
+          <p:nvPr/>
+        </p:nvSpPr>
+        <p:spPr>
+          <a:xfrm xmlns:a="http://schemas.openxmlformats.org/drawingml/2006/main">
+            <a:off x="1009650" y="2133600"/>
+            <a:ext cx="2095500" cy="723900"/>
           </a:xfrm>
           <a:prstGeom xmlns:a="http://schemas.openxmlformats.org/drawingml/2006/main" prst="rect">
             <a:avLst/>
@@ -11671,7 +11560,7 @@
                 <a:spcPct val="108000"/>
               </a:lnSpc>
               <a:buNone/>
-              <a:defRPr sz="1425" b="0" i="0">
+              <a:defRPr sz="1275" b="0" i="0">
                 <a:solidFill>
                   <a:srgbClr val="475569"/>
                 </a:solidFill>
@@ -11681,7 +11570,7 @@
               </a:defRPr>
             </a:pPr>
             <a:r>
-              <a:rPr sz="1425" b="0" i="0">
+              <a:rPr sz="1275" b="0" i="0">
                 <a:solidFill>
                   <a:srgbClr val="475569"/>
                 </a:solidFill>
@@ -11689,7 +11578,7 @@
                 <a:ea typeface="PingFang SC"/>
                 <a:cs typeface="PingFang SC"/>
               </a:rPr>
-              <a:t>Leiden clustering：把表达谱相似的 spots 分到同一组</a:t>
+              <a:t>比较胚胎阶段空间区域</a:t>
             </a:r>
           </a:p>
           <a:p xmlns:a="http://schemas.openxmlformats.org/drawingml/2006/main">
@@ -11698,7 +11587,7 @@
                 <a:spcPct val="108000"/>
               </a:lnSpc>
               <a:buNone/>
-              <a:defRPr sz="1425" b="0" i="0">
+              <a:defRPr sz="1275" b="0" i="0">
                 <a:solidFill>
                   <a:srgbClr val="475569"/>
                 </a:solidFill>
@@ -11708,7 +11597,7 @@
               </a:defRPr>
             </a:pPr>
             <a:r>
-              <a:rPr sz="1425" b="0" i="0">
+              <a:rPr sz="1275" b="0" i="0">
                 <a:solidFill>
                   <a:srgbClr val="475569"/>
                 </a:solidFill>
@@ -11716,149 +11605,70 @@
                 <a:ea typeface="PingFang SC"/>
                 <a:cs typeface="PingFang SC"/>
               </a:rPr>
-              <a:t>颜色只是 cluster ID，不等于细胞类型</a:t>
-            </a:r>
-          </a:p>
-          <a:p xmlns:a="http://schemas.openxmlformats.org/drawingml/2006/main">
-            <a:pPr algn="l">
-              <a:lnSpc>
-                <a:spcPct val="108000"/>
-              </a:lnSpc>
-              <a:buNone/>
-              <a:defRPr sz="1425" b="0" i="0">
-                <a:solidFill>
-                  <a:srgbClr val="475569"/>
-                </a:solidFill>
-                <a:latin typeface="PingFang SC"/>
-                <a:ea typeface="PingFang SC"/>
-                <a:cs typeface="PingFang SC"/>
-              </a:defRPr>
-            </a:pPr>
-            <a:r>
-              <a:rPr sz="1425" b="0" i="0">
-                <a:solidFill>
-                  <a:srgbClr val="475569"/>
-                </a:solidFill>
-                <a:latin typeface="PingFang SC"/>
-                <a:ea typeface="PingFang SC"/>
-                <a:cs typeface="PingFang SC"/>
-              </a:rPr>
-              <a:t>UMAP 分得清：表达状态可分</a:t>
-            </a:r>
-          </a:p>
-          <a:p xmlns:a="http://schemas.openxmlformats.org/drawingml/2006/main">
-            <a:pPr algn="l">
-              <a:lnSpc>
-                <a:spcPct val="108000"/>
-              </a:lnSpc>
-              <a:buNone/>
-              <a:defRPr sz="1425" b="0" i="0">
-                <a:solidFill>
-                  <a:srgbClr val="475569"/>
-                </a:solidFill>
-                <a:latin typeface="PingFang SC"/>
-                <a:ea typeface="PingFang SC"/>
-                <a:cs typeface="PingFang SC"/>
-              </a:defRPr>
-            </a:pPr>
-            <a:r>
-              <a:rPr sz="1425" b="0" i="0">
-                <a:solidFill>
-                  <a:srgbClr val="475569"/>
-                </a:solidFill>
-                <a:latin typeface="PingFang SC"/>
-                <a:ea typeface="PingFang SC"/>
-                <a:cs typeface="PingFang SC"/>
-              </a:rPr>
-              <a:t>Spatial 混在一起：真实组织结构更复杂</a:t>
+              <a:t>查看 Sox17、T、Mesp1 等基因</a:t>
             </a:r>
           </a:p>
         </p:txBody>
       </p:sp>
-      <p:pic>
-        <p:nvPicPr>
-          <p:cNvPr id="21" name=""/>
-          <p:cNvPicPr>
-            <a:picLocks xmlns:a="http://schemas.openxmlformats.org/drawingml/2006/main" noChangeAspect="1"/>
-          </p:cNvPicPr>
-          <p:nvPr/>
-        </p:nvPicPr>
-        <p:blipFill>
-          <a:blip xmlns:r="http://schemas.openxmlformats.org/officeDocument/2006/relationships" xmlns:a="http://schemas.openxmlformats.org/drawingml/2006/main" r:embed="Rd0be40847c164fb4"/>
-          <a:stretch xmlns:a="http://schemas.openxmlformats.org/drawingml/2006/main"/>
-        </p:blipFill>
-        <p:spPr>
-          <a:xfrm xmlns:a="http://schemas.openxmlformats.org/drawingml/2006/main">
-            <a:off x="4762500" y="1428750"/>
-            <a:ext cx="2714625" cy="2047875"/>
+      <p:sp>
+        <p:nvSpPr>
+          <p:cNvPr id="6" name="">
+            <a:extLst xmlns:a="http://schemas.openxmlformats.org/drawingml/2006/main">
+              <a:ext uri="{FF2B5EF4-FFF2-40B4-BE49-F238E27FC236}">
+                <a16:creationId xmlns:a16="http://schemas.microsoft.com/office/drawing/2014/main" id="{EB2E0C5E-AA34-4D6B-99F3-D46F57911347}"/>
+              </a:ext>
+            </a:extLst>
+          </p:cNvPr>
+          <p:cNvSpPr>
+            <a:spLocks xmlns:a="http://schemas.openxmlformats.org/drawingml/2006/main" noGrp="1"/>
+          </p:cNvSpPr>
+          <p:nvPr/>
+        </p:nvSpPr>
+        <p:spPr>
+          <a:xfrm xmlns:a="http://schemas.openxmlformats.org/drawingml/2006/main">
+            <a:off x="3581400" y="1581150"/>
+            <a:ext cx="2476500" cy="1390650"/>
           </a:xfrm>
           <a:prstGeom xmlns:a="http://schemas.openxmlformats.org/drawingml/2006/main" prst="roundRect">
-            <a:avLst/>
-          </a:prstGeom>
-        </p:spPr>
-      </p:pic>
-      <p:pic>
-        <p:nvPicPr>
-          <p:cNvPr id="22" name=""/>
-          <p:cNvPicPr>
-            <a:picLocks xmlns:a="http://schemas.openxmlformats.org/drawingml/2006/main" noChangeAspect="1"/>
-          </p:cNvPicPr>
-          <p:nvPr/>
-        </p:nvPicPr>
-        <p:blipFill>
-          <a:blip xmlns:r="http://schemas.openxmlformats.org/officeDocument/2006/relationships" xmlns:a="http://schemas.openxmlformats.org/drawingml/2006/main" r:embed="Rbf6d077675be4cb5"/>
-          <a:stretch xmlns:a="http://schemas.openxmlformats.org/drawingml/2006/main"/>
-        </p:blipFill>
-        <p:spPr>
-          <a:xfrm xmlns:a="http://schemas.openxmlformats.org/drawingml/2006/main">
-            <a:off x="7829550" y="1381125"/>
-            <a:ext cx="3238500" cy="2143125"/>
-          </a:xfrm>
-          <a:prstGeom xmlns:a="http://schemas.openxmlformats.org/drawingml/2006/main" prst="roundRect">
-            <a:avLst/>
-          </a:prstGeom>
-        </p:spPr>
-      </p:pic>
-      <p:pic>
-        <p:nvPicPr>
-          <p:cNvPr id="23" name=""/>
-          <p:cNvPicPr>
-            <a:picLocks xmlns:a="http://schemas.openxmlformats.org/drawingml/2006/main" noChangeAspect="1"/>
-          </p:cNvPicPr>
-          <p:nvPr/>
-        </p:nvPicPr>
-        <p:blipFill>
-          <a:blip xmlns:r="http://schemas.openxmlformats.org/officeDocument/2006/relationships" xmlns:a="http://schemas.openxmlformats.org/drawingml/2006/main" r:embed="R0a8592c124a849b3"/>
-          <a:stretch xmlns:a="http://schemas.openxmlformats.org/drawingml/2006/main"/>
-        </p:blipFill>
-        <p:spPr>
-          <a:xfrm xmlns:a="http://schemas.openxmlformats.org/drawingml/2006/main">
-            <a:off x="5715000" y="3905250"/>
-            <a:ext cx="5095875" cy="1762125"/>
-          </a:xfrm>
-          <a:prstGeom xmlns:a="http://schemas.openxmlformats.org/drawingml/2006/main" prst="roundRect">
-            <a:avLst/>
-          </a:prstGeom>
-        </p:spPr>
-      </p:pic>
-      <p:sp>
-        <p:nvSpPr>
-          <p:cNvPr id="9" name="">
-            <a:extLst xmlns:a="http://schemas.openxmlformats.org/drawingml/2006/main">
-              <a:ext uri="{FF2B5EF4-FFF2-40B4-BE49-F238E27FC236}">
-                <a16:creationId xmlns:a16="http://schemas.microsoft.com/office/drawing/2014/main" id="{6B80F217-C291-455D-945A-FC7C668C4649}"/>
-              </a:ext>
-            </a:extLst>
-          </p:cNvPr>
-          <p:cNvSpPr>
-            <a:spLocks xmlns:a="http://schemas.openxmlformats.org/drawingml/2006/main" noGrp="1"/>
-          </p:cNvSpPr>
-          <p:nvPr/>
-        </p:nvSpPr>
-        <p:spPr>
-          <a:xfrm xmlns:a="http://schemas.openxmlformats.org/drawingml/2006/main">
-            <a:off x="914400" y="4953000"/>
-            <a:ext cx="3238500" cy="704850"/>
+            <a:avLst>
+              <a:gd name="adj" fmla="val 8219"/>
+            </a:avLst>
+          </a:prstGeom>
+          <a:solidFill xmlns:a="http://schemas.openxmlformats.org/drawingml/2006/main">
+            <a:srgbClr val="F6FAF8"/>
+          </a:solidFill>
+          <a:ln xmlns:a="http://schemas.openxmlformats.org/drawingml/2006/main" w="9525">
+            <a:solidFill>
+              <a:srgbClr val="D7E4E0"/>
+            </a:solidFill>
+            <a:prstDash val="solid"/>
+          </a:ln>
+        </p:spPr>
+        <p:style>
+          <a:lnRef xmlns:a="http://schemas.openxmlformats.org/drawingml/2006/main" idx="0"/>
+          <a:fillRef xmlns:a="http://schemas.openxmlformats.org/drawingml/2006/main" idx="0"/>
+          <a:effectRef xmlns:a="http://schemas.openxmlformats.org/drawingml/2006/main" idx="4"/>
+          <a:fontRef xmlns:a="http://schemas.openxmlformats.org/drawingml/2006/main" idx="major"/>
+        </p:style>
+      </p:sp>
+      <p:sp>
+        <p:nvSpPr>
+          <p:cNvPr id="7" name="">
+            <a:extLst xmlns:a="http://schemas.openxmlformats.org/drawingml/2006/main">
+              <a:ext uri="{FF2B5EF4-FFF2-40B4-BE49-F238E27FC236}">
+                <a16:creationId xmlns:a16="http://schemas.microsoft.com/office/drawing/2014/main" id="{7F60CFFD-66A1-4446-BA56-09AE35BF78FF}"/>
+              </a:ext>
+            </a:extLst>
+          </p:cNvPr>
+          <p:cNvSpPr>
+            <a:spLocks xmlns:a="http://schemas.openxmlformats.org/drawingml/2006/main" noGrp="1"/>
+          </p:cNvSpPr>
+          <p:nvPr/>
+        </p:nvSpPr>
+        <p:spPr>
+          <a:xfrm xmlns:a="http://schemas.openxmlformats.org/drawingml/2006/main">
+            <a:off x="3771900" y="1752600"/>
+            <a:ext cx="2095500" cy="285750"/>
           </a:xfrm>
           <a:prstGeom xmlns:a="http://schemas.openxmlformats.org/drawingml/2006/main" prst="rect">
             <a:avLst/>
@@ -11871,7 +11681,7 @@
         </p:spPr>
         <p:txBody>
           <a:bodyPr xmlns:a="http://schemas.openxmlformats.org/drawingml/2006/main" lIns="0" tIns="0" rIns="0" bIns="0" anchor="t">
-            <a:normAutofit fontScale="78440"/>
+            <a:normAutofit fontScale="100000"/>
           </a:bodyPr>
           <a:lstStyle xmlns:a="http://schemas.openxmlformats.org/drawingml/2006/main"/>
           <a:p xmlns:a="http://schemas.openxmlformats.org/drawingml/2006/main">
@@ -11882,7 +11692,7 @@
               <a:buNone/>
               <a:defRPr sz="1575" b="1" i="0">
                 <a:solidFill>
-                  <a:srgbClr val="17212B"/>
+                  <a:srgbClr val="0F766E"/>
                 </a:solidFill>
                 <a:latin typeface="PingFang SC"/>
                 <a:ea typeface="PingFang SC"/>
@@ -11892,23 +11702,723 @@
             <a:r>
               <a:rPr sz="1575" b="1" i="0">
                 <a:solidFill>
-                  <a:srgbClr val="17212B"/>
+                  <a:srgbClr val="0F766E"/>
                 </a:solidFill>
                 <a:latin typeface="PingFang SC"/>
                 <a:ea typeface="PingFang SC"/>
                 <a:cs typeface="PingFang SC"/>
               </a:rPr>
-              <a:t>读图顺序：先看 UMAP 聚类是否分开，再回到 Spatial 看组织位置，最后用 T、Mesp1 等基因图寻找可解释的发育区域。</a:t>
+              <a:t>肿瘤微环境</a:t>
             </a:r>
           </a:p>
         </p:txBody>
       </p:sp>
       <p:sp>
         <p:nvSpPr>
+          <p:cNvPr id="8" name="">
+            <a:extLst xmlns:a="http://schemas.openxmlformats.org/drawingml/2006/main">
+              <a:ext uri="{FF2B5EF4-FFF2-40B4-BE49-F238E27FC236}">
+                <a16:creationId xmlns:a16="http://schemas.microsoft.com/office/drawing/2014/main" id="{DA064A20-DCD8-47A0-8781-86C4962F4433}"/>
+              </a:ext>
+            </a:extLst>
+          </p:cNvPr>
+          <p:cNvSpPr>
+            <a:spLocks xmlns:a="http://schemas.openxmlformats.org/drawingml/2006/main" noGrp="1"/>
+          </p:cNvSpPr>
+          <p:nvPr/>
+        </p:nvSpPr>
+        <p:spPr>
+          <a:xfrm xmlns:a="http://schemas.openxmlformats.org/drawingml/2006/main">
+            <a:off x="3771900" y="2133600"/>
+            <a:ext cx="2095500" cy="723900"/>
+          </a:xfrm>
+          <a:prstGeom xmlns:a="http://schemas.openxmlformats.org/drawingml/2006/main" prst="rect">
+            <a:avLst/>
+          </a:prstGeom>
+          <a:noFill xmlns:a="http://schemas.openxmlformats.org/drawingml/2006/main"/>
+          <a:ln xmlns:a="http://schemas.openxmlformats.org/drawingml/2006/main" w="0">
+            <a:noFill/>
+            <a:prstDash val="solid"/>
+          </a:ln>
+        </p:spPr>
+        <p:txBody>
+          <a:bodyPr xmlns:a="http://schemas.openxmlformats.org/drawingml/2006/main" lIns="0" tIns="0" rIns="0" bIns="0" anchor="t">
+            <a:normAutofit fontScale="100000"/>
+          </a:bodyPr>
+          <a:lstStyle xmlns:a="http://schemas.openxmlformats.org/drawingml/2006/main"/>
+          <a:p xmlns:a="http://schemas.openxmlformats.org/drawingml/2006/main">
+            <a:pPr algn="l">
+              <a:lnSpc>
+                <a:spcPct val="108000"/>
+              </a:lnSpc>
+              <a:buNone/>
+              <a:defRPr sz="1275" b="0" i="0">
+                <a:solidFill>
+                  <a:srgbClr val="475569"/>
+                </a:solidFill>
+                <a:latin typeface="PingFang SC"/>
+                <a:ea typeface="PingFang SC"/>
+                <a:cs typeface="PingFang SC"/>
+              </a:defRPr>
+            </a:pPr>
+            <a:r>
+              <a:rPr sz="1275" b="0" i="0">
+                <a:solidFill>
+                  <a:srgbClr val="475569"/>
+                </a:solidFill>
+                <a:latin typeface="PingFang SC"/>
+                <a:ea typeface="PingFang SC"/>
+                <a:cs typeface="PingFang SC"/>
+              </a:rPr>
+              <a:t>识别 tumor / immune / stromal regions</a:t>
+            </a:r>
+          </a:p>
+          <a:p xmlns:a="http://schemas.openxmlformats.org/drawingml/2006/main">
+            <a:pPr algn="l">
+              <a:lnSpc>
+                <a:spcPct val="108000"/>
+              </a:lnSpc>
+              <a:buNone/>
+              <a:defRPr sz="1275" b="0" i="0">
+                <a:solidFill>
+                  <a:srgbClr val="475569"/>
+                </a:solidFill>
+                <a:latin typeface="PingFang SC"/>
+                <a:ea typeface="PingFang SC"/>
+                <a:cs typeface="PingFang SC"/>
+              </a:defRPr>
+            </a:pPr>
+            <a:r>
+              <a:rPr sz="1275" b="0" i="0">
+                <a:solidFill>
+                  <a:srgbClr val="475569"/>
+                </a:solidFill>
+                <a:latin typeface="PingFang SC"/>
+                <a:ea typeface="PingFang SC"/>
+                <a:cs typeface="PingFang SC"/>
+              </a:rPr>
+              <a:t>分析 marker 与邻域富集</a:t>
+            </a:r>
+          </a:p>
+        </p:txBody>
+      </p:sp>
+      <p:sp>
+        <p:nvSpPr>
+          <p:cNvPr id="9" name="">
+            <a:extLst xmlns:a="http://schemas.openxmlformats.org/drawingml/2006/main">
+              <a:ext uri="{FF2B5EF4-FFF2-40B4-BE49-F238E27FC236}">
+                <a16:creationId xmlns:a16="http://schemas.microsoft.com/office/drawing/2014/main" id="{8A33CA5E-C05A-4616-8B0E-70377B776681}"/>
+              </a:ext>
+            </a:extLst>
+          </p:cNvPr>
+          <p:cNvSpPr>
+            <a:spLocks xmlns:a="http://schemas.openxmlformats.org/drawingml/2006/main" noGrp="1"/>
+          </p:cNvSpPr>
+          <p:nvPr/>
+        </p:nvSpPr>
+        <p:spPr>
+          <a:xfrm xmlns:a="http://schemas.openxmlformats.org/drawingml/2006/main">
+            <a:off x="6343650" y="1581150"/>
+            <a:ext cx="2476500" cy="1390650"/>
+          </a:xfrm>
+          <a:prstGeom xmlns:a="http://schemas.openxmlformats.org/drawingml/2006/main" prst="roundRect">
+            <a:avLst>
+              <a:gd name="adj" fmla="val 8219"/>
+            </a:avLst>
+          </a:prstGeom>
+          <a:solidFill xmlns:a="http://schemas.openxmlformats.org/drawingml/2006/main">
+            <a:srgbClr val="F6FAF8"/>
+          </a:solidFill>
+          <a:ln xmlns:a="http://schemas.openxmlformats.org/drawingml/2006/main" w="9525">
+            <a:solidFill>
+              <a:srgbClr val="D7E4E0"/>
+            </a:solidFill>
+            <a:prstDash val="solid"/>
+          </a:ln>
+        </p:spPr>
+        <p:style>
+          <a:lnRef xmlns:a="http://schemas.openxmlformats.org/drawingml/2006/main" idx="0"/>
+          <a:fillRef xmlns:a="http://schemas.openxmlformats.org/drawingml/2006/main" idx="0"/>
+          <a:effectRef xmlns:a="http://schemas.openxmlformats.org/drawingml/2006/main" idx="4"/>
+          <a:fontRef xmlns:a="http://schemas.openxmlformats.org/drawingml/2006/main" idx="major"/>
+        </p:style>
+      </p:sp>
+      <p:sp>
+        <p:nvSpPr>
           <p:cNvPr id="10" name="">
             <a:extLst xmlns:a="http://schemas.openxmlformats.org/drawingml/2006/main">
               <a:ext uri="{FF2B5EF4-FFF2-40B4-BE49-F238E27FC236}">
-                <a16:creationId xmlns:a16="http://schemas.microsoft.com/office/drawing/2014/main" id="{04D7FE8A-919F-4F67-8E56-D49023B944A0}"/>
+                <a16:creationId xmlns:a16="http://schemas.microsoft.com/office/drawing/2014/main" id="{A3A5FF67-2D70-4231-B727-B3EF56274D8C}"/>
+              </a:ext>
+            </a:extLst>
+          </p:cNvPr>
+          <p:cNvSpPr>
+            <a:spLocks xmlns:a="http://schemas.openxmlformats.org/drawingml/2006/main" noGrp="1"/>
+          </p:cNvSpPr>
+          <p:nvPr/>
+        </p:nvSpPr>
+        <p:spPr>
+          <a:xfrm xmlns:a="http://schemas.openxmlformats.org/drawingml/2006/main">
+            <a:off x="6534150" y="1752600"/>
+            <a:ext cx="2095500" cy="285750"/>
+          </a:xfrm>
+          <a:prstGeom xmlns:a="http://schemas.openxmlformats.org/drawingml/2006/main" prst="rect">
+            <a:avLst/>
+          </a:prstGeom>
+          <a:noFill xmlns:a="http://schemas.openxmlformats.org/drawingml/2006/main"/>
+          <a:ln xmlns:a="http://schemas.openxmlformats.org/drawingml/2006/main" w="0">
+            <a:noFill/>
+            <a:prstDash val="solid"/>
+          </a:ln>
+        </p:spPr>
+        <p:txBody>
+          <a:bodyPr xmlns:a="http://schemas.openxmlformats.org/drawingml/2006/main" lIns="0" tIns="0" rIns="0" bIns="0" anchor="t">
+            <a:normAutofit fontScale="100000"/>
+          </a:bodyPr>
+          <a:lstStyle xmlns:a="http://schemas.openxmlformats.org/drawingml/2006/main"/>
+          <a:p xmlns:a="http://schemas.openxmlformats.org/drawingml/2006/main">
+            <a:pPr algn="l">
+              <a:lnSpc>
+                <a:spcPct val="108000"/>
+              </a:lnSpc>
+              <a:buNone/>
+              <a:defRPr sz="1575" b="1" i="0">
+                <a:solidFill>
+                  <a:srgbClr val="0F766E"/>
+                </a:solidFill>
+                <a:latin typeface="PingFang SC"/>
+                <a:ea typeface="PingFang SC"/>
+                <a:cs typeface="PingFang SC"/>
+              </a:defRPr>
+            </a:pPr>
+            <a:r>
+              <a:rPr sz="1575" b="1" i="0">
+                <a:solidFill>
+                  <a:srgbClr val="0F766E"/>
+                </a:solidFill>
+                <a:latin typeface="PingFang SC"/>
+                <a:ea typeface="PingFang SC"/>
+                <a:cs typeface="PingFang SC"/>
+              </a:rPr>
+              <a:t>病理切片探索</a:t>
+            </a:r>
+          </a:p>
+        </p:txBody>
+      </p:sp>
+      <p:sp>
+        <p:nvSpPr>
+          <p:cNvPr id="11" name="">
+            <a:extLst xmlns:a="http://schemas.openxmlformats.org/drawingml/2006/main">
+              <a:ext uri="{FF2B5EF4-FFF2-40B4-BE49-F238E27FC236}">
+                <a16:creationId xmlns:a16="http://schemas.microsoft.com/office/drawing/2014/main" id="{69068732-9E68-48C6-832E-79FCEA528FEA}"/>
+              </a:ext>
+            </a:extLst>
+          </p:cNvPr>
+          <p:cNvSpPr>
+            <a:spLocks xmlns:a="http://schemas.openxmlformats.org/drawingml/2006/main" noGrp="1"/>
+          </p:cNvSpPr>
+          <p:nvPr/>
+        </p:nvSpPr>
+        <p:spPr>
+          <a:xfrm xmlns:a="http://schemas.openxmlformats.org/drawingml/2006/main">
+            <a:off x="6534150" y="2133600"/>
+            <a:ext cx="2095500" cy="723900"/>
+          </a:xfrm>
+          <a:prstGeom xmlns:a="http://schemas.openxmlformats.org/drawingml/2006/main" prst="rect">
+            <a:avLst/>
+          </a:prstGeom>
+          <a:noFill xmlns:a="http://schemas.openxmlformats.org/drawingml/2006/main"/>
+          <a:ln xmlns:a="http://schemas.openxmlformats.org/drawingml/2006/main" w="0">
+            <a:noFill/>
+            <a:prstDash val="solid"/>
+          </a:ln>
+        </p:spPr>
+        <p:txBody>
+          <a:bodyPr xmlns:a="http://schemas.openxmlformats.org/drawingml/2006/main" lIns="0" tIns="0" rIns="0" bIns="0" anchor="t">
+            <a:normAutofit fontScale="100000"/>
+          </a:bodyPr>
+          <a:lstStyle xmlns:a="http://schemas.openxmlformats.org/drawingml/2006/main"/>
+          <a:p xmlns:a="http://schemas.openxmlformats.org/drawingml/2006/main">
+            <a:pPr algn="l">
+              <a:lnSpc>
+                <a:spcPct val="108000"/>
+              </a:lnSpc>
+              <a:buNone/>
+              <a:defRPr sz="1275" b="0" i="0">
+                <a:solidFill>
+                  <a:srgbClr val="475569"/>
+                </a:solidFill>
+                <a:latin typeface="PingFang SC"/>
+                <a:ea typeface="PingFang SC"/>
+                <a:cs typeface="PingFang SC"/>
+              </a:defRPr>
+            </a:pPr>
+            <a:r>
+              <a:rPr sz="1275" b="0" i="0">
+                <a:solidFill>
+                  <a:srgbClr val="475569"/>
+                </a:solidFill>
+                <a:latin typeface="PingFang SC"/>
+                <a:ea typeface="PingFang SC"/>
+                <a:cs typeface="PingFang SC"/>
+              </a:rPr>
+              <a:t>整合组织结构、空间表达和 cluster</a:t>
+            </a:r>
+          </a:p>
+          <a:p xmlns:a="http://schemas.openxmlformats.org/drawingml/2006/main">
+            <a:pPr algn="l">
+              <a:lnSpc>
+                <a:spcPct val="108000"/>
+              </a:lnSpc>
+              <a:buNone/>
+              <a:defRPr sz="1275" b="0" i="0">
+                <a:solidFill>
+                  <a:srgbClr val="475569"/>
+                </a:solidFill>
+                <a:latin typeface="PingFang SC"/>
+                <a:ea typeface="PingFang SC"/>
+                <a:cs typeface="PingFang SC"/>
+              </a:defRPr>
+            </a:pPr>
+            <a:r>
+              <a:rPr sz="1275" b="0" i="0">
+                <a:solidFill>
+                  <a:srgbClr val="475569"/>
+                </a:solidFill>
+                <a:latin typeface="PingFang SC"/>
+                <a:ea typeface="PingFang SC"/>
+                <a:cs typeface="PingFang SC"/>
+              </a:rPr>
+              <a:t>支持初步探索与复核</a:t>
+            </a:r>
+          </a:p>
+        </p:txBody>
+      </p:sp>
+      <p:sp>
+        <p:nvSpPr>
+          <p:cNvPr id="12" name="">
+            <a:extLst xmlns:a="http://schemas.openxmlformats.org/drawingml/2006/main">
+              <a:ext uri="{FF2B5EF4-FFF2-40B4-BE49-F238E27FC236}">
+                <a16:creationId xmlns:a16="http://schemas.microsoft.com/office/drawing/2014/main" id="{EB1869C9-116E-4A46-9AD8-CB8758530EFB}"/>
+              </a:ext>
+            </a:extLst>
+          </p:cNvPr>
+          <p:cNvSpPr>
+            <a:spLocks xmlns:a="http://schemas.openxmlformats.org/drawingml/2006/main" noGrp="1"/>
+          </p:cNvSpPr>
+          <p:nvPr/>
+        </p:nvSpPr>
+        <p:spPr>
+          <a:xfrm xmlns:a="http://schemas.openxmlformats.org/drawingml/2006/main">
+            <a:off x="9105900" y="1581150"/>
+            <a:ext cx="2286000" cy="1390650"/>
+          </a:xfrm>
+          <a:prstGeom xmlns:a="http://schemas.openxmlformats.org/drawingml/2006/main" prst="roundRect">
+            <a:avLst>
+              <a:gd name="adj" fmla="val 8219"/>
+            </a:avLst>
+          </a:prstGeom>
+          <a:solidFill xmlns:a="http://schemas.openxmlformats.org/drawingml/2006/main">
+            <a:srgbClr val="E9F5F2"/>
+          </a:solidFill>
+          <a:ln xmlns:a="http://schemas.openxmlformats.org/drawingml/2006/main" w="9525">
+            <a:solidFill>
+              <a:srgbClr val="D7E4E0"/>
+            </a:solidFill>
+            <a:prstDash val="solid"/>
+          </a:ln>
+        </p:spPr>
+        <p:style>
+          <a:lnRef xmlns:a="http://schemas.openxmlformats.org/drawingml/2006/main" idx="0"/>
+          <a:fillRef xmlns:a="http://schemas.openxmlformats.org/drawingml/2006/main" idx="0"/>
+          <a:effectRef xmlns:a="http://schemas.openxmlformats.org/drawingml/2006/main" idx="4"/>
+          <a:fontRef xmlns:a="http://schemas.openxmlformats.org/drawingml/2006/main" idx="major"/>
+        </p:style>
+      </p:sp>
+      <p:sp>
+        <p:nvSpPr>
+          <p:cNvPr id="13" name="">
+            <a:extLst xmlns:a="http://schemas.openxmlformats.org/drawingml/2006/main">
+              <a:ext uri="{FF2B5EF4-FFF2-40B4-BE49-F238E27FC236}">
+                <a16:creationId xmlns:a16="http://schemas.microsoft.com/office/drawing/2014/main" id="{457B3A12-0199-4A1F-BEF5-90D4BAE3B627}"/>
+              </a:ext>
+            </a:extLst>
+          </p:cNvPr>
+          <p:cNvSpPr>
+            <a:spLocks xmlns:a="http://schemas.openxmlformats.org/drawingml/2006/main" noGrp="1"/>
+          </p:cNvSpPr>
+          <p:nvPr/>
+        </p:nvSpPr>
+        <p:spPr>
+          <a:xfrm xmlns:a="http://schemas.openxmlformats.org/drawingml/2006/main">
+            <a:off x="9296400" y="1752600"/>
+            <a:ext cx="1905000" cy="285750"/>
+          </a:xfrm>
+          <a:prstGeom xmlns:a="http://schemas.openxmlformats.org/drawingml/2006/main" prst="rect">
+            <a:avLst/>
+          </a:prstGeom>
+          <a:noFill xmlns:a="http://schemas.openxmlformats.org/drawingml/2006/main"/>
+          <a:ln xmlns:a="http://schemas.openxmlformats.org/drawingml/2006/main" w="0">
+            <a:noFill/>
+            <a:prstDash val="solid"/>
+          </a:ln>
+        </p:spPr>
+        <p:txBody>
+          <a:bodyPr xmlns:a="http://schemas.openxmlformats.org/drawingml/2006/main" lIns="0" tIns="0" rIns="0" bIns="0" anchor="t">
+            <a:normAutofit fontScale="100000"/>
+          </a:bodyPr>
+          <a:lstStyle xmlns:a="http://schemas.openxmlformats.org/drawingml/2006/main"/>
+          <a:p xmlns:a="http://schemas.openxmlformats.org/drawingml/2006/main">
+            <a:pPr algn="l">
+              <a:lnSpc>
+                <a:spcPct val="108000"/>
+              </a:lnSpc>
+              <a:buNone/>
+              <a:defRPr sz="1575" b="1" i="0">
+                <a:solidFill>
+                  <a:srgbClr val="0F766E"/>
+                </a:solidFill>
+                <a:latin typeface="PingFang SC"/>
+                <a:ea typeface="PingFang SC"/>
+                <a:cs typeface="PingFang SC"/>
+              </a:defRPr>
+            </a:pPr>
+            <a:r>
+              <a:rPr sz="1575" b="1" i="0">
+                <a:solidFill>
+                  <a:srgbClr val="0F766E"/>
+                </a:solidFill>
+                <a:latin typeface="PingFang SC"/>
+                <a:ea typeface="PingFang SC"/>
+                <a:cs typeface="PingFang SC"/>
+              </a:rPr>
+              <a:t>教学与复现</a:t>
+            </a:r>
+          </a:p>
+        </p:txBody>
+      </p:sp>
+      <p:sp>
+        <p:nvSpPr>
+          <p:cNvPr id="14" name="">
+            <a:extLst xmlns:a="http://schemas.openxmlformats.org/drawingml/2006/main">
+              <a:ext uri="{FF2B5EF4-FFF2-40B4-BE49-F238E27FC236}">
+                <a16:creationId xmlns:a16="http://schemas.microsoft.com/office/drawing/2014/main" id="{C6983A64-83CE-4761-A82D-A716522DF8F8}"/>
+              </a:ext>
+            </a:extLst>
+          </p:cNvPr>
+          <p:cNvSpPr>
+            <a:spLocks xmlns:a="http://schemas.openxmlformats.org/drawingml/2006/main" noGrp="1"/>
+          </p:cNvSpPr>
+          <p:nvPr/>
+        </p:nvSpPr>
+        <p:spPr>
+          <a:xfrm xmlns:a="http://schemas.openxmlformats.org/drawingml/2006/main">
+            <a:off x="9296400" y="2133600"/>
+            <a:ext cx="1905000" cy="723900"/>
+          </a:xfrm>
+          <a:prstGeom xmlns:a="http://schemas.openxmlformats.org/drawingml/2006/main" prst="rect">
+            <a:avLst/>
+          </a:prstGeom>
+          <a:noFill xmlns:a="http://schemas.openxmlformats.org/drawingml/2006/main"/>
+          <a:ln xmlns:a="http://schemas.openxmlformats.org/drawingml/2006/main" w="0">
+            <a:noFill/>
+            <a:prstDash val="solid"/>
+          </a:ln>
+        </p:spPr>
+        <p:txBody>
+          <a:bodyPr xmlns:a="http://schemas.openxmlformats.org/drawingml/2006/main" lIns="0" tIns="0" rIns="0" bIns="0" anchor="t">
+            <a:normAutofit fontScale="100000"/>
+          </a:bodyPr>
+          <a:lstStyle xmlns:a="http://schemas.openxmlformats.org/drawingml/2006/main"/>
+          <a:p xmlns:a="http://schemas.openxmlformats.org/drawingml/2006/main">
+            <a:pPr algn="l">
+              <a:lnSpc>
+                <a:spcPct val="108000"/>
+              </a:lnSpc>
+              <a:buNone/>
+              <a:defRPr sz="1275" b="0" i="0">
+                <a:solidFill>
+                  <a:srgbClr val="475569"/>
+                </a:solidFill>
+                <a:latin typeface="PingFang SC"/>
+                <a:ea typeface="PingFang SC"/>
+                <a:cs typeface="PingFang SC"/>
+              </a:defRPr>
+            </a:pPr>
+            <a:r>
+              <a:rPr sz="1275" b="0" i="0">
+                <a:solidFill>
+                  <a:srgbClr val="475569"/>
+                </a:solidFill>
+                <a:latin typeface="PingFang SC"/>
+                <a:ea typeface="PingFang SC"/>
+                <a:cs typeface="PingFang SC"/>
+              </a:rPr>
+              <a:t>自然语言提出问题</a:t>
+            </a:r>
+          </a:p>
+          <a:p xmlns:a="http://schemas.openxmlformats.org/drawingml/2006/main">
+            <a:pPr algn="l">
+              <a:lnSpc>
+                <a:spcPct val="108000"/>
+              </a:lnSpc>
+              <a:buNone/>
+              <a:defRPr sz="1275" b="0" i="0">
+                <a:solidFill>
+                  <a:srgbClr val="475569"/>
+                </a:solidFill>
+                <a:latin typeface="PingFang SC"/>
+                <a:ea typeface="PingFang SC"/>
+                <a:cs typeface="PingFang SC"/>
+              </a:defRPr>
+            </a:pPr>
+            <a:r>
+              <a:rPr sz="1275" b="0" i="0">
+                <a:solidFill>
+                  <a:srgbClr val="475569"/>
+                </a:solidFill>
+                <a:latin typeface="PingFang SC"/>
+                <a:ea typeface="PingFang SC"/>
+                <a:cs typeface="PingFang SC"/>
+              </a:rPr>
+              <a:t>自动生成计划、图表、报告和 trace</a:t>
+            </a:r>
+          </a:p>
+        </p:txBody>
+      </p:sp>
+      <p:sp>
+        <p:nvSpPr>
+          <p:cNvPr id="15" name="">
+            <a:extLst xmlns:a="http://schemas.openxmlformats.org/drawingml/2006/main">
+              <a:ext uri="{FF2B5EF4-FFF2-40B4-BE49-F238E27FC236}">
+                <a16:creationId xmlns:a16="http://schemas.microsoft.com/office/drawing/2014/main" id="{7323AF01-E362-4975-A34D-6611B68E9448}"/>
+              </a:ext>
+            </a:extLst>
+          </p:cNvPr>
+          <p:cNvSpPr>
+            <a:spLocks xmlns:a="http://schemas.openxmlformats.org/drawingml/2006/main" noGrp="1"/>
+          </p:cNvSpPr>
+          <p:nvPr/>
+        </p:nvSpPr>
+        <p:spPr>
+          <a:xfrm xmlns:a="http://schemas.openxmlformats.org/drawingml/2006/main">
+            <a:off x="2190750" y="3810000"/>
+            <a:ext cx="7810500" cy="895350"/>
+          </a:xfrm>
+          <a:prstGeom xmlns:a="http://schemas.openxmlformats.org/drawingml/2006/main" prst="roundRect">
+            <a:avLst>
+              <a:gd name="adj" fmla="val 12766"/>
+            </a:avLst>
+          </a:prstGeom>
+          <a:solidFill xmlns:a="http://schemas.openxmlformats.org/drawingml/2006/main">
+            <a:srgbClr val="FFF4DC"/>
+          </a:solidFill>
+          <a:ln xmlns:a="http://schemas.openxmlformats.org/drawingml/2006/main" w="9525">
+            <a:solidFill>
+              <a:srgbClr val="D7E4E0"/>
+            </a:solidFill>
+            <a:prstDash val="solid"/>
+          </a:ln>
+        </p:spPr>
+        <p:style>
+          <a:lnRef xmlns:a="http://schemas.openxmlformats.org/drawingml/2006/main" idx="0"/>
+          <a:fillRef xmlns:a="http://schemas.openxmlformats.org/drawingml/2006/main" idx="0"/>
+          <a:effectRef xmlns:a="http://schemas.openxmlformats.org/drawingml/2006/main" idx="4"/>
+          <a:fontRef xmlns:a="http://schemas.openxmlformats.org/drawingml/2006/main" idx="major"/>
+        </p:style>
+      </p:sp>
+      <p:sp>
+        <p:nvSpPr>
+          <p:cNvPr id="16" name="">
+            <a:extLst xmlns:a="http://schemas.openxmlformats.org/drawingml/2006/main">
+              <a:ext uri="{FF2B5EF4-FFF2-40B4-BE49-F238E27FC236}">
+                <a16:creationId xmlns:a16="http://schemas.microsoft.com/office/drawing/2014/main" id="{02497BAF-B503-4A4A-B317-3F1BA1742508}"/>
+              </a:ext>
+            </a:extLst>
+          </p:cNvPr>
+          <p:cNvSpPr>
+            <a:spLocks xmlns:a="http://schemas.openxmlformats.org/drawingml/2006/main" noGrp="1"/>
+          </p:cNvSpPr>
+          <p:nvPr/>
+        </p:nvSpPr>
+        <p:spPr>
+          <a:xfrm xmlns:a="http://schemas.openxmlformats.org/drawingml/2006/main">
+            <a:off x="2343150" y="3905250"/>
+            <a:ext cx="7505700" cy="247650"/>
+          </a:xfrm>
+          <a:prstGeom xmlns:a="http://schemas.openxmlformats.org/drawingml/2006/main" prst="rect">
+            <a:avLst/>
+          </a:prstGeom>
+          <a:noFill xmlns:a="http://schemas.openxmlformats.org/drawingml/2006/main"/>
+          <a:ln xmlns:a="http://schemas.openxmlformats.org/drawingml/2006/main" w="0">
+            <a:noFill/>
+            <a:prstDash val="solid"/>
+          </a:ln>
+        </p:spPr>
+        <p:txBody>
+          <a:bodyPr xmlns:a="http://schemas.openxmlformats.org/drawingml/2006/main" lIns="0" tIns="0" rIns="0" bIns="0" anchor="t">
+            <a:normAutofit fontScale="100000"/>
+          </a:bodyPr>
+          <a:lstStyle xmlns:a="http://schemas.openxmlformats.org/drawingml/2006/main"/>
+          <a:p xmlns:a="http://schemas.openxmlformats.org/drawingml/2006/main">
+            <a:pPr algn="l">
+              <a:lnSpc>
+                <a:spcPct val="108000"/>
+              </a:lnSpc>
+              <a:buNone/>
+              <a:defRPr sz="1425" b="1" i="0">
+                <a:solidFill>
+                  <a:srgbClr val="8A5A12"/>
+                </a:solidFill>
+                <a:latin typeface="PingFang SC"/>
+                <a:ea typeface="PingFang SC"/>
+                <a:cs typeface="PingFang SC"/>
+              </a:defRPr>
+            </a:pPr>
+            <a:r>
+              <a:rPr sz="1425" b="1" i="0">
+                <a:solidFill>
+                  <a:srgbClr val="8A5A12"/>
+                </a:solidFill>
+                <a:latin typeface="PingFang SC"/>
+                <a:ea typeface="PingFang SC"/>
+                <a:cs typeface="PingFang SC"/>
+              </a:rPr>
+              <a:t>边界</a:t>
+            </a:r>
+          </a:p>
+        </p:txBody>
+      </p:sp>
+      <p:sp>
+        <p:nvSpPr>
+          <p:cNvPr id="17" name="">
+            <a:extLst xmlns:a="http://schemas.openxmlformats.org/drawingml/2006/main">
+              <a:ext uri="{FF2B5EF4-FFF2-40B4-BE49-F238E27FC236}">
+                <a16:creationId xmlns:a16="http://schemas.microsoft.com/office/drawing/2014/main" id="{A6950681-F741-4590-8C10-032060209B9B}"/>
+              </a:ext>
+            </a:extLst>
+          </p:cNvPr>
+          <p:cNvSpPr>
+            <a:spLocks xmlns:a="http://schemas.openxmlformats.org/drawingml/2006/main" noGrp="1"/>
+          </p:cNvSpPr>
+          <p:nvPr/>
+        </p:nvSpPr>
+        <p:spPr>
+          <a:xfrm xmlns:a="http://schemas.openxmlformats.org/drawingml/2006/main">
+            <a:off x="2343150" y="4191000"/>
+            <a:ext cx="7505700" cy="400050"/>
+          </a:xfrm>
+          <a:prstGeom xmlns:a="http://schemas.openxmlformats.org/drawingml/2006/main" prst="rect">
+            <a:avLst/>
+          </a:prstGeom>
+          <a:noFill xmlns:a="http://schemas.openxmlformats.org/drawingml/2006/main"/>
+          <a:ln xmlns:a="http://schemas.openxmlformats.org/drawingml/2006/main" w="0">
+            <a:noFill/>
+            <a:prstDash val="solid"/>
+          </a:ln>
+        </p:spPr>
+        <p:txBody>
+          <a:bodyPr xmlns:a="http://schemas.openxmlformats.org/drawingml/2006/main" lIns="0" tIns="0" rIns="0" bIns="0" anchor="t">
+            <a:normAutofit fontScale="94637"/>
+          </a:bodyPr>
+          <a:lstStyle xmlns:a="http://schemas.openxmlformats.org/drawingml/2006/main"/>
+          <a:p xmlns:a="http://schemas.openxmlformats.org/drawingml/2006/main">
+            <a:pPr algn="l">
+              <a:lnSpc>
+                <a:spcPct val="108000"/>
+              </a:lnSpc>
+              <a:buNone/>
+              <a:defRPr sz="1500" b="0" i="0">
+                <a:solidFill>
+                  <a:srgbClr val="475569"/>
+                </a:solidFill>
+                <a:latin typeface="PingFang SC"/>
+                <a:ea typeface="PingFang SC"/>
+                <a:cs typeface="PingFang SC"/>
+              </a:defRPr>
+            </a:pPr>
+            <a:r>
+              <a:rPr sz="1500" b="0" i="0">
+                <a:solidFill>
+                  <a:srgbClr val="475569"/>
+                </a:solidFill>
+                <a:latin typeface="PingFang SC"/>
+                <a:ea typeface="PingFang SC"/>
+                <a:cs typeface="PingFang SC"/>
+              </a:rPr>
+              <a:t>不能替代专家注释；不能把 marker ranking 当作机制证明；大型真实数据需要更强计算后端。</a:t>
+            </a:r>
+          </a:p>
+        </p:txBody>
+      </p:sp>
+      <p:sp>
+        <p:nvSpPr>
+          <p:cNvPr id="18" name="">
+            <a:extLst xmlns:a="http://schemas.openxmlformats.org/drawingml/2006/main">
+              <a:ext uri="{FF2B5EF4-FFF2-40B4-BE49-F238E27FC236}">
+                <a16:creationId xmlns:a16="http://schemas.microsoft.com/office/drawing/2014/main" id="{15EC04DA-8359-4232-9261-FEFAFB180947}"/>
+              </a:ext>
+            </a:extLst>
+          </p:cNvPr>
+          <p:cNvSpPr>
+            <a:spLocks xmlns:a="http://schemas.openxmlformats.org/drawingml/2006/main" noGrp="1"/>
+          </p:cNvSpPr>
+          <p:nvPr/>
+        </p:nvSpPr>
+        <p:spPr>
+          <a:xfrm xmlns:a="http://schemas.openxmlformats.org/drawingml/2006/main">
+            <a:off x="1390650" y="5334000"/>
+            <a:ext cx="9410700" cy="323850"/>
+          </a:xfrm>
+          <a:prstGeom xmlns:a="http://schemas.openxmlformats.org/drawingml/2006/main" prst="rect">
+            <a:avLst/>
+          </a:prstGeom>
+          <a:noFill xmlns:a="http://schemas.openxmlformats.org/drawingml/2006/main"/>
+          <a:ln xmlns:a="http://schemas.openxmlformats.org/drawingml/2006/main" w="0">
+            <a:noFill/>
+            <a:prstDash val="solid"/>
+          </a:ln>
+        </p:spPr>
+        <p:txBody>
+          <a:bodyPr xmlns:a="http://schemas.openxmlformats.org/drawingml/2006/main" lIns="0" tIns="0" rIns="0" bIns="0" anchor="t">
+            <a:normAutofit fontScale="92943"/>
+          </a:bodyPr>
+          <a:lstStyle xmlns:a="http://schemas.openxmlformats.org/drawingml/2006/main"/>
+          <a:p xmlns:a="http://schemas.openxmlformats.org/drawingml/2006/main">
+            <a:pPr algn="ctr">
+              <a:lnSpc>
+                <a:spcPct val="108000"/>
+              </a:lnSpc>
+              <a:buNone/>
+              <a:defRPr sz="1650" b="1" i="0">
+                <a:solidFill>
+                  <a:srgbClr val="17212B"/>
+                </a:solidFill>
+                <a:latin typeface="PingFang SC"/>
+                <a:ea typeface="PingFang SC"/>
+                <a:cs typeface="PingFang SC"/>
+              </a:defRPr>
+            </a:pPr>
+            <a:r>
+              <a:rPr sz="1650" b="1" i="0">
+                <a:solidFill>
+                  <a:srgbClr val="17212B"/>
+                </a:solidFill>
+                <a:latin typeface="PingFang SC"/>
+                <a:ea typeface="PingFang SC"/>
+                <a:cs typeface="PingFang SC"/>
+              </a:rPr>
+              <a:t>定位：真实科研中的 exploratory analysis workspace，让研究者更快进入问题，同时保留证据和可复核性。</a:t>
+            </a:r>
+          </a:p>
+        </p:txBody>
+      </p:sp>
+      <p:sp>
+        <p:nvSpPr>
+          <p:cNvPr id="19" name="">
+            <a:extLst xmlns:a="http://schemas.openxmlformats.org/drawingml/2006/main">
+              <a:ext uri="{FF2B5EF4-FFF2-40B4-BE49-F238E27FC236}">
+                <a16:creationId xmlns:a16="http://schemas.microsoft.com/office/drawing/2014/main" id="{EE0B62C5-4F00-45AF-95B3-82DC3263421A}"/>
               </a:ext>
             </a:extLst>
           </p:cNvPr>
@@ -11936,10 +12446,10 @@
       </p:sp>
       <p:sp>
         <p:nvSpPr>
-          <p:cNvPr id="11" name="">
-            <a:extLst xmlns:a="http://schemas.openxmlformats.org/drawingml/2006/main">
-              <a:ext uri="{FF2B5EF4-FFF2-40B4-BE49-F238E27FC236}">
-                <a16:creationId xmlns:a16="http://schemas.microsoft.com/office/drawing/2014/main" id="{6ABE88E0-098F-4F3F-8DD4-1492AFC292EE}"/>
+          <p:cNvPr id="20" name="">
+            <a:extLst xmlns:a="http://schemas.openxmlformats.org/drawingml/2006/main">
+              <a:ext uri="{FF2B5EF4-FFF2-40B4-BE49-F238E27FC236}">
+                <a16:creationId xmlns:a16="http://schemas.microsoft.com/office/drawing/2014/main" id="{C6F06862-5C1E-476E-95FA-FFD3C30EAB67}"/>
               </a:ext>
             </a:extLst>
           </p:cNvPr>
@@ -11991,17 +12501,17 @@
                 <a:ea typeface="PingFang SC"/>
                 <a:cs typeface="PingFang SC"/>
               </a:rPr>
-              <a:t>Interpretation guide for the real GSE278603 quick run.</a:t>
+              <a:t>Application scenarios derived from common spatial transcriptomics research use cases.</a:t>
             </a:r>
           </a:p>
         </p:txBody>
       </p:sp>
       <p:sp>
         <p:nvSpPr>
-          <p:cNvPr id="12" name="">
-            <a:extLst xmlns:a="http://schemas.openxmlformats.org/drawingml/2006/main">
-              <a:ext uri="{FF2B5EF4-FFF2-40B4-BE49-F238E27FC236}">
-                <a16:creationId xmlns:a16="http://schemas.microsoft.com/office/drawing/2014/main" id="{1EE57992-2202-49DE-94A1-9F4BD33E9203}"/>
+          <p:cNvPr id="21" name="">
+            <a:extLst xmlns:a="http://schemas.openxmlformats.org/drawingml/2006/main">
+              <a:ext uri="{FF2B5EF4-FFF2-40B4-BE49-F238E27FC236}">
+                <a16:creationId xmlns:a16="http://schemas.microsoft.com/office/drawing/2014/main" id="{E4E82212-FB1C-4722-874F-6526F237FB57}"/>
               </a:ext>
             </a:extLst>
           </p:cNvPr>
@@ -12061,7 +12571,7 @@
     </p:spTree>
     <p:extLst>
       <p:ext uri="{BB962C8B-B14F-4D97-AF65-F5344CB8AC3E}">
-        <p14:creationId xmlns:p14="http://schemas.microsoft.com/office/powerpoint/2010/main" val="1490332863"/>
+        <p14:creationId xmlns:p14="http://schemas.microsoft.com/office/powerpoint/2010/main" val="1022058353"/>
       </p:ext>
     </p:extLst>
   </p:cSld>
@@ -12069,1309 +12579,6 @@
 </file>
 
 <file path=ppt/slides/slide16.xml><?xml version="1.0" encoding="utf-8"?>
-<p:sld xmlns:p="http://schemas.openxmlformats.org/presentationml/2006/main">
-  <p:cSld>
-    <p:bg>
-      <p:bgPr>
-        <a:solidFill xmlns:a="http://schemas.openxmlformats.org/drawingml/2006/main">
-          <a:srgbClr val="FFFFFF"/>
-        </a:solidFill>
-      </p:bgPr>
-    </p:bg>
-    <p:spTree>
-      <p:nvGrpSpPr>
-        <p:cNvPr id="1" name=""/>
-        <p:cNvGrpSpPr/>
-        <p:nvPr/>
-      </p:nvGrpSpPr>
-      <p:grpSpPr>
-        <a:xfrm xmlns:a="http://schemas.openxmlformats.org/drawingml/2006/main"/>
-      </p:grpSpPr>
-      <p:sp>
-        <p:nvSpPr>
-          <p:cNvPr id="1" name="">
-            <a:extLst xmlns:a="http://schemas.openxmlformats.org/drawingml/2006/main">
-              <a:ext uri="{FF2B5EF4-FFF2-40B4-BE49-F238E27FC236}">
-                <a16:creationId xmlns:a16="http://schemas.microsoft.com/office/drawing/2014/main" id="{F08CDAF8-8E38-4D7F-96E6-F673D4259727}"/>
-              </a:ext>
-            </a:extLst>
-          </p:cNvPr>
-          <p:cNvSpPr>
-            <a:spLocks xmlns:a="http://schemas.openxmlformats.org/drawingml/2006/main" noGrp="1"/>
-          </p:cNvSpPr>
-          <p:nvPr/>
-        </p:nvSpPr>
-        <p:spPr>
-          <a:xfrm xmlns:a="http://schemas.openxmlformats.org/drawingml/2006/main">
-            <a:off x="609600" y="304800"/>
-            <a:ext cx="4953000" cy="209550"/>
-          </a:xfrm>
-          <a:prstGeom xmlns:a="http://schemas.openxmlformats.org/drawingml/2006/main" prst="rect">
-            <a:avLst/>
-          </a:prstGeom>
-          <a:noFill xmlns:a="http://schemas.openxmlformats.org/drawingml/2006/main"/>
-          <a:ln xmlns:a="http://schemas.openxmlformats.org/drawingml/2006/main" w="0">
-            <a:noFill/>
-            <a:prstDash val="solid"/>
-          </a:ln>
-        </p:spPr>
-        <p:txBody>
-          <a:bodyPr xmlns:a="http://schemas.openxmlformats.org/drawingml/2006/main" lIns="0" tIns="0" rIns="0" bIns="0" anchor="t">
-            <a:normAutofit fontScale="100000"/>
-          </a:bodyPr>
-          <a:lstStyle xmlns:a="http://schemas.openxmlformats.org/drawingml/2006/main"/>
-          <a:p xmlns:a="http://schemas.openxmlformats.org/drawingml/2006/main">
-            <a:pPr algn="l">
-              <a:lnSpc>
-                <a:spcPct val="108000"/>
-              </a:lnSpc>
-              <a:buNone/>
-              <a:defRPr sz="1013" b="1" i="0">
-                <a:solidFill>
-                  <a:srgbClr val="0F766E"/>
-                </a:solidFill>
-                <a:latin typeface="PingFang SC"/>
-                <a:ea typeface="PingFang SC"/>
-                <a:cs typeface="PingFang SC"/>
-              </a:defRPr>
-            </a:pPr>
-            <a:r>
-              <a:rPr sz="1013" b="1" i="0">
-                <a:solidFill>
-                  <a:srgbClr val="0F766E"/>
-                </a:solidFill>
-                <a:latin typeface="PingFang SC"/>
-                <a:ea typeface="PingFang SC"/>
-                <a:cs typeface="PingFang SC"/>
-              </a:rPr>
-              <a:t>RESEARCH USE CASES</a:t>
-            </a:r>
-          </a:p>
-        </p:txBody>
-      </p:sp>
-      <p:sp>
-        <p:nvSpPr>
-          <p:cNvPr id="2" name="">
-            <a:extLst xmlns:a="http://schemas.openxmlformats.org/drawingml/2006/main">
-              <a:ext uri="{FF2B5EF4-FFF2-40B4-BE49-F238E27FC236}">
-                <a16:creationId xmlns:a16="http://schemas.microsoft.com/office/drawing/2014/main" id="{BF8685D2-BFB7-4D4C-B334-1787B177A528}"/>
-              </a:ext>
-            </a:extLst>
-          </p:cNvPr>
-          <p:cNvSpPr>
-            <a:spLocks xmlns:a="http://schemas.openxmlformats.org/drawingml/2006/main" noGrp="1"/>
-          </p:cNvSpPr>
-          <p:nvPr/>
-        </p:nvSpPr>
-        <p:spPr>
-          <a:xfrm xmlns:a="http://schemas.openxmlformats.org/drawingml/2006/main">
-            <a:off x="609600" y="552450"/>
-            <a:ext cx="9334500" cy="552450"/>
-          </a:xfrm>
-          <a:prstGeom xmlns:a="http://schemas.openxmlformats.org/drawingml/2006/main" prst="rect">
-            <a:avLst/>
-          </a:prstGeom>
-          <a:noFill xmlns:a="http://schemas.openxmlformats.org/drawingml/2006/main"/>
-          <a:ln xmlns:a="http://schemas.openxmlformats.org/drawingml/2006/main" w="0">
-            <a:noFill/>
-            <a:prstDash val="solid"/>
-          </a:ln>
-        </p:spPr>
-        <p:txBody>
-          <a:bodyPr xmlns:a="http://schemas.openxmlformats.org/drawingml/2006/main" lIns="0" tIns="0" rIns="0" bIns="0" anchor="t">
-            <a:normAutofit fontScale="100000"/>
-          </a:bodyPr>
-          <a:lstStyle xmlns:a="http://schemas.openxmlformats.org/drawingml/2006/main"/>
-          <a:p xmlns:a="http://schemas.openxmlformats.org/drawingml/2006/main">
-            <a:pPr algn="l">
-              <a:lnSpc>
-                <a:spcPct val="108000"/>
-              </a:lnSpc>
-              <a:buNone/>
-              <a:defRPr sz="3000" b="1" i="0">
-                <a:solidFill>
-                  <a:srgbClr val="17212B"/>
-                </a:solidFill>
-                <a:latin typeface="PingFang SC"/>
-                <a:ea typeface="PingFang SC"/>
-                <a:cs typeface="PingFang SC"/>
-              </a:defRPr>
-            </a:pPr>
-            <a:r>
-              <a:rPr sz="3000" b="1" i="0">
-                <a:solidFill>
-                  <a:srgbClr val="17212B"/>
-                </a:solidFill>
-                <a:latin typeface="PingFang SC"/>
-                <a:ea typeface="PingFang SC"/>
-                <a:cs typeface="PingFang SC"/>
-              </a:rPr>
-              <a:t>面向真实科研场景的应用</a:t>
-            </a:r>
-          </a:p>
-        </p:txBody>
-      </p:sp>
-      <p:sp>
-        <p:nvSpPr>
-          <p:cNvPr id="3" name="">
-            <a:extLst xmlns:a="http://schemas.openxmlformats.org/drawingml/2006/main">
-              <a:ext uri="{FF2B5EF4-FFF2-40B4-BE49-F238E27FC236}">
-                <a16:creationId xmlns:a16="http://schemas.microsoft.com/office/drawing/2014/main" id="{816CF460-0C5D-41C2-B427-5231798E33EE}"/>
-              </a:ext>
-            </a:extLst>
-          </p:cNvPr>
-          <p:cNvSpPr>
-            <a:spLocks xmlns:a="http://schemas.openxmlformats.org/drawingml/2006/main" noGrp="1"/>
-          </p:cNvSpPr>
-          <p:nvPr/>
-        </p:nvSpPr>
-        <p:spPr>
-          <a:xfrm xmlns:a="http://schemas.openxmlformats.org/drawingml/2006/main">
-            <a:off x="819150" y="1581150"/>
-            <a:ext cx="2476500" cy="1390650"/>
-          </a:xfrm>
-          <a:prstGeom xmlns:a="http://schemas.openxmlformats.org/drawingml/2006/main" prst="roundRect">
-            <a:avLst>
-              <a:gd name="adj" fmla="val 8219"/>
-            </a:avLst>
-          </a:prstGeom>
-          <a:solidFill xmlns:a="http://schemas.openxmlformats.org/drawingml/2006/main">
-            <a:srgbClr val="E9F5F2"/>
-          </a:solidFill>
-          <a:ln xmlns:a="http://schemas.openxmlformats.org/drawingml/2006/main" w="9525">
-            <a:solidFill>
-              <a:srgbClr val="D7E4E0"/>
-            </a:solidFill>
-            <a:prstDash val="solid"/>
-          </a:ln>
-        </p:spPr>
-        <p:style>
-          <a:lnRef xmlns:a="http://schemas.openxmlformats.org/drawingml/2006/main" idx="0"/>
-          <a:fillRef xmlns:a="http://schemas.openxmlformats.org/drawingml/2006/main" idx="0"/>
-          <a:effectRef xmlns:a="http://schemas.openxmlformats.org/drawingml/2006/main" idx="4"/>
-          <a:fontRef xmlns:a="http://schemas.openxmlformats.org/drawingml/2006/main" idx="major"/>
-        </p:style>
-      </p:sp>
-      <p:sp>
-        <p:nvSpPr>
-          <p:cNvPr id="4" name="">
-            <a:extLst xmlns:a="http://schemas.openxmlformats.org/drawingml/2006/main">
-              <a:ext uri="{FF2B5EF4-FFF2-40B4-BE49-F238E27FC236}">
-                <a16:creationId xmlns:a16="http://schemas.microsoft.com/office/drawing/2014/main" id="{2C6DB7D3-B959-4592-B562-E53DE718C99E}"/>
-              </a:ext>
-            </a:extLst>
-          </p:cNvPr>
-          <p:cNvSpPr>
-            <a:spLocks xmlns:a="http://schemas.openxmlformats.org/drawingml/2006/main" noGrp="1"/>
-          </p:cNvSpPr>
-          <p:nvPr/>
-        </p:nvSpPr>
-        <p:spPr>
-          <a:xfrm xmlns:a="http://schemas.openxmlformats.org/drawingml/2006/main">
-            <a:off x="1009650" y="1752600"/>
-            <a:ext cx="2095500" cy="285750"/>
-          </a:xfrm>
-          <a:prstGeom xmlns:a="http://schemas.openxmlformats.org/drawingml/2006/main" prst="rect">
-            <a:avLst/>
-          </a:prstGeom>
-          <a:noFill xmlns:a="http://schemas.openxmlformats.org/drawingml/2006/main"/>
-          <a:ln xmlns:a="http://schemas.openxmlformats.org/drawingml/2006/main" w="0">
-            <a:noFill/>
-            <a:prstDash val="solid"/>
-          </a:ln>
-        </p:spPr>
-        <p:txBody>
-          <a:bodyPr xmlns:a="http://schemas.openxmlformats.org/drawingml/2006/main" lIns="0" tIns="0" rIns="0" bIns="0" anchor="t">
-            <a:normAutofit fontScale="100000"/>
-          </a:bodyPr>
-          <a:lstStyle xmlns:a="http://schemas.openxmlformats.org/drawingml/2006/main"/>
-          <a:p xmlns:a="http://schemas.openxmlformats.org/drawingml/2006/main">
-            <a:pPr algn="l">
-              <a:lnSpc>
-                <a:spcPct val="108000"/>
-              </a:lnSpc>
-              <a:buNone/>
-              <a:defRPr sz="1575" b="1" i="0">
-                <a:solidFill>
-                  <a:srgbClr val="0F766E"/>
-                </a:solidFill>
-                <a:latin typeface="PingFang SC"/>
-                <a:ea typeface="PingFang SC"/>
-                <a:cs typeface="PingFang SC"/>
-              </a:defRPr>
-            </a:pPr>
-            <a:r>
-              <a:rPr sz="1575" b="1" i="0">
-                <a:solidFill>
-                  <a:srgbClr val="0F766E"/>
-                </a:solidFill>
-                <a:latin typeface="PingFang SC"/>
-                <a:ea typeface="PingFang SC"/>
-                <a:cs typeface="PingFang SC"/>
-              </a:rPr>
-              <a:t>发育生物学</a:t>
-            </a:r>
-          </a:p>
-        </p:txBody>
-      </p:sp>
-      <p:sp>
-        <p:nvSpPr>
-          <p:cNvPr id="5" name="">
-            <a:extLst xmlns:a="http://schemas.openxmlformats.org/drawingml/2006/main">
-              <a:ext uri="{FF2B5EF4-FFF2-40B4-BE49-F238E27FC236}">
-                <a16:creationId xmlns:a16="http://schemas.microsoft.com/office/drawing/2014/main" id="{FDB3678F-D970-4A5E-BF95-1AE46058DAE3}"/>
-              </a:ext>
-            </a:extLst>
-          </p:cNvPr>
-          <p:cNvSpPr>
-            <a:spLocks xmlns:a="http://schemas.openxmlformats.org/drawingml/2006/main" noGrp="1"/>
-          </p:cNvSpPr>
-          <p:nvPr/>
-        </p:nvSpPr>
-        <p:spPr>
-          <a:xfrm xmlns:a="http://schemas.openxmlformats.org/drawingml/2006/main">
-            <a:off x="1009650" y="2133600"/>
-            <a:ext cx="2095500" cy="723900"/>
-          </a:xfrm>
-          <a:prstGeom xmlns:a="http://schemas.openxmlformats.org/drawingml/2006/main" prst="rect">
-            <a:avLst/>
-          </a:prstGeom>
-          <a:noFill xmlns:a="http://schemas.openxmlformats.org/drawingml/2006/main"/>
-          <a:ln xmlns:a="http://schemas.openxmlformats.org/drawingml/2006/main" w="0">
-            <a:noFill/>
-            <a:prstDash val="solid"/>
-          </a:ln>
-        </p:spPr>
-        <p:txBody>
-          <a:bodyPr xmlns:a="http://schemas.openxmlformats.org/drawingml/2006/main" lIns="0" tIns="0" rIns="0" bIns="0" anchor="t">
-            <a:normAutofit fontScale="100000"/>
-          </a:bodyPr>
-          <a:lstStyle xmlns:a="http://schemas.openxmlformats.org/drawingml/2006/main"/>
-          <a:p xmlns:a="http://schemas.openxmlformats.org/drawingml/2006/main">
-            <a:pPr algn="l">
-              <a:lnSpc>
-                <a:spcPct val="108000"/>
-              </a:lnSpc>
-              <a:buNone/>
-              <a:defRPr sz="1275" b="0" i="0">
-                <a:solidFill>
-                  <a:srgbClr val="475569"/>
-                </a:solidFill>
-                <a:latin typeface="PingFang SC"/>
-                <a:ea typeface="PingFang SC"/>
-                <a:cs typeface="PingFang SC"/>
-              </a:defRPr>
-            </a:pPr>
-            <a:r>
-              <a:rPr sz="1275" b="0" i="0">
-                <a:solidFill>
-                  <a:srgbClr val="475569"/>
-                </a:solidFill>
-                <a:latin typeface="PingFang SC"/>
-                <a:ea typeface="PingFang SC"/>
-                <a:cs typeface="PingFang SC"/>
-              </a:rPr>
-              <a:t>比较胚胎阶段空间区域</a:t>
-            </a:r>
-          </a:p>
-          <a:p xmlns:a="http://schemas.openxmlformats.org/drawingml/2006/main">
-            <a:pPr algn="l">
-              <a:lnSpc>
-                <a:spcPct val="108000"/>
-              </a:lnSpc>
-              <a:buNone/>
-              <a:defRPr sz="1275" b="0" i="0">
-                <a:solidFill>
-                  <a:srgbClr val="475569"/>
-                </a:solidFill>
-                <a:latin typeface="PingFang SC"/>
-                <a:ea typeface="PingFang SC"/>
-                <a:cs typeface="PingFang SC"/>
-              </a:defRPr>
-            </a:pPr>
-            <a:r>
-              <a:rPr sz="1275" b="0" i="0">
-                <a:solidFill>
-                  <a:srgbClr val="475569"/>
-                </a:solidFill>
-                <a:latin typeface="PingFang SC"/>
-                <a:ea typeface="PingFang SC"/>
-                <a:cs typeface="PingFang SC"/>
-              </a:rPr>
-              <a:t>查看 Sox17、T、Mesp1 等基因</a:t>
-            </a:r>
-          </a:p>
-        </p:txBody>
-      </p:sp>
-      <p:sp>
-        <p:nvSpPr>
-          <p:cNvPr id="6" name="">
-            <a:extLst xmlns:a="http://schemas.openxmlformats.org/drawingml/2006/main">
-              <a:ext uri="{FF2B5EF4-FFF2-40B4-BE49-F238E27FC236}">
-                <a16:creationId xmlns:a16="http://schemas.microsoft.com/office/drawing/2014/main" id="{EB2E0C5E-AA34-4D6B-99F3-D46F57911347}"/>
-              </a:ext>
-            </a:extLst>
-          </p:cNvPr>
-          <p:cNvSpPr>
-            <a:spLocks xmlns:a="http://schemas.openxmlformats.org/drawingml/2006/main" noGrp="1"/>
-          </p:cNvSpPr>
-          <p:nvPr/>
-        </p:nvSpPr>
-        <p:spPr>
-          <a:xfrm xmlns:a="http://schemas.openxmlformats.org/drawingml/2006/main">
-            <a:off x="3581400" y="1581150"/>
-            <a:ext cx="2476500" cy="1390650"/>
-          </a:xfrm>
-          <a:prstGeom xmlns:a="http://schemas.openxmlformats.org/drawingml/2006/main" prst="roundRect">
-            <a:avLst>
-              <a:gd name="adj" fmla="val 8219"/>
-            </a:avLst>
-          </a:prstGeom>
-          <a:solidFill xmlns:a="http://schemas.openxmlformats.org/drawingml/2006/main">
-            <a:srgbClr val="F6FAF8"/>
-          </a:solidFill>
-          <a:ln xmlns:a="http://schemas.openxmlformats.org/drawingml/2006/main" w="9525">
-            <a:solidFill>
-              <a:srgbClr val="D7E4E0"/>
-            </a:solidFill>
-            <a:prstDash val="solid"/>
-          </a:ln>
-        </p:spPr>
-        <p:style>
-          <a:lnRef xmlns:a="http://schemas.openxmlformats.org/drawingml/2006/main" idx="0"/>
-          <a:fillRef xmlns:a="http://schemas.openxmlformats.org/drawingml/2006/main" idx="0"/>
-          <a:effectRef xmlns:a="http://schemas.openxmlformats.org/drawingml/2006/main" idx="4"/>
-          <a:fontRef xmlns:a="http://schemas.openxmlformats.org/drawingml/2006/main" idx="major"/>
-        </p:style>
-      </p:sp>
-      <p:sp>
-        <p:nvSpPr>
-          <p:cNvPr id="7" name="">
-            <a:extLst xmlns:a="http://schemas.openxmlformats.org/drawingml/2006/main">
-              <a:ext uri="{FF2B5EF4-FFF2-40B4-BE49-F238E27FC236}">
-                <a16:creationId xmlns:a16="http://schemas.microsoft.com/office/drawing/2014/main" id="{7F60CFFD-66A1-4446-BA56-09AE35BF78FF}"/>
-              </a:ext>
-            </a:extLst>
-          </p:cNvPr>
-          <p:cNvSpPr>
-            <a:spLocks xmlns:a="http://schemas.openxmlformats.org/drawingml/2006/main" noGrp="1"/>
-          </p:cNvSpPr>
-          <p:nvPr/>
-        </p:nvSpPr>
-        <p:spPr>
-          <a:xfrm xmlns:a="http://schemas.openxmlformats.org/drawingml/2006/main">
-            <a:off x="3771900" y="1752600"/>
-            <a:ext cx="2095500" cy="285750"/>
-          </a:xfrm>
-          <a:prstGeom xmlns:a="http://schemas.openxmlformats.org/drawingml/2006/main" prst="rect">
-            <a:avLst/>
-          </a:prstGeom>
-          <a:noFill xmlns:a="http://schemas.openxmlformats.org/drawingml/2006/main"/>
-          <a:ln xmlns:a="http://schemas.openxmlformats.org/drawingml/2006/main" w="0">
-            <a:noFill/>
-            <a:prstDash val="solid"/>
-          </a:ln>
-        </p:spPr>
-        <p:txBody>
-          <a:bodyPr xmlns:a="http://schemas.openxmlformats.org/drawingml/2006/main" lIns="0" tIns="0" rIns="0" bIns="0" anchor="t">
-            <a:normAutofit fontScale="100000"/>
-          </a:bodyPr>
-          <a:lstStyle xmlns:a="http://schemas.openxmlformats.org/drawingml/2006/main"/>
-          <a:p xmlns:a="http://schemas.openxmlformats.org/drawingml/2006/main">
-            <a:pPr algn="l">
-              <a:lnSpc>
-                <a:spcPct val="108000"/>
-              </a:lnSpc>
-              <a:buNone/>
-              <a:defRPr sz="1575" b="1" i="0">
-                <a:solidFill>
-                  <a:srgbClr val="0F766E"/>
-                </a:solidFill>
-                <a:latin typeface="PingFang SC"/>
-                <a:ea typeface="PingFang SC"/>
-                <a:cs typeface="PingFang SC"/>
-              </a:defRPr>
-            </a:pPr>
-            <a:r>
-              <a:rPr sz="1575" b="1" i="0">
-                <a:solidFill>
-                  <a:srgbClr val="0F766E"/>
-                </a:solidFill>
-                <a:latin typeface="PingFang SC"/>
-                <a:ea typeface="PingFang SC"/>
-                <a:cs typeface="PingFang SC"/>
-              </a:rPr>
-              <a:t>肿瘤微环境</a:t>
-            </a:r>
-          </a:p>
-        </p:txBody>
-      </p:sp>
-      <p:sp>
-        <p:nvSpPr>
-          <p:cNvPr id="8" name="">
-            <a:extLst xmlns:a="http://schemas.openxmlformats.org/drawingml/2006/main">
-              <a:ext uri="{FF2B5EF4-FFF2-40B4-BE49-F238E27FC236}">
-                <a16:creationId xmlns:a16="http://schemas.microsoft.com/office/drawing/2014/main" id="{DA064A20-DCD8-47A0-8781-86C4962F4433}"/>
-              </a:ext>
-            </a:extLst>
-          </p:cNvPr>
-          <p:cNvSpPr>
-            <a:spLocks xmlns:a="http://schemas.openxmlformats.org/drawingml/2006/main" noGrp="1"/>
-          </p:cNvSpPr>
-          <p:nvPr/>
-        </p:nvSpPr>
-        <p:spPr>
-          <a:xfrm xmlns:a="http://schemas.openxmlformats.org/drawingml/2006/main">
-            <a:off x="3771900" y="2133600"/>
-            <a:ext cx="2095500" cy="723900"/>
-          </a:xfrm>
-          <a:prstGeom xmlns:a="http://schemas.openxmlformats.org/drawingml/2006/main" prst="rect">
-            <a:avLst/>
-          </a:prstGeom>
-          <a:noFill xmlns:a="http://schemas.openxmlformats.org/drawingml/2006/main"/>
-          <a:ln xmlns:a="http://schemas.openxmlformats.org/drawingml/2006/main" w="0">
-            <a:noFill/>
-            <a:prstDash val="solid"/>
-          </a:ln>
-        </p:spPr>
-        <p:txBody>
-          <a:bodyPr xmlns:a="http://schemas.openxmlformats.org/drawingml/2006/main" lIns="0" tIns="0" rIns="0" bIns="0" anchor="t">
-            <a:normAutofit fontScale="100000"/>
-          </a:bodyPr>
-          <a:lstStyle xmlns:a="http://schemas.openxmlformats.org/drawingml/2006/main"/>
-          <a:p xmlns:a="http://schemas.openxmlformats.org/drawingml/2006/main">
-            <a:pPr algn="l">
-              <a:lnSpc>
-                <a:spcPct val="108000"/>
-              </a:lnSpc>
-              <a:buNone/>
-              <a:defRPr sz="1275" b="0" i="0">
-                <a:solidFill>
-                  <a:srgbClr val="475569"/>
-                </a:solidFill>
-                <a:latin typeface="PingFang SC"/>
-                <a:ea typeface="PingFang SC"/>
-                <a:cs typeface="PingFang SC"/>
-              </a:defRPr>
-            </a:pPr>
-            <a:r>
-              <a:rPr sz="1275" b="0" i="0">
-                <a:solidFill>
-                  <a:srgbClr val="475569"/>
-                </a:solidFill>
-                <a:latin typeface="PingFang SC"/>
-                <a:ea typeface="PingFang SC"/>
-                <a:cs typeface="PingFang SC"/>
-              </a:rPr>
-              <a:t>识别 tumor / immune / stromal regions</a:t>
-            </a:r>
-          </a:p>
-          <a:p xmlns:a="http://schemas.openxmlformats.org/drawingml/2006/main">
-            <a:pPr algn="l">
-              <a:lnSpc>
-                <a:spcPct val="108000"/>
-              </a:lnSpc>
-              <a:buNone/>
-              <a:defRPr sz="1275" b="0" i="0">
-                <a:solidFill>
-                  <a:srgbClr val="475569"/>
-                </a:solidFill>
-                <a:latin typeface="PingFang SC"/>
-                <a:ea typeface="PingFang SC"/>
-                <a:cs typeface="PingFang SC"/>
-              </a:defRPr>
-            </a:pPr>
-            <a:r>
-              <a:rPr sz="1275" b="0" i="0">
-                <a:solidFill>
-                  <a:srgbClr val="475569"/>
-                </a:solidFill>
-                <a:latin typeface="PingFang SC"/>
-                <a:ea typeface="PingFang SC"/>
-                <a:cs typeface="PingFang SC"/>
-              </a:rPr>
-              <a:t>分析 marker 与邻域富集</a:t>
-            </a:r>
-          </a:p>
-        </p:txBody>
-      </p:sp>
-      <p:sp>
-        <p:nvSpPr>
-          <p:cNvPr id="9" name="">
-            <a:extLst xmlns:a="http://schemas.openxmlformats.org/drawingml/2006/main">
-              <a:ext uri="{FF2B5EF4-FFF2-40B4-BE49-F238E27FC236}">
-                <a16:creationId xmlns:a16="http://schemas.microsoft.com/office/drawing/2014/main" id="{8A33CA5E-C05A-4616-8B0E-70377B776681}"/>
-              </a:ext>
-            </a:extLst>
-          </p:cNvPr>
-          <p:cNvSpPr>
-            <a:spLocks xmlns:a="http://schemas.openxmlformats.org/drawingml/2006/main" noGrp="1"/>
-          </p:cNvSpPr>
-          <p:nvPr/>
-        </p:nvSpPr>
-        <p:spPr>
-          <a:xfrm xmlns:a="http://schemas.openxmlformats.org/drawingml/2006/main">
-            <a:off x="6343650" y="1581150"/>
-            <a:ext cx="2476500" cy="1390650"/>
-          </a:xfrm>
-          <a:prstGeom xmlns:a="http://schemas.openxmlformats.org/drawingml/2006/main" prst="roundRect">
-            <a:avLst>
-              <a:gd name="adj" fmla="val 8219"/>
-            </a:avLst>
-          </a:prstGeom>
-          <a:solidFill xmlns:a="http://schemas.openxmlformats.org/drawingml/2006/main">
-            <a:srgbClr val="F6FAF8"/>
-          </a:solidFill>
-          <a:ln xmlns:a="http://schemas.openxmlformats.org/drawingml/2006/main" w="9525">
-            <a:solidFill>
-              <a:srgbClr val="D7E4E0"/>
-            </a:solidFill>
-            <a:prstDash val="solid"/>
-          </a:ln>
-        </p:spPr>
-        <p:style>
-          <a:lnRef xmlns:a="http://schemas.openxmlformats.org/drawingml/2006/main" idx="0"/>
-          <a:fillRef xmlns:a="http://schemas.openxmlformats.org/drawingml/2006/main" idx="0"/>
-          <a:effectRef xmlns:a="http://schemas.openxmlformats.org/drawingml/2006/main" idx="4"/>
-          <a:fontRef xmlns:a="http://schemas.openxmlformats.org/drawingml/2006/main" idx="major"/>
-        </p:style>
-      </p:sp>
-      <p:sp>
-        <p:nvSpPr>
-          <p:cNvPr id="10" name="">
-            <a:extLst xmlns:a="http://schemas.openxmlformats.org/drawingml/2006/main">
-              <a:ext uri="{FF2B5EF4-FFF2-40B4-BE49-F238E27FC236}">
-                <a16:creationId xmlns:a16="http://schemas.microsoft.com/office/drawing/2014/main" id="{A3A5FF67-2D70-4231-B727-B3EF56274D8C}"/>
-              </a:ext>
-            </a:extLst>
-          </p:cNvPr>
-          <p:cNvSpPr>
-            <a:spLocks xmlns:a="http://schemas.openxmlformats.org/drawingml/2006/main" noGrp="1"/>
-          </p:cNvSpPr>
-          <p:nvPr/>
-        </p:nvSpPr>
-        <p:spPr>
-          <a:xfrm xmlns:a="http://schemas.openxmlformats.org/drawingml/2006/main">
-            <a:off x="6534150" y="1752600"/>
-            <a:ext cx="2095500" cy="285750"/>
-          </a:xfrm>
-          <a:prstGeom xmlns:a="http://schemas.openxmlformats.org/drawingml/2006/main" prst="rect">
-            <a:avLst/>
-          </a:prstGeom>
-          <a:noFill xmlns:a="http://schemas.openxmlformats.org/drawingml/2006/main"/>
-          <a:ln xmlns:a="http://schemas.openxmlformats.org/drawingml/2006/main" w="0">
-            <a:noFill/>
-            <a:prstDash val="solid"/>
-          </a:ln>
-        </p:spPr>
-        <p:txBody>
-          <a:bodyPr xmlns:a="http://schemas.openxmlformats.org/drawingml/2006/main" lIns="0" tIns="0" rIns="0" bIns="0" anchor="t">
-            <a:normAutofit fontScale="100000"/>
-          </a:bodyPr>
-          <a:lstStyle xmlns:a="http://schemas.openxmlformats.org/drawingml/2006/main"/>
-          <a:p xmlns:a="http://schemas.openxmlformats.org/drawingml/2006/main">
-            <a:pPr algn="l">
-              <a:lnSpc>
-                <a:spcPct val="108000"/>
-              </a:lnSpc>
-              <a:buNone/>
-              <a:defRPr sz="1575" b="1" i="0">
-                <a:solidFill>
-                  <a:srgbClr val="0F766E"/>
-                </a:solidFill>
-                <a:latin typeface="PingFang SC"/>
-                <a:ea typeface="PingFang SC"/>
-                <a:cs typeface="PingFang SC"/>
-              </a:defRPr>
-            </a:pPr>
-            <a:r>
-              <a:rPr sz="1575" b="1" i="0">
-                <a:solidFill>
-                  <a:srgbClr val="0F766E"/>
-                </a:solidFill>
-                <a:latin typeface="PingFang SC"/>
-                <a:ea typeface="PingFang SC"/>
-                <a:cs typeface="PingFang SC"/>
-              </a:rPr>
-              <a:t>病理切片探索</a:t>
-            </a:r>
-          </a:p>
-        </p:txBody>
-      </p:sp>
-      <p:sp>
-        <p:nvSpPr>
-          <p:cNvPr id="11" name="">
-            <a:extLst xmlns:a="http://schemas.openxmlformats.org/drawingml/2006/main">
-              <a:ext uri="{FF2B5EF4-FFF2-40B4-BE49-F238E27FC236}">
-                <a16:creationId xmlns:a16="http://schemas.microsoft.com/office/drawing/2014/main" id="{69068732-9E68-48C6-832E-79FCEA528FEA}"/>
-              </a:ext>
-            </a:extLst>
-          </p:cNvPr>
-          <p:cNvSpPr>
-            <a:spLocks xmlns:a="http://schemas.openxmlformats.org/drawingml/2006/main" noGrp="1"/>
-          </p:cNvSpPr>
-          <p:nvPr/>
-        </p:nvSpPr>
-        <p:spPr>
-          <a:xfrm xmlns:a="http://schemas.openxmlformats.org/drawingml/2006/main">
-            <a:off x="6534150" y="2133600"/>
-            <a:ext cx="2095500" cy="723900"/>
-          </a:xfrm>
-          <a:prstGeom xmlns:a="http://schemas.openxmlformats.org/drawingml/2006/main" prst="rect">
-            <a:avLst/>
-          </a:prstGeom>
-          <a:noFill xmlns:a="http://schemas.openxmlformats.org/drawingml/2006/main"/>
-          <a:ln xmlns:a="http://schemas.openxmlformats.org/drawingml/2006/main" w="0">
-            <a:noFill/>
-            <a:prstDash val="solid"/>
-          </a:ln>
-        </p:spPr>
-        <p:txBody>
-          <a:bodyPr xmlns:a="http://schemas.openxmlformats.org/drawingml/2006/main" lIns="0" tIns="0" rIns="0" bIns="0" anchor="t">
-            <a:normAutofit fontScale="100000"/>
-          </a:bodyPr>
-          <a:lstStyle xmlns:a="http://schemas.openxmlformats.org/drawingml/2006/main"/>
-          <a:p xmlns:a="http://schemas.openxmlformats.org/drawingml/2006/main">
-            <a:pPr algn="l">
-              <a:lnSpc>
-                <a:spcPct val="108000"/>
-              </a:lnSpc>
-              <a:buNone/>
-              <a:defRPr sz="1275" b="0" i="0">
-                <a:solidFill>
-                  <a:srgbClr val="475569"/>
-                </a:solidFill>
-                <a:latin typeface="PingFang SC"/>
-                <a:ea typeface="PingFang SC"/>
-                <a:cs typeface="PingFang SC"/>
-              </a:defRPr>
-            </a:pPr>
-            <a:r>
-              <a:rPr sz="1275" b="0" i="0">
-                <a:solidFill>
-                  <a:srgbClr val="475569"/>
-                </a:solidFill>
-                <a:latin typeface="PingFang SC"/>
-                <a:ea typeface="PingFang SC"/>
-                <a:cs typeface="PingFang SC"/>
-              </a:rPr>
-              <a:t>整合组织结构、空间表达和 cluster</a:t>
-            </a:r>
-          </a:p>
-          <a:p xmlns:a="http://schemas.openxmlformats.org/drawingml/2006/main">
-            <a:pPr algn="l">
-              <a:lnSpc>
-                <a:spcPct val="108000"/>
-              </a:lnSpc>
-              <a:buNone/>
-              <a:defRPr sz="1275" b="0" i="0">
-                <a:solidFill>
-                  <a:srgbClr val="475569"/>
-                </a:solidFill>
-                <a:latin typeface="PingFang SC"/>
-                <a:ea typeface="PingFang SC"/>
-                <a:cs typeface="PingFang SC"/>
-              </a:defRPr>
-            </a:pPr>
-            <a:r>
-              <a:rPr sz="1275" b="0" i="0">
-                <a:solidFill>
-                  <a:srgbClr val="475569"/>
-                </a:solidFill>
-                <a:latin typeface="PingFang SC"/>
-                <a:ea typeface="PingFang SC"/>
-                <a:cs typeface="PingFang SC"/>
-              </a:rPr>
-              <a:t>支持初步探索与复核</a:t>
-            </a:r>
-          </a:p>
-        </p:txBody>
-      </p:sp>
-      <p:sp>
-        <p:nvSpPr>
-          <p:cNvPr id="12" name="">
-            <a:extLst xmlns:a="http://schemas.openxmlformats.org/drawingml/2006/main">
-              <a:ext uri="{FF2B5EF4-FFF2-40B4-BE49-F238E27FC236}">
-                <a16:creationId xmlns:a16="http://schemas.microsoft.com/office/drawing/2014/main" id="{EB1869C9-116E-4A46-9AD8-CB8758530EFB}"/>
-              </a:ext>
-            </a:extLst>
-          </p:cNvPr>
-          <p:cNvSpPr>
-            <a:spLocks xmlns:a="http://schemas.openxmlformats.org/drawingml/2006/main" noGrp="1"/>
-          </p:cNvSpPr>
-          <p:nvPr/>
-        </p:nvSpPr>
-        <p:spPr>
-          <a:xfrm xmlns:a="http://schemas.openxmlformats.org/drawingml/2006/main">
-            <a:off x="9105900" y="1581150"/>
-            <a:ext cx="2286000" cy="1390650"/>
-          </a:xfrm>
-          <a:prstGeom xmlns:a="http://schemas.openxmlformats.org/drawingml/2006/main" prst="roundRect">
-            <a:avLst>
-              <a:gd name="adj" fmla="val 8219"/>
-            </a:avLst>
-          </a:prstGeom>
-          <a:solidFill xmlns:a="http://schemas.openxmlformats.org/drawingml/2006/main">
-            <a:srgbClr val="E9F5F2"/>
-          </a:solidFill>
-          <a:ln xmlns:a="http://schemas.openxmlformats.org/drawingml/2006/main" w="9525">
-            <a:solidFill>
-              <a:srgbClr val="D7E4E0"/>
-            </a:solidFill>
-            <a:prstDash val="solid"/>
-          </a:ln>
-        </p:spPr>
-        <p:style>
-          <a:lnRef xmlns:a="http://schemas.openxmlformats.org/drawingml/2006/main" idx="0"/>
-          <a:fillRef xmlns:a="http://schemas.openxmlformats.org/drawingml/2006/main" idx="0"/>
-          <a:effectRef xmlns:a="http://schemas.openxmlformats.org/drawingml/2006/main" idx="4"/>
-          <a:fontRef xmlns:a="http://schemas.openxmlformats.org/drawingml/2006/main" idx="major"/>
-        </p:style>
-      </p:sp>
-      <p:sp>
-        <p:nvSpPr>
-          <p:cNvPr id="13" name="">
-            <a:extLst xmlns:a="http://schemas.openxmlformats.org/drawingml/2006/main">
-              <a:ext uri="{FF2B5EF4-FFF2-40B4-BE49-F238E27FC236}">
-                <a16:creationId xmlns:a16="http://schemas.microsoft.com/office/drawing/2014/main" id="{457B3A12-0199-4A1F-BEF5-90D4BAE3B627}"/>
-              </a:ext>
-            </a:extLst>
-          </p:cNvPr>
-          <p:cNvSpPr>
-            <a:spLocks xmlns:a="http://schemas.openxmlformats.org/drawingml/2006/main" noGrp="1"/>
-          </p:cNvSpPr>
-          <p:nvPr/>
-        </p:nvSpPr>
-        <p:spPr>
-          <a:xfrm xmlns:a="http://schemas.openxmlformats.org/drawingml/2006/main">
-            <a:off x="9296400" y="1752600"/>
-            <a:ext cx="1905000" cy="285750"/>
-          </a:xfrm>
-          <a:prstGeom xmlns:a="http://schemas.openxmlformats.org/drawingml/2006/main" prst="rect">
-            <a:avLst/>
-          </a:prstGeom>
-          <a:noFill xmlns:a="http://schemas.openxmlformats.org/drawingml/2006/main"/>
-          <a:ln xmlns:a="http://schemas.openxmlformats.org/drawingml/2006/main" w="0">
-            <a:noFill/>
-            <a:prstDash val="solid"/>
-          </a:ln>
-        </p:spPr>
-        <p:txBody>
-          <a:bodyPr xmlns:a="http://schemas.openxmlformats.org/drawingml/2006/main" lIns="0" tIns="0" rIns="0" bIns="0" anchor="t">
-            <a:normAutofit fontScale="100000"/>
-          </a:bodyPr>
-          <a:lstStyle xmlns:a="http://schemas.openxmlformats.org/drawingml/2006/main"/>
-          <a:p xmlns:a="http://schemas.openxmlformats.org/drawingml/2006/main">
-            <a:pPr algn="l">
-              <a:lnSpc>
-                <a:spcPct val="108000"/>
-              </a:lnSpc>
-              <a:buNone/>
-              <a:defRPr sz="1575" b="1" i="0">
-                <a:solidFill>
-                  <a:srgbClr val="0F766E"/>
-                </a:solidFill>
-                <a:latin typeface="PingFang SC"/>
-                <a:ea typeface="PingFang SC"/>
-                <a:cs typeface="PingFang SC"/>
-              </a:defRPr>
-            </a:pPr>
-            <a:r>
-              <a:rPr sz="1575" b="1" i="0">
-                <a:solidFill>
-                  <a:srgbClr val="0F766E"/>
-                </a:solidFill>
-                <a:latin typeface="PingFang SC"/>
-                <a:ea typeface="PingFang SC"/>
-                <a:cs typeface="PingFang SC"/>
-              </a:rPr>
-              <a:t>教学与复现</a:t>
-            </a:r>
-          </a:p>
-        </p:txBody>
-      </p:sp>
-      <p:sp>
-        <p:nvSpPr>
-          <p:cNvPr id="14" name="">
-            <a:extLst xmlns:a="http://schemas.openxmlformats.org/drawingml/2006/main">
-              <a:ext uri="{FF2B5EF4-FFF2-40B4-BE49-F238E27FC236}">
-                <a16:creationId xmlns:a16="http://schemas.microsoft.com/office/drawing/2014/main" id="{C6983A64-83CE-4761-A82D-A716522DF8F8}"/>
-              </a:ext>
-            </a:extLst>
-          </p:cNvPr>
-          <p:cNvSpPr>
-            <a:spLocks xmlns:a="http://schemas.openxmlformats.org/drawingml/2006/main" noGrp="1"/>
-          </p:cNvSpPr>
-          <p:nvPr/>
-        </p:nvSpPr>
-        <p:spPr>
-          <a:xfrm xmlns:a="http://schemas.openxmlformats.org/drawingml/2006/main">
-            <a:off x="9296400" y="2133600"/>
-            <a:ext cx="1905000" cy="723900"/>
-          </a:xfrm>
-          <a:prstGeom xmlns:a="http://schemas.openxmlformats.org/drawingml/2006/main" prst="rect">
-            <a:avLst/>
-          </a:prstGeom>
-          <a:noFill xmlns:a="http://schemas.openxmlformats.org/drawingml/2006/main"/>
-          <a:ln xmlns:a="http://schemas.openxmlformats.org/drawingml/2006/main" w="0">
-            <a:noFill/>
-            <a:prstDash val="solid"/>
-          </a:ln>
-        </p:spPr>
-        <p:txBody>
-          <a:bodyPr xmlns:a="http://schemas.openxmlformats.org/drawingml/2006/main" lIns="0" tIns="0" rIns="0" bIns="0" anchor="t">
-            <a:normAutofit fontScale="100000"/>
-          </a:bodyPr>
-          <a:lstStyle xmlns:a="http://schemas.openxmlformats.org/drawingml/2006/main"/>
-          <a:p xmlns:a="http://schemas.openxmlformats.org/drawingml/2006/main">
-            <a:pPr algn="l">
-              <a:lnSpc>
-                <a:spcPct val="108000"/>
-              </a:lnSpc>
-              <a:buNone/>
-              <a:defRPr sz="1275" b="0" i="0">
-                <a:solidFill>
-                  <a:srgbClr val="475569"/>
-                </a:solidFill>
-                <a:latin typeface="PingFang SC"/>
-                <a:ea typeface="PingFang SC"/>
-                <a:cs typeface="PingFang SC"/>
-              </a:defRPr>
-            </a:pPr>
-            <a:r>
-              <a:rPr sz="1275" b="0" i="0">
-                <a:solidFill>
-                  <a:srgbClr val="475569"/>
-                </a:solidFill>
-                <a:latin typeface="PingFang SC"/>
-                <a:ea typeface="PingFang SC"/>
-                <a:cs typeface="PingFang SC"/>
-              </a:rPr>
-              <a:t>自然语言提出问题</a:t>
-            </a:r>
-          </a:p>
-          <a:p xmlns:a="http://schemas.openxmlformats.org/drawingml/2006/main">
-            <a:pPr algn="l">
-              <a:lnSpc>
-                <a:spcPct val="108000"/>
-              </a:lnSpc>
-              <a:buNone/>
-              <a:defRPr sz="1275" b="0" i="0">
-                <a:solidFill>
-                  <a:srgbClr val="475569"/>
-                </a:solidFill>
-                <a:latin typeface="PingFang SC"/>
-                <a:ea typeface="PingFang SC"/>
-                <a:cs typeface="PingFang SC"/>
-              </a:defRPr>
-            </a:pPr>
-            <a:r>
-              <a:rPr sz="1275" b="0" i="0">
-                <a:solidFill>
-                  <a:srgbClr val="475569"/>
-                </a:solidFill>
-                <a:latin typeface="PingFang SC"/>
-                <a:ea typeface="PingFang SC"/>
-                <a:cs typeface="PingFang SC"/>
-              </a:rPr>
-              <a:t>自动生成计划、图表、报告和 trace</a:t>
-            </a:r>
-          </a:p>
-        </p:txBody>
-      </p:sp>
-      <p:sp>
-        <p:nvSpPr>
-          <p:cNvPr id="15" name="">
-            <a:extLst xmlns:a="http://schemas.openxmlformats.org/drawingml/2006/main">
-              <a:ext uri="{FF2B5EF4-FFF2-40B4-BE49-F238E27FC236}">
-                <a16:creationId xmlns:a16="http://schemas.microsoft.com/office/drawing/2014/main" id="{7323AF01-E362-4975-A34D-6611B68E9448}"/>
-              </a:ext>
-            </a:extLst>
-          </p:cNvPr>
-          <p:cNvSpPr>
-            <a:spLocks xmlns:a="http://schemas.openxmlformats.org/drawingml/2006/main" noGrp="1"/>
-          </p:cNvSpPr>
-          <p:nvPr/>
-        </p:nvSpPr>
-        <p:spPr>
-          <a:xfrm xmlns:a="http://schemas.openxmlformats.org/drawingml/2006/main">
-            <a:off x="2190750" y="3810000"/>
-            <a:ext cx="7810500" cy="895350"/>
-          </a:xfrm>
-          <a:prstGeom xmlns:a="http://schemas.openxmlformats.org/drawingml/2006/main" prst="roundRect">
-            <a:avLst>
-              <a:gd name="adj" fmla="val 12766"/>
-            </a:avLst>
-          </a:prstGeom>
-          <a:solidFill xmlns:a="http://schemas.openxmlformats.org/drawingml/2006/main">
-            <a:srgbClr val="FFF4DC"/>
-          </a:solidFill>
-          <a:ln xmlns:a="http://schemas.openxmlformats.org/drawingml/2006/main" w="9525">
-            <a:solidFill>
-              <a:srgbClr val="D7E4E0"/>
-            </a:solidFill>
-            <a:prstDash val="solid"/>
-          </a:ln>
-        </p:spPr>
-        <p:style>
-          <a:lnRef xmlns:a="http://schemas.openxmlformats.org/drawingml/2006/main" idx="0"/>
-          <a:fillRef xmlns:a="http://schemas.openxmlformats.org/drawingml/2006/main" idx="0"/>
-          <a:effectRef xmlns:a="http://schemas.openxmlformats.org/drawingml/2006/main" idx="4"/>
-          <a:fontRef xmlns:a="http://schemas.openxmlformats.org/drawingml/2006/main" idx="major"/>
-        </p:style>
-      </p:sp>
-      <p:sp>
-        <p:nvSpPr>
-          <p:cNvPr id="16" name="">
-            <a:extLst xmlns:a="http://schemas.openxmlformats.org/drawingml/2006/main">
-              <a:ext uri="{FF2B5EF4-FFF2-40B4-BE49-F238E27FC236}">
-                <a16:creationId xmlns:a16="http://schemas.microsoft.com/office/drawing/2014/main" id="{02497BAF-B503-4A4A-B317-3F1BA1742508}"/>
-              </a:ext>
-            </a:extLst>
-          </p:cNvPr>
-          <p:cNvSpPr>
-            <a:spLocks xmlns:a="http://schemas.openxmlformats.org/drawingml/2006/main" noGrp="1"/>
-          </p:cNvSpPr>
-          <p:nvPr/>
-        </p:nvSpPr>
-        <p:spPr>
-          <a:xfrm xmlns:a="http://schemas.openxmlformats.org/drawingml/2006/main">
-            <a:off x="2343150" y="3905250"/>
-            <a:ext cx="7505700" cy="247650"/>
-          </a:xfrm>
-          <a:prstGeom xmlns:a="http://schemas.openxmlformats.org/drawingml/2006/main" prst="rect">
-            <a:avLst/>
-          </a:prstGeom>
-          <a:noFill xmlns:a="http://schemas.openxmlformats.org/drawingml/2006/main"/>
-          <a:ln xmlns:a="http://schemas.openxmlformats.org/drawingml/2006/main" w="0">
-            <a:noFill/>
-            <a:prstDash val="solid"/>
-          </a:ln>
-        </p:spPr>
-        <p:txBody>
-          <a:bodyPr xmlns:a="http://schemas.openxmlformats.org/drawingml/2006/main" lIns="0" tIns="0" rIns="0" bIns="0" anchor="t">
-            <a:normAutofit fontScale="100000"/>
-          </a:bodyPr>
-          <a:lstStyle xmlns:a="http://schemas.openxmlformats.org/drawingml/2006/main"/>
-          <a:p xmlns:a="http://schemas.openxmlformats.org/drawingml/2006/main">
-            <a:pPr algn="l">
-              <a:lnSpc>
-                <a:spcPct val="108000"/>
-              </a:lnSpc>
-              <a:buNone/>
-              <a:defRPr sz="1425" b="1" i="0">
-                <a:solidFill>
-                  <a:srgbClr val="8A5A12"/>
-                </a:solidFill>
-                <a:latin typeface="PingFang SC"/>
-                <a:ea typeface="PingFang SC"/>
-                <a:cs typeface="PingFang SC"/>
-              </a:defRPr>
-            </a:pPr>
-            <a:r>
-              <a:rPr sz="1425" b="1" i="0">
-                <a:solidFill>
-                  <a:srgbClr val="8A5A12"/>
-                </a:solidFill>
-                <a:latin typeface="PingFang SC"/>
-                <a:ea typeface="PingFang SC"/>
-                <a:cs typeface="PingFang SC"/>
-              </a:rPr>
-              <a:t>边界</a:t>
-            </a:r>
-          </a:p>
-        </p:txBody>
-      </p:sp>
-      <p:sp>
-        <p:nvSpPr>
-          <p:cNvPr id="17" name="">
-            <a:extLst xmlns:a="http://schemas.openxmlformats.org/drawingml/2006/main">
-              <a:ext uri="{FF2B5EF4-FFF2-40B4-BE49-F238E27FC236}">
-                <a16:creationId xmlns:a16="http://schemas.microsoft.com/office/drawing/2014/main" id="{A6950681-F741-4590-8C10-032060209B9B}"/>
-              </a:ext>
-            </a:extLst>
-          </p:cNvPr>
-          <p:cNvSpPr>
-            <a:spLocks xmlns:a="http://schemas.openxmlformats.org/drawingml/2006/main" noGrp="1"/>
-          </p:cNvSpPr>
-          <p:nvPr/>
-        </p:nvSpPr>
-        <p:spPr>
-          <a:xfrm xmlns:a="http://schemas.openxmlformats.org/drawingml/2006/main">
-            <a:off x="2343150" y="4191000"/>
-            <a:ext cx="7505700" cy="400050"/>
-          </a:xfrm>
-          <a:prstGeom xmlns:a="http://schemas.openxmlformats.org/drawingml/2006/main" prst="rect">
-            <a:avLst/>
-          </a:prstGeom>
-          <a:noFill xmlns:a="http://schemas.openxmlformats.org/drawingml/2006/main"/>
-          <a:ln xmlns:a="http://schemas.openxmlformats.org/drawingml/2006/main" w="0">
-            <a:noFill/>
-            <a:prstDash val="solid"/>
-          </a:ln>
-        </p:spPr>
-        <p:txBody>
-          <a:bodyPr xmlns:a="http://schemas.openxmlformats.org/drawingml/2006/main" lIns="0" tIns="0" rIns="0" bIns="0" anchor="t">
-            <a:normAutofit fontScale="94637"/>
-          </a:bodyPr>
-          <a:lstStyle xmlns:a="http://schemas.openxmlformats.org/drawingml/2006/main"/>
-          <a:p xmlns:a="http://schemas.openxmlformats.org/drawingml/2006/main">
-            <a:pPr algn="l">
-              <a:lnSpc>
-                <a:spcPct val="108000"/>
-              </a:lnSpc>
-              <a:buNone/>
-              <a:defRPr sz="1500" b="0" i="0">
-                <a:solidFill>
-                  <a:srgbClr val="475569"/>
-                </a:solidFill>
-                <a:latin typeface="PingFang SC"/>
-                <a:ea typeface="PingFang SC"/>
-                <a:cs typeface="PingFang SC"/>
-              </a:defRPr>
-            </a:pPr>
-            <a:r>
-              <a:rPr sz="1500" b="0" i="0">
-                <a:solidFill>
-                  <a:srgbClr val="475569"/>
-                </a:solidFill>
-                <a:latin typeface="PingFang SC"/>
-                <a:ea typeface="PingFang SC"/>
-                <a:cs typeface="PingFang SC"/>
-              </a:rPr>
-              <a:t>不能替代专家注释；不能把 marker ranking 当作机制证明；大型真实数据需要更强计算后端。</a:t>
-            </a:r>
-          </a:p>
-        </p:txBody>
-      </p:sp>
-      <p:sp>
-        <p:nvSpPr>
-          <p:cNvPr id="18" name="">
-            <a:extLst xmlns:a="http://schemas.openxmlformats.org/drawingml/2006/main">
-              <a:ext uri="{FF2B5EF4-FFF2-40B4-BE49-F238E27FC236}">
-                <a16:creationId xmlns:a16="http://schemas.microsoft.com/office/drawing/2014/main" id="{15EC04DA-8359-4232-9261-FEFAFB180947}"/>
-              </a:ext>
-            </a:extLst>
-          </p:cNvPr>
-          <p:cNvSpPr>
-            <a:spLocks xmlns:a="http://schemas.openxmlformats.org/drawingml/2006/main" noGrp="1"/>
-          </p:cNvSpPr>
-          <p:nvPr/>
-        </p:nvSpPr>
-        <p:spPr>
-          <a:xfrm xmlns:a="http://schemas.openxmlformats.org/drawingml/2006/main">
-            <a:off x="1390650" y="5334000"/>
-            <a:ext cx="9410700" cy="323850"/>
-          </a:xfrm>
-          <a:prstGeom xmlns:a="http://schemas.openxmlformats.org/drawingml/2006/main" prst="rect">
-            <a:avLst/>
-          </a:prstGeom>
-          <a:noFill xmlns:a="http://schemas.openxmlformats.org/drawingml/2006/main"/>
-          <a:ln xmlns:a="http://schemas.openxmlformats.org/drawingml/2006/main" w="0">
-            <a:noFill/>
-            <a:prstDash val="solid"/>
-          </a:ln>
-        </p:spPr>
-        <p:txBody>
-          <a:bodyPr xmlns:a="http://schemas.openxmlformats.org/drawingml/2006/main" lIns="0" tIns="0" rIns="0" bIns="0" anchor="t">
-            <a:normAutofit fontScale="92943"/>
-          </a:bodyPr>
-          <a:lstStyle xmlns:a="http://schemas.openxmlformats.org/drawingml/2006/main"/>
-          <a:p xmlns:a="http://schemas.openxmlformats.org/drawingml/2006/main">
-            <a:pPr algn="ctr">
-              <a:lnSpc>
-                <a:spcPct val="108000"/>
-              </a:lnSpc>
-              <a:buNone/>
-              <a:defRPr sz="1650" b="1" i="0">
-                <a:solidFill>
-                  <a:srgbClr val="17212B"/>
-                </a:solidFill>
-                <a:latin typeface="PingFang SC"/>
-                <a:ea typeface="PingFang SC"/>
-                <a:cs typeface="PingFang SC"/>
-              </a:defRPr>
-            </a:pPr>
-            <a:r>
-              <a:rPr sz="1650" b="1" i="0">
-                <a:solidFill>
-                  <a:srgbClr val="17212B"/>
-                </a:solidFill>
-                <a:latin typeface="PingFang SC"/>
-                <a:ea typeface="PingFang SC"/>
-                <a:cs typeface="PingFang SC"/>
-              </a:rPr>
-              <a:t>定位：真实科研中的 exploratory analysis workspace，让研究者更快进入问题，同时保留证据和可复核性。</a:t>
-            </a:r>
-          </a:p>
-        </p:txBody>
-      </p:sp>
-      <p:sp>
-        <p:nvSpPr>
-          <p:cNvPr id="19" name="">
-            <a:extLst xmlns:a="http://schemas.openxmlformats.org/drawingml/2006/main">
-              <a:ext uri="{FF2B5EF4-FFF2-40B4-BE49-F238E27FC236}">
-                <a16:creationId xmlns:a16="http://schemas.microsoft.com/office/drawing/2014/main" id="{EE0B62C5-4F00-45AF-95B3-82DC3263421A}"/>
-              </a:ext>
-            </a:extLst>
-          </p:cNvPr>
-          <p:cNvSpPr>
-            <a:spLocks xmlns:a="http://schemas.openxmlformats.org/drawingml/2006/main" noGrp="1"/>
-          </p:cNvSpPr>
-          <p:nvPr/>
-        </p:nvSpPr>
-        <p:spPr>
-          <a:xfrm xmlns:a="http://schemas.openxmlformats.org/drawingml/2006/main">
-            <a:off x="609600" y="6438900"/>
-            <a:ext cx="10972800" cy="0"/>
-          </a:xfrm>
-          <a:prstGeom xmlns:a="http://schemas.openxmlformats.org/drawingml/2006/main" prst="line">
-            <a:avLst/>
-          </a:prstGeom>
-          <a:noFill xmlns:a="http://schemas.openxmlformats.org/drawingml/2006/main"/>
-          <a:ln xmlns:a="http://schemas.openxmlformats.org/drawingml/2006/main" w="9525">
-            <a:solidFill>
-              <a:srgbClr val="D7E4E0"/>
-            </a:solidFill>
-            <a:prstDash val="solid"/>
-          </a:ln>
-        </p:spPr>
-      </p:sp>
-      <p:sp>
-        <p:nvSpPr>
-          <p:cNvPr id="20" name="">
-            <a:extLst xmlns:a="http://schemas.openxmlformats.org/drawingml/2006/main">
-              <a:ext uri="{FF2B5EF4-FFF2-40B4-BE49-F238E27FC236}">
-                <a16:creationId xmlns:a16="http://schemas.microsoft.com/office/drawing/2014/main" id="{C6F06862-5C1E-476E-95FA-FFD3C30EAB67}"/>
-              </a:ext>
-            </a:extLst>
-          </p:cNvPr>
-          <p:cNvSpPr>
-            <a:spLocks xmlns:a="http://schemas.openxmlformats.org/drawingml/2006/main" noGrp="1"/>
-          </p:cNvSpPr>
-          <p:nvPr/>
-        </p:nvSpPr>
-        <p:spPr>
-          <a:xfrm xmlns:a="http://schemas.openxmlformats.org/drawingml/2006/main">
-            <a:off x="609600" y="6515100"/>
-            <a:ext cx="8572500" cy="190500"/>
-          </a:xfrm>
-          <a:prstGeom xmlns:a="http://schemas.openxmlformats.org/drawingml/2006/main" prst="rect">
-            <a:avLst/>
-          </a:prstGeom>
-          <a:noFill xmlns:a="http://schemas.openxmlformats.org/drawingml/2006/main"/>
-          <a:ln xmlns:a="http://schemas.openxmlformats.org/drawingml/2006/main" w="0">
-            <a:noFill/>
-            <a:prstDash val="solid"/>
-          </a:ln>
-        </p:spPr>
-        <p:txBody>
-          <a:bodyPr xmlns:a="http://schemas.openxmlformats.org/drawingml/2006/main" lIns="0" tIns="0" rIns="0" bIns="0" anchor="t">
-            <a:normAutofit fontScale="100000"/>
-          </a:bodyPr>
-          <a:lstStyle xmlns:a="http://schemas.openxmlformats.org/drawingml/2006/main"/>
-          <a:p xmlns:a="http://schemas.openxmlformats.org/drawingml/2006/main">
-            <a:pPr algn="l">
-              <a:lnSpc>
-                <a:spcPct val="108000"/>
-              </a:lnSpc>
-              <a:buNone/>
-              <a:defRPr sz="863" b="0" i="0">
-                <a:solidFill>
-                  <a:srgbClr val="475569"/>
-                </a:solidFill>
-                <a:latin typeface="PingFang SC"/>
-                <a:ea typeface="PingFang SC"/>
-                <a:cs typeface="PingFang SC"/>
-              </a:defRPr>
-            </a:pPr>
-            <a:r>
-              <a:rPr sz="863" b="0" i="0">
-                <a:solidFill>
-                  <a:srgbClr val="475569"/>
-                </a:solidFill>
-                <a:latin typeface="PingFang SC"/>
-                <a:ea typeface="PingFang SC"/>
-                <a:cs typeface="PingFang SC"/>
-              </a:rPr>
-              <a:t>Application scenarios derived from common spatial transcriptomics research use cases.</a:t>
-            </a:r>
-          </a:p>
-        </p:txBody>
-      </p:sp>
-      <p:sp>
-        <p:nvSpPr>
-          <p:cNvPr id="21" name="">
-            <a:extLst xmlns:a="http://schemas.openxmlformats.org/drawingml/2006/main">
-              <a:ext uri="{FF2B5EF4-FFF2-40B4-BE49-F238E27FC236}">
-                <a16:creationId xmlns:a16="http://schemas.microsoft.com/office/drawing/2014/main" id="{E4E82212-FB1C-4722-874F-6526F237FB57}"/>
-              </a:ext>
-            </a:extLst>
-          </p:cNvPr>
-          <p:cNvSpPr>
-            <a:spLocks xmlns:a="http://schemas.openxmlformats.org/drawingml/2006/main" noGrp="1"/>
-          </p:cNvSpPr>
-          <p:nvPr/>
-        </p:nvSpPr>
-        <p:spPr>
-          <a:xfrm xmlns:a="http://schemas.openxmlformats.org/drawingml/2006/main">
-            <a:off x="11125200" y="6515100"/>
-            <a:ext cx="457200" cy="190500"/>
-          </a:xfrm>
-          <a:prstGeom xmlns:a="http://schemas.openxmlformats.org/drawingml/2006/main" prst="rect">
-            <a:avLst/>
-          </a:prstGeom>
-          <a:noFill xmlns:a="http://schemas.openxmlformats.org/drawingml/2006/main"/>
-          <a:ln xmlns:a="http://schemas.openxmlformats.org/drawingml/2006/main" w="0">
-            <a:noFill/>
-            <a:prstDash val="solid"/>
-          </a:ln>
-        </p:spPr>
-        <p:txBody>
-          <a:bodyPr xmlns:a="http://schemas.openxmlformats.org/drawingml/2006/main" lIns="0" tIns="0" rIns="0" bIns="0" anchor="t">
-            <a:normAutofit fontScale="100000"/>
-          </a:bodyPr>
-          <a:lstStyle xmlns:a="http://schemas.openxmlformats.org/drawingml/2006/main"/>
-          <a:p xmlns:a="http://schemas.openxmlformats.org/drawingml/2006/main">
-            <a:pPr algn="r">
-              <a:lnSpc>
-                <a:spcPct val="108000"/>
-              </a:lnSpc>
-              <a:buNone/>
-              <a:defRPr sz="1013" b="1" i="0">
-                <a:solidFill>
-                  <a:srgbClr val="0F766E"/>
-                </a:solidFill>
-                <a:latin typeface="PingFang SC"/>
-                <a:ea typeface="PingFang SC"/>
-                <a:cs typeface="PingFang SC"/>
-              </a:defRPr>
-            </a:pPr>
-            <a:r>
-              <a:rPr sz="1013" b="1" i="0">
-                <a:solidFill>
-                  <a:srgbClr val="0F766E"/>
-                </a:solidFill>
-                <a:latin typeface="PingFang SC"/>
-                <a:ea typeface="PingFang SC"/>
-                <a:cs typeface="PingFang SC"/>
-              </a:rPr>
-              <a:t>16</a:t>
-            </a:r>
-          </a:p>
-        </p:txBody>
-      </p:sp>
-    </p:spTree>
-    <p:extLst>
-      <p:ext uri="{BB962C8B-B14F-4D97-AF65-F5344CB8AC3E}">
-        <p14:creationId xmlns:p14="http://schemas.microsoft.com/office/powerpoint/2010/main" val="1022058353"/>
-      </p:ext>
-    </p:extLst>
-  </p:cSld>
-</p:sld>
-</file>
-
-<file path=ppt/slides/slide17.xml><?xml version="1.0" encoding="utf-8"?>
 <p:sld xmlns:p="http://schemas.openxmlformats.org/presentationml/2006/main">
   <p:cSld>
     <p:bg>
@@ -13399,7 +12606,7 @@
           <p:nvPr/>
         </p:nvPicPr>
         <p:blipFill>
-          <a:blip xmlns:r="http://schemas.openxmlformats.org/officeDocument/2006/relationships" xmlns:a="http://schemas.openxmlformats.org/drawingml/2006/main" r:embed="R7c611a598e7c4227"/>
+          <a:blip xmlns:r="http://schemas.openxmlformats.org/officeDocument/2006/relationships" xmlns:a="http://schemas.openxmlformats.org/drawingml/2006/main" r:embed="Ra65533781a764e63"/>
           <a:stretch xmlns:a="http://schemas.openxmlformats.org/drawingml/2006/main"/>
         </p:blipFill>
         <p:spPr>
@@ -14141,7 +13348,7 @@
                 <a:ea typeface="PingFang SC"/>
                 <a:cs typeface="PingFang SC"/>
               </a:rPr>
-              <a:t>17</a:t>
+              <a:t>16</a:t>
             </a:r>
           </a:p>
         </p:txBody>
@@ -31650,7 +30857,7 @@
           <p:nvPr/>
         </p:nvPicPr>
         <p:blipFill>
-          <a:blip xmlns:r="http://schemas.openxmlformats.org/officeDocument/2006/relationships" xmlns:a="http://schemas.openxmlformats.org/drawingml/2006/main" r:embed="Rb619f5382c524270"/>
+          <a:blip xmlns:r="http://schemas.openxmlformats.org/officeDocument/2006/relationships" xmlns:a="http://schemas.openxmlformats.org/drawingml/2006/main" r:embed="R8aef7e8caf7b4c96"/>
           <a:stretch xmlns:a="http://schemas.openxmlformats.org/drawingml/2006/main"/>
         </p:blipFill>
         <p:spPr>
@@ -32507,7 +31714,7 @@
           <p:nvPr/>
         </p:nvPicPr>
         <p:blipFill>
-          <a:blip xmlns:r="http://schemas.openxmlformats.org/officeDocument/2006/relationships" xmlns:a="http://schemas.openxmlformats.org/drawingml/2006/main" r:embed="Rc1f1c9e3dec94c47"/>
+          <a:blip xmlns:r="http://schemas.openxmlformats.org/officeDocument/2006/relationships" xmlns:a="http://schemas.openxmlformats.org/drawingml/2006/main" r:embed="R7580a9e3a2934dab"/>
           <a:stretch xmlns:a="http://schemas.openxmlformats.org/drawingml/2006/main"/>
         </p:blipFill>
         <p:spPr>
@@ -32529,7 +31736,7 @@
           <p:nvPr/>
         </p:nvPicPr>
         <p:blipFill>
-          <a:blip xmlns:r="http://schemas.openxmlformats.org/officeDocument/2006/relationships" xmlns:a="http://schemas.openxmlformats.org/drawingml/2006/main" r:embed="Rf246755a37cd439e"/>
+          <a:blip xmlns:r="http://schemas.openxmlformats.org/officeDocument/2006/relationships" xmlns:a="http://schemas.openxmlformats.org/drawingml/2006/main" r:embed="Rbfdf7e73d867448d"/>
           <a:stretch xmlns:a="http://schemas.openxmlformats.org/drawingml/2006/main"/>
         </p:blipFill>
         <p:spPr>
@@ -32551,7 +31758,7 @@
           <p:nvPr/>
         </p:nvPicPr>
         <p:blipFill>
-          <a:blip xmlns:r="http://schemas.openxmlformats.org/officeDocument/2006/relationships" xmlns:a="http://schemas.openxmlformats.org/drawingml/2006/main" r:embed="R548cc2614cfe4219"/>
+          <a:blip xmlns:r="http://schemas.openxmlformats.org/officeDocument/2006/relationships" xmlns:a="http://schemas.openxmlformats.org/drawingml/2006/main" r:embed="R884a78904c404624"/>
           <a:stretch xmlns:a="http://schemas.openxmlformats.org/drawingml/2006/main"/>
         </p:blipFill>
         <p:spPr>

</xml_diff>

<commit_message>
Add acknowledgements to presentation close
</commit_message>
<xml_diff>
--- a/reports/SpatialScope_Agent_Presentation.pptx
+++ b/reports/SpatialScope_Agent_Presentation.pptx
@@ -2,28 +2,28 @@
 <file path=ppt/presentation.xml><?xml version="1.0" encoding="utf-8"?>
 <p:presentation xmlns:p="http://schemas.openxmlformats.org/presentationml/2006/main">
   <p:sldMasterIdLst>
-    <p:sldMasterId xmlns:r="http://schemas.openxmlformats.org/officeDocument/2006/relationships" id="2147483648" r:id="R5bb8db4d8151479b"/>
+    <p:sldMasterId xmlns:r="http://schemas.openxmlformats.org/officeDocument/2006/relationships" id="2147483648" r:id="R94b79985de1446fb"/>
   </p:sldMasterIdLst>
   <p:notesMasterIdLst>
-    <p:notesMasterId xmlns:r="http://schemas.openxmlformats.org/officeDocument/2006/relationships" r:id="R6da5f6d4c73e4e16"/>
+    <p:notesMasterId xmlns:r="http://schemas.openxmlformats.org/officeDocument/2006/relationships" r:id="Rbb5a039dc3c64d4d"/>
   </p:notesMasterIdLst>
   <p:sldIdLst>
-    <p:sldId xmlns:r="http://schemas.openxmlformats.org/officeDocument/2006/relationships" id="256" r:id="R59a7aa19e5874be2"/>
-    <p:sldId xmlns:r="http://schemas.openxmlformats.org/officeDocument/2006/relationships" id="257" r:id="R6ca8893ca1234547"/>
-    <p:sldId xmlns:r="http://schemas.openxmlformats.org/officeDocument/2006/relationships" id="258" r:id="Re0887018bb5e41d9"/>
-    <p:sldId xmlns:r="http://schemas.openxmlformats.org/officeDocument/2006/relationships" id="259" r:id="R3097437c90294386"/>
-    <p:sldId xmlns:r="http://schemas.openxmlformats.org/officeDocument/2006/relationships" id="260" r:id="R449d6de7b6504dd7"/>
-    <p:sldId xmlns:r="http://schemas.openxmlformats.org/officeDocument/2006/relationships" id="261" r:id="Re9c9bffb40994b3a"/>
-    <p:sldId xmlns:r="http://schemas.openxmlformats.org/officeDocument/2006/relationships" id="262" r:id="Re0d963fc4efc4c78"/>
-    <p:sldId xmlns:r="http://schemas.openxmlformats.org/officeDocument/2006/relationships" id="263" r:id="R916cbaeb62484ac5"/>
-    <p:sldId xmlns:r="http://schemas.openxmlformats.org/officeDocument/2006/relationships" id="264" r:id="R03c38d5d44354f24"/>
-    <p:sldId xmlns:r="http://schemas.openxmlformats.org/officeDocument/2006/relationships" id="265" r:id="Rad20951c931a4bb8"/>
-    <p:sldId xmlns:r="http://schemas.openxmlformats.org/officeDocument/2006/relationships" id="266" r:id="Ra4404fb9df0343a9"/>
-    <p:sldId xmlns:r="http://schemas.openxmlformats.org/officeDocument/2006/relationships" id="267" r:id="Rf3c1d67b91204280"/>
-    <p:sldId xmlns:r="http://schemas.openxmlformats.org/officeDocument/2006/relationships" id="268" r:id="Rf79ff2fb32d04c24"/>
-    <p:sldId xmlns:r="http://schemas.openxmlformats.org/officeDocument/2006/relationships" id="269" r:id="R5cf9b85c93f142c2"/>
-    <p:sldId xmlns:r="http://schemas.openxmlformats.org/officeDocument/2006/relationships" id="270" r:id="R4d601c3d946041bb"/>
-    <p:sldId xmlns:r="http://schemas.openxmlformats.org/officeDocument/2006/relationships" id="271" r:id="R34341111d24a47dc"/>
+    <p:sldId xmlns:r="http://schemas.openxmlformats.org/officeDocument/2006/relationships" id="256" r:id="R31d91689df2d46de"/>
+    <p:sldId xmlns:r="http://schemas.openxmlformats.org/officeDocument/2006/relationships" id="257" r:id="R6677fc7150f34ccb"/>
+    <p:sldId xmlns:r="http://schemas.openxmlformats.org/officeDocument/2006/relationships" id="258" r:id="R1eb287a4f15844d5"/>
+    <p:sldId xmlns:r="http://schemas.openxmlformats.org/officeDocument/2006/relationships" id="259" r:id="R4f3ff564842e487a"/>
+    <p:sldId xmlns:r="http://schemas.openxmlformats.org/officeDocument/2006/relationships" id="260" r:id="R67ca5a4fb3e94516"/>
+    <p:sldId xmlns:r="http://schemas.openxmlformats.org/officeDocument/2006/relationships" id="261" r:id="Rc0f7936399cb4e43"/>
+    <p:sldId xmlns:r="http://schemas.openxmlformats.org/officeDocument/2006/relationships" id="262" r:id="R807d8324cdbd46b5"/>
+    <p:sldId xmlns:r="http://schemas.openxmlformats.org/officeDocument/2006/relationships" id="263" r:id="R91526c673e6d437e"/>
+    <p:sldId xmlns:r="http://schemas.openxmlformats.org/officeDocument/2006/relationships" id="264" r:id="R3d367536246a40f8"/>
+    <p:sldId xmlns:r="http://schemas.openxmlformats.org/officeDocument/2006/relationships" id="265" r:id="R6b567d1e1e834bbc"/>
+    <p:sldId xmlns:r="http://schemas.openxmlformats.org/officeDocument/2006/relationships" id="266" r:id="R14515d7b56d945b6"/>
+    <p:sldId xmlns:r="http://schemas.openxmlformats.org/officeDocument/2006/relationships" id="267" r:id="Rc9282df482a2483f"/>
+    <p:sldId xmlns:r="http://schemas.openxmlformats.org/officeDocument/2006/relationships" id="268" r:id="R8cba8ec9c12c4112"/>
+    <p:sldId xmlns:r="http://schemas.openxmlformats.org/officeDocument/2006/relationships" id="269" r:id="R892c9640163a4030"/>
+    <p:sldId xmlns:r="http://schemas.openxmlformats.org/officeDocument/2006/relationships" id="270" r:id="Rad8e58ff90314c45"/>
+    <p:sldId xmlns:r="http://schemas.openxmlformats.org/officeDocument/2006/relationships" id="271" r:id="Rcfef8330d8b84154"/>
   </p:sldIdLst>
   <p:sldSz cx="12192000" cy="6858000"/>
   <p:notesSz cx="6858000" cy="9144000"/>
@@ -1215,6 +1215,16 @@
               <a:t>收尾：这个项目的目标是让研究者更顺畅地探索空间转录组数据，同时保留可追踪性、可复现性和科学解释的谨慎性。然后准备回答问题。</a:t>
             </a:r>
           </a:p>
+          <a:p xmlns:a="http://schemas.openxmlformats.org/drawingml/2006/main">
+            <a:r>
+              <a:t/>
+            </a:r>
+          </a:p>
+          <a:p xmlns:a="http://schemas.openxmlformats.org/drawingml/2006/main">
+            <a:r>
+              <a:t>致谢：最后可以简短补一句：I gratefully thank Professor Peng Xie and Teaching Assistant Binyu Gao, School of Biological Science and Medical Engineering, Southeast University.</a:t>
+            </a:r>
+          </a:p>
         </p:txBody>
       </p:sp>
       <p:sp>
@@ -1920,7 +1930,7 @@
   </p:cSld>
   <p:clrMap bg1="lt1" tx1="dk1" bg2="lt2" tx2="dk2" accent1="accent1" accent2="accent2" accent3="accent3" accent4="accent4" accent5="accent5" accent6="accent6" hlink="hlink" folHlink="folHlink"/>
   <p:sldLayoutIdLst>
-    <p:sldLayoutId xmlns:r="http://schemas.openxmlformats.org/officeDocument/2006/relationships" id="2147483649" r:id="R5113e0da4466459c"/>
+    <p:sldLayoutId xmlns:r="http://schemas.openxmlformats.org/officeDocument/2006/relationships" id="2147483649" r:id="Ra9421d92c30041e4"/>
   </p:sldLayoutIdLst>
   <p:txStyles>
     <p:titleStyle>
@@ -2541,7 +2551,7 @@
           <p:nvPr/>
         </p:nvPicPr>
         <p:blipFill>
-          <a:blip xmlns:r="http://schemas.openxmlformats.org/officeDocument/2006/relationships" xmlns:a="http://schemas.openxmlformats.org/drawingml/2006/main" r:embed="R5062443b37b94b83"/>
+          <a:blip xmlns:r="http://schemas.openxmlformats.org/officeDocument/2006/relationships" xmlns:a="http://schemas.openxmlformats.org/drawingml/2006/main" r:embed="R9f979938bb084224"/>
           <a:stretch xmlns:a="http://schemas.openxmlformats.org/drawingml/2006/main"/>
         </p:blipFill>
         <p:spPr>
@@ -2749,7 +2759,7 @@
           <p:nvPr/>
         </p:nvPicPr>
         <p:blipFill>
-          <a:blip xmlns:r="http://schemas.openxmlformats.org/officeDocument/2006/relationships" xmlns:a="http://schemas.openxmlformats.org/drawingml/2006/main" r:embed="Rba7f4712a1bd46d3"/>
+          <a:blip xmlns:r="http://schemas.openxmlformats.org/officeDocument/2006/relationships" xmlns:a="http://schemas.openxmlformats.org/drawingml/2006/main" r:embed="Rb241446bbfbc4f09"/>
           <a:srcRect xmlns:a="http://schemas.openxmlformats.org/drawingml/2006/main" l="0" t="10358" r="0" b="10358"/>
           <a:stretch xmlns:a="http://schemas.openxmlformats.org/drawingml/2006/main">
             <a:fillRect l="0" t="0" r="0" b="0"/>
@@ -5796,7 +5806,7 @@
       </p:sp>
       <p:cxnSp>
         <p:nvCxnSpPr>
-          <p:cNvPr id="94" name=""/>
+          <p:cNvPr id="122" name=""/>
           <p:cNvCxnSpPr>
             <a:stCxn xmlns:a="http://schemas.openxmlformats.org/drawingml/2006/main" id="5" idx="3"/>
             <a:endCxn xmlns:a="http://schemas.openxmlformats.org/drawingml/2006/main" id="6" idx="1"/>
@@ -5952,7 +5962,7 @@
       </p:sp>
       <p:cxnSp>
         <p:nvCxnSpPr>
-          <p:cNvPr id="97" name=""/>
+          <p:cNvPr id="125" name=""/>
           <p:cNvCxnSpPr>
             <a:stCxn xmlns:a="http://schemas.openxmlformats.org/drawingml/2006/main" id="8" idx="3"/>
             <a:endCxn xmlns:a="http://schemas.openxmlformats.org/drawingml/2006/main" id="9" idx="1"/>
@@ -6108,7 +6118,7 @@
       </p:sp>
       <p:cxnSp>
         <p:nvCxnSpPr>
-          <p:cNvPr id="100" name=""/>
+          <p:cNvPr id="128" name=""/>
           <p:cNvCxnSpPr>
             <a:stCxn xmlns:a="http://schemas.openxmlformats.org/drawingml/2006/main" id="11" idx="3"/>
             <a:endCxn xmlns:a="http://schemas.openxmlformats.org/drawingml/2006/main" id="12" idx="1"/>
@@ -6264,7 +6274,7 @@
       </p:sp>
       <p:cxnSp>
         <p:nvCxnSpPr>
-          <p:cNvPr id="103" name=""/>
+          <p:cNvPr id="131" name=""/>
           <p:cNvCxnSpPr>
             <a:stCxn xmlns:a="http://schemas.openxmlformats.org/drawingml/2006/main" id="14" idx="3"/>
             <a:endCxn xmlns:a="http://schemas.openxmlformats.org/drawingml/2006/main" id="15" idx="1"/>
@@ -6420,7 +6430,7 @@
       </p:sp>
       <p:cxnSp>
         <p:nvCxnSpPr>
-          <p:cNvPr id="106" name=""/>
+          <p:cNvPr id="134" name=""/>
           <p:cNvCxnSpPr>
             <a:stCxn xmlns:a="http://schemas.openxmlformats.org/drawingml/2006/main" id="17" idx="3"/>
             <a:endCxn xmlns:a="http://schemas.openxmlformats.org/drawingml/2006/main" id="18" idx="1"/>
@@ -6576,7 +6586,7 @@
       </p:sp>
       <p:cxnSp>
         <p:nvCxnSpPr>
-          <p:cNvPr id="109" name=""/>
+          <p:cNvPr id="137" name=""/>
           <p:cNvCxnSpPr>
             <a:stCxn xmlns:a="http://schemas.openxmlformats.org/drawingml/2006/main" id="20" idx="3"/>
             <a:endCxn xmlns:a="http://schemas.openxmlformats.org/drawingml/2006/main" id="21" idx="1"/>
@@ -6732,7 +6742,7 @@
       </p:sp>
       <p:cxnSp>
         <p:nvCxnSpPr>
-          <p:cNvPr id="112" name=""/>
+          <p:cNvPr id="140" name=""/>
           <p:cNvCxnSpPr>
             <a:stCxn xmlns:a="http://schemas.openxmlformats.org/drawingml/2006/main" id="23" idx="3"/>
             <a:endCxn xmlns:a="http://schemas.openxmlformats.org/drawingml/2006/main" id="24" idx="1"/>
@@ -6888,7 +6898,7 @@
       </p:sp>
       <p:cxnSp>
         <p:nvCxnSpPr>
-          <p:cNvPr id="115" name=""/>
+          <p:cNvPr id="143" name=""/>
           <p:cNvCxnSpPr>
             <a:stCxn xmlns:a="http://schemas.openxmlformats.org/drawingml/2006/main" id="26" idx="3"/>
             <a:endCxn xmlns:a="http://schemas.openxmlformats.org/drawingml/2006/main" id="27" idx="1"/>
@@ -7229,7 +7239,7 @@
           <p:nvPr/>
         </p:nvPicPr>
         <p:blipFill>
-          <a:blip xmlns:r="http://schemas.openxmlformats.org/officeDocument/2006/relationships" xmlns:a="http://schemas.openxmlformats.org/drawingml/2006/main" r:embed="R8190f9b06e9b4d60"/>
+          <a:blip xmlns:r="http://schemas.openxmlformats.org/officeDocument/2006/relationships" xmlns:a="http://schemas.openxmlformats.org/drawingml/2006/main" r:embed="R6a740240412c45f1"/>
           <a:srcRect xmlns:a="http://schemas.openxmlformats.org/drawingml/2006/main" l="0" t="17360" r="0" b="17360"/>
           <a:stretch xmlns:a="http://schemas.openxmlformats.org/drawingml/2006/main">
             <a:fillRect l="0" t="0" r="0" b="0"/>
@@ -7254,7 +7264,7 @@
           <p:nvPr/>
         </p:nvPicPr>
         <p:blipFill>
-          <a:blip xmlns:r="http://schemas.openxmlformats.org/officeDocument/2006/relationships" xmlns:a="http://schemas.openxmlformats.org/drawingml/2006/main" r:embed="R90f66e01d02f454c"/>
+          <a:blip xmlns:r="http://schemas.openxmlformats.org/officeDocument/2006/relationships" xmlns:a="http://schemas.openxmlformats.org/drawingml/2006/main" r:embed="Rd9f2efc541a54290"/>
           <a:srcRect xmlns:a="http://schemas.openxmlformats.org/drawingml/2006/main" l="0" t="17360" r="0" b="17360"/>
           <a:stretch xmlns:a="http://schemas.openxmlformats.org/drawingml/2006/main">
             <a:fillRect l="0" t="0" r="0" b="0"/>
@@ -10991,7 +11001,7 @@
           <p:nvPr/>
         </p:nvPicPr>
         <p:blipFill>
-          <a:blip xmlns:r="http://schemas.openxmlformats.org/officeDocument/2006/relationships" xmlns:a="http://schemas.openxmlformats.org/drawingml/2006/main" r:embed="R30de565b46854558"/>
+          <a:blip xmlns:r="http://schemas.openxmlformats.org/officeDocument/2006/relationships" xmlns:a="http://schemas.openxmlformats.org/drawingml/2006/main" r:embed="Rd070f17e4c104222"/>
           <a:stretch xmlns:a="http://schemas.openxmlformats.org/drawingml/2006/main"/>
         </p:blipFill>
         <p:spPr>
@@ -11013,7 +11023,7 @@
           <p:nvPr/>
         </p:nvPicPr>
         <p:blipFill>
-          <a:blip xmlns:r="http://schemas.openxmlformats.org/officeDocument/2006/relationships" xmlns:a="http://schemas.openxmlformats.org/drawingml/2006/main" r:embed="Ra24cfae5f0a04615"/>
+          <a:blip xmlns:r="http://schemas.openxmlformats.org/officeDocument/2006/relationships" xmlns:a="http://schemas.openxmlformats.org/drawingml/2006/main" r:embed="Rb7d5266d8d114ea7"/>
           <a:stretch xmlns:a="http://schemas.openxmlformats.org/drawingml/2006/main"/>
         </p:blipFill>
         <p:spPr>
@@ -11035,7 +11045,7 @@
           <p:nvPr/>
         </p:nvPicPr>
         <p:blipFill>
-          <a:blip xmlns:r="http://schemas.openxmlformats.org/officeDocument/2006/relationships" xmlns:a="http://schemas.openxmlformats.org/drawingml/2006/main" r:embed="R28848bdbc0cd4e8b"/>
+          <a:blip xmlns:r="http://schemas.openxmlformats.org/officeDocument/2006/relationships" xmlns:a="http://schemas.openxmlformats.org/drawingml/2006/main" r:embed="R250634656a064ff6"/>
           <a:stretch xmlns:a="http://schemas.openxmlformats.org/drawingml/2006/main"/>
         </p:blipFill>
         <p:spPr>
@@ -12599,14 +12609,14 @@
       </p:grpSpPr>
       <p:pic>
         <p:nvPicPr>
-          <p:cNvPr id="17" name=""/>
+          <p:cNvPr id="20" name=""/>
           <p:cNvPicPr>
             <a:picLocks xmlns:a="http://schemas.openxmlformats.org/drawingml/2006/main" noChangeAspect="1"/>
           </p:cNvPicPr>
           <p:nvPr/>
         </p:nvPicPr>
         <p:blipFill>
-          <a:blip xmlns:r="http://schemas.openxmlformats.org/officeDocument/2006/relationships" xmlns:a="http://schemas.openxmlformats.org/drawingml/2006/main" r:embed="Ra65533781a764e63"/>
+          <a:blip xmlns:r="http://schemas.openxmlformats.org/officeDocument/2006/relationships" xmlns:a="http://schemas.openxmlformats.org/drawingml/2006/main" r:embed="R446b0e922a184627"/>
           <a:stretch xmlns:a="http://schemas.openxmlformats.org/drawingml/2006/main"/>
         </p:blipFill>
         <p:spPr>
@@ -13147,8 +13157,8 @@
         </p:nvSpPr>
         <p:spPr>
           <a:xfrm xmlns:a="http://schemas.openxmlformats.org/drawingml/2006/main">
-            <a:off x="3067050" y="5200650"/>
-            <a:ext cx="6057900" cy="514350"/>
+            <a:off x="3067050" y="5867400"/>
+            <a:ext cx="6057900" cy="419100"/>
           </a:xfrm>
           <a:prstGeom xmlns:a="http://schemas.openxmlformats.org/drawingml/2006/main" prst="rect">
             <a:avLst/>
@@ -13161,7 +13171,7 @@
         </p:spPr>
         <p:txBody>
           <a:bodyPr xmlns:a="http://schemas.openxmlformats.org/drawingml/2006/main" lIns="0" tIns="0" rIns="0" bIns="0" anchor="t">
-            <a:normAutofit fontScale="100000"/>
+            <a:normAutofit fontScale="94307"/>
           </a:bodyPr>
           <a:lstStyle xmlns:a="http://schemas.openxmlformats.org/drawingml/2006/main"/>
           <a:p xmlns:a="http://schemas.openxmlformats.org/drawingml/2006/main">
@@ -13170,9 +13180,9 @@
                 <a:spcPct val="108000"/>
               </a:lnSpc>
               <a:buNone/>
-              <a:defRPr sz="1500" b="0" i="0">
-                <a:solidFill>
-                  <a:srgbClr val="475569"/>
+              <a:defRPr sz="1350" b="0" i="0">
+                <a:solidFill>
+                  <a:srgbClr val="4B5D73"/>
                 </a:solidFill>
                 <a:latin typeface="PingFang SC"/>
                 <a:ea typeface="PingFang SC"/>
@@ -13197,9 +13207,9 @@
                 <a:spcPct val="108000"/>
               </a:lnSpc>
               <a:buNone/>
-              <a:defRPr sz="1500" b="0" i="0">
-                <a:solidFill>
-                  <a:srgbClr val="475569"/>
+              <a:defRPr sz="1350" b="0" i="0">
+                <a:solidFill>
+                  <a:srgbClr val="4B5D73"/>
                 </a:solidFill>
                 <a:latin typeface="PingFang SC"/>
                 <a:ea typeface="PingFang SC"/>
@@ -13349,6 +13359,141 @@
                 <a:cs typeface="PingFang SC"/>
               </a:rPr>
               <a:t>16</a:t>
+            </a:r>
+          </a:p>
+        </p:txBody>
+      </p:sp>
+      <p:sp>
+        <p:nvSpPr>
+          <p:cNvPr id="17" name="acknowledgements-card">
+            <a:extLst xmlns:a="http://schemas.openxmlformats.org/drawingml/2006/main">
+              <a:ext uri="{FF2B5EF4-FFF2-40B4-BE49-F238E27FC236}">
+                <a16:creationId xmlns:a16="http://schemas.microsoft.com/office/drawing/2014/main" id="{DF37DDBB-695E-49F2-A84B-B96648433CC8}"/>
+              </a:ext>
+            </a:extLst>
+          </p:cNvPr>
+          <p:cNvSpPr>
+            <a:spLocks xmlns:a="http://schemas.openxmlformats.org/drawingml/2006/main" noGrp="1"/>
+          </p:cNvSpPr>
+          <p:nvPr/>
+        </p:nvSpPr>
+        <p:spPr>
+          <a:xfrm xmlns:a="http://schemas.openxmlformats.org/drawingml/2006/main">
+            <a:off x="1828800" y="4895850"/>
+            <a:ext cx="8096250" cy="742950"/>
+          </a:xfrm>
+          <a:prstGeom xmlns:a="http://schemas.openxmlformats.org/drawingml/2006/main" prst="roundRect">
+            <a:avLst>
+              <a:gd name="adj" fmla="val 15385"/>
+            </a:avLst>
+          </a:prstGeom>
+          <a:solidFill xmlns:a="http://schemas.openxmlformats.org/drawingml/2006/main">
+            <a:srgbClr val="F8FCFA"/>
+          </a:solidFill>
+          <a:ln xmlns:a="http://schemas.openxmlformats.org/drawingml/2006/main" w="9525">
+            <a:solidFill>
+              <a:srgbClr val="D7E7E3"/>
+            </a:solidFill>
+            <a:prstDash val="solid"/>
+          </a:ln>
+        </p:spPr>
+      </p:sp>
+      <p:sp>
+        <p:nvSpPr>
+          <p:cNvPr id="18" name="acknowledgements-title">
+            <a:extLst xmlns:a="http://schemas.openxmlformats.org/drawingml/2006/main">
+              <a:ext uri="{FF2B5EF4-FFF2-40B4-BE49-F238E27FC236}">
+                <a16:creationId xmlns:a16="http://schemas.microsoft.com/office/drawing/2014/main" id="{EA4AD3C1-6369-497F-A1D0-77969CEF6695}"/>
+              </a:ext>
+            </a:extLst>
+          </p:cNvPr>
+          <p:cNvSpPr>
+            <a:spLocks xmlns:a="http://schemas.openxmlformats.org/drawingml/2006/main" noGrp="1"/>
+          </p:cNvSpPr>
+          <p:nvPr/>
+        </p:nvSpPr>
+        <p:spPr>
+          <a:xfrm xmlns:a="http://schemas.openxmlformats.org/drawingml/2006/main">
+            <a:off x="1981200" y="4991100"/>
+            <a:ext cx="7791450" cy="228600"/>
+          </a:xfrm>
+          <a:prstGeom xmlns:a="http://schemas.openxmlformats.org/drawingml/2006/main" prst="rect">
+            <a:avLst/>
+          </a:prstGeom>
+          <a:noFill xmlns:a="http://schemas.openxmlformats.org/drawingml/2006/main"/>
+          <a:ln xmlns:a="http://schemas.openxmlformats.org/drawingml/2006/main" w="0">
+            <a:noFill/>
+            <a:prstDash val="solid"/>
+          </a:ln>
+        </p:spPr>
+        <p:txBody>
+          <a:bodyPr xmlns:a="http://schemas.openxmlformats.org/drawingml/2006/main"/>
+          <a:lstStyle xmlns:a="http://schemas.openxmlformats.org/drawingml/2006/main"/>
+          <a:p xmlns:a="http://schemas.openxmlformats.org/drawingml/2006/main">
+            <a:pPr>
+              <a:defRPr sz="1275" b="1">
+                <a:solidFill>
+                  <a:srgbClr val="00796B"/>
+                </a:solidFill>
+              </a:defRPr>
+            </a:pPr>
+            <a:r>
+              <a:rPr sz="1275" b="1">
+                <a:solidFill>
+                  <a:srgbClr val="00796B"/>
+                </a:solidFill>
+              </a:rPr>
+              <a:t>Acknowledgements</a:t>
+            </a:r>
+          </a:p>
+        </p:txBody>
+      </p:sp>
+      <p:sp>
+        <p:nvSpPr>
+          <p:cNvPr id="19" name="acknowledgements-body">
+            <a:extLst xmlns:a="http://schemas.openxmlformats.org/drawingml/2006/main">
+              <a:ext uri="{FF2B5EF4-FFF2-40B4-BE49-F238E27FC236}">
+                <a16:creationId xmlns:a16="http://schemas.microsoft.com/office/drawing/2014/main" id="{6E39E11B-3A1C-42B4-A33D-039DAC9EC310}"/>
+              </a:ext>
+            </a:extLst>
+          </p:cNvPr>
+          <p:cNvSpPr>
+            <a:spLocks xmlns:a="http://schemas.openxmlformats.org/drawingml/2006/main" noGrp="1"/>
+          </p:cNvSpPr>
+          <p:nvPr/>
+        </p:nvSpPr>
+        <p:spPr>
+          <a:xfrm xmlns:a="http://schemas.openxmlformats.org/drawingml/2006/main">
+            <a:off x="1981200" y="5238750"/>
+            <a:ext cx="7791450" cy="304800"/>
+          </a:xfrm>
+          <a:prstGeom xmlns:a="http://schemas.openxmlformats.org/drawingml/2006/main" prst="rect">
+            <a:avLst/>
+          </a:prstGeom>
+          <a:noFill xmlns:a="http://schemas.openxmlformats.org/drawingml/2006/main"/>
+          <a:ln xmlns:a="http://schemas.openxmlformats.org/drawingml/2006/main" w="0">
+            <a:noFill/>
+            <a:prstDash val="solid"/>
+          </a:ln>
+        </p:spPr>
+        <p:txBody>
+          <a:bodyPr xmlns:a="http://schemas.openxmlformats.org/drawingml/2006/main"/>
+          <a:lstStyle xmlns:a="http://schemas.openxmlformats.org/drawingml/2006/main"/>
+          <a:p xmlns:a="http://schemas.openxmlformats.org/drawingml/2006/main">
+            <a:pPr>
+              <a:defRPr sz="1200">
+                <a:solidFill>
+                  <a:srgbClr val="4B5D73"/>
+                </a:solidFill>
+              </a:defRPr>
+            </a:pPr>
+            <a:r>
+              <a:rPr sz="1200">
+                <a:solidFill>
+                  <a:srgbClr val="4B5D73"/>
+                </a:solidFill>
+              </a:rPr>
+              <a:t>I gratefully thank Professor Peng Xie and Teaching Assistant Binyu Gao, School of Biological Science and Medical Engineering, Southeast University.</a:t>
             </a:r>
           </a:p>
         </p:txBody>
@@ -30857,7 +31002,7 @@
           <p:nvPr/>
         </p:nvPicPr>
         <p:blipFill>
-          <a:blip xmlns:r="http://schemas.openxmlformats.org/officeDocument/2006/relationships" xmlns:a="http://schemas.openxmlformats.org/drawingml/2006/main" r:embed="R8aef7e8caf7b4c96"/>
+          <a:blip xmlns:r="http://schemas.openxmlformats.org/officeDocument/2006/relationships" xmlns:a="http://schemas.openxmlformats.org/drawingml/2006/main" r:embed="R1cefa228351246e9"/>
           <a:stretch xmlns:a="http://schemas.openxmlformats.org/drawingml/2006/main"/>
         </p:blipFill>
         <p:spPr>
@@ -31714,7 +31859,7 @@
           <p:nvPr/>
         </p:nvPicPr>
         <p:blipFill>
-          <a:blip xmlns:r="http://schemas.openxmlformats.org/officeDocument/2006/relationships" xmlns:a="http://schemas.openxmlformats.org/drawingml/2006/main" r:embed="R7580a9e3a2934dab"/>
+          <a:blip xmlns:r="http://schemas.openxmlformats.org/officeDocument/2006/relationships" xmlns:a="http://schemas.openxmlformats.org/drawingml/2006/main" r:embed="Rc5ba61cabb3f4f81"/>
           <a:stretch xmlns:a="http://schemas.openxmlformats.org/drawingml/2006/main"/>
         </p:blipFill>
         <p:spPr>
@@ -31736,7 +31881,7 @@
           <p:nvPr/>
         </p:nvPicPr>
         <p:blipFill>
-          <a:blip xmlns:r="http://schemas.openxmlformats.org/officeDocument/2006/relationships" xmlns:a="http://schemas.openxmlformats.org/drawingml/2006/main" r:embed="Rbfdf7e73d867448d"/>
+          <a:blip xmlns:r="http://schemas.openxmlformats.org/officeDocument/2006/relationships" xmlns:a="http://schemas.openxmlformats.org/drawingml/2006/main" r:embed="Rfea42e524e9f4ac7"/>
           <a:stretch xmlns:a="http://schemas.openxmlformats.org/drawingml/2006/main"/>
         </p:blipFill>
         <p:spPr>
@@ -31758,7 +31903,7 @@
           <p:nvPr/>
         </p:nvPicPr>
         <p:blipFill>
-          <a:blip xmlns:r="http://schemas.openxmlformats.org/officeDocument/2006/relationships" xmlns:a="http://schemas.openxmlformats.org/drawingml/2006/main" r:embed="R884a78904c404624"/>
+          <a:blip xmlns:r="http://schemas.openxmlformats.org/officeDocument/2006/relationships" xmlns:a="http://schemas.openxmlformats.org/drawingml/2006/main" r:embed="R26366c22b1464d91"/>
           <a:stretch xmlns:a="http://schemas.openxmlformats.org/drawingml/2006/main"/>
         </p:blipFill>
         <p:spPr>

</xml_diff>